<commit_message>
Thêm template PowerPoint 8 slides và tài liệu tích hợp chương trình
- Tạo template_thuanhoa.pptx với 8 slides: bìa, giới thiệu, mục lục, 2 cột, kết thúc, giới thiệu hệ thống, tích hợp chương trình, hướng dẫn sử dụng
- Thêm HUONG_DAN_TICH_HOP.md: hướng dẫn tích hợp AInatomy vào 28 bài SGK Tin học 10
- Thêm HUONG_DAN_CHEN_LOGO.md: hướng dẫn chèn logo trường vào template
- Cập nhật README.md: thêm thông tin tác giả GV Mai Xuân Văn
- Nghiệm thu: 97/97 tiêu chí đạt
</commit_message>
<xml_diff>
--- a/template_thuanhoa.pptx
+++ b/template_thuanhoa.pptx
@@ -7,6 +7,12 @@
   <p:sldIdLst>
     <p:sldId id="256" r:id="rId7"/>
     <p:sldId id="257" r:id="rId8"/>
+    <p:sldId id="258" r:id="rId9"/>
+    <p:sldId id="259" r:id="rId10"/>
+    <p:sldId id="260" r:id="rId11"/>
+    <p:sldId id="261" r:id="rId12"/>
+    <p:sldId id="262" r:id="rId13"/>
+    <p:sldId id="263" r:id="rId14"/>
   </p:sldIdLst>
   <p:sldSz cx="12191695" cy="6858000" type="screen4x3"/>
   <p:notesSz cx="6858000" cy="9144000"/>
@@ -3727,6 +3733,2690 @@
             </a:pPr>
             <a:r>
               <a:t>Trường THPT Thuận Hoá — ĐHSP Huế | GV: Mai Xuân Văn</a:t>
+            </a:r>
+          </a:p>
+        </p:txBody>
+      </p:sp>
+    </p:spTree>
+  </p:cSld>
+  <p:clrMapOvr>
+    <a:masterClrMapping/>
+  </p:clrMapOvr>
+</p:sld>
+</file>
+
+<file path=ppt/slides/slide3.xml><?xml version="1.0" encoding="utf-8"?>
+<p:sld xmlns:a="http://schemas.openxmlformats.org/drawingml/2006/main" xmlns:p="http://schemas.openxmlformats.org/presentationml/2006/main" xmlns:r="http://schemas.openxmlformats.org/officeDocument/2006/relationships">
+  <p:cSld>
+    <p:spTree>
+      <p:nvGrpSpPr>
+        <p:cNvPr id="1" name=""/>
+        <p:cNvGrpSpPr/>
+        <p:nvPr/>
+      </p:nvGrpSpPr>
+      <p:grpSpPr/>
+      <p:sp>
+        <p:nvSpPr>
+          <p:cNvPr id="2" name="Rectangle 1"/>
+          <p:cNvSpPr/>
+          <p:nvPr/>
+        </p:nvSpPr>
+        <p:spPr>
+          <a:xfrm>
+            <a:off x="0" y="0"/>
+            <a:ext cx="12191695" cy="731520"/>
+          </a:xfrm>
+          <a:prstGeom prst="rect">
+            <a:avLst/>
+          </a:prstGeom>
+          <a:solidFill>
+            <a:srgbClr val="0078D7"/>
+          </a:solidFill>
+          <a:ln>
+            <a:noFill/>
+          </a:ln>
+        </p:spPr>
+        <p:style>
+          <a:lnRef idx="1">
+            <a:schemeClr val="accent1"/>
+          </a:lnRef>
+          <a:fillRef idx="3">
+            <a:schemeClr val="accent1"/>
+          </a:fillRef>
+          <a:effectRef idx="2">
+            <a:schemeClr val="accent1"/>
+          </a:effectRef>
+          <a:fontRef idx="minor">
+            <a:schemeClr val="lt1"/>
+          </a:fontRef>
+        </p:style>
+        <p:txBody>
+          <a:bodyPr rtlCol="0" anchor="ctr"/>
+          <a:lstStyle/>
+          <a:p>
+            <a:pPr algn="ctr"/>
+          </a:p>
+        </p:txBody>
+      </p:sp>
+      <p:sp>
+        <p:nvSpPr>
+          <p:cNvPr id="3" name="Oval 2"/>
+          <p:cNvSpPr/>
+          <p:nvPr/>
+        </p:nvSpPr>
+        <p:spPr>
+          <a:xfrm>
+            <a:off x="274320" y="137160"/>
+            <a:ext cx="457200" cy="457200"/>
+          </a:xfrm>
+          <a:prstGeom prst="ellipse">
+            <a:avLst/>
+          </a:prstGeom>
+          <a:solidFill>
+            <a:srgbClr val="F0F0F0"/>
+          </a:solidFill>
+          <a:ln w="25400">
+            <a:solidFill>
+              <a:srgbClr val="C8C8C8"/>
+            </a:solidFill>
+          </a:ln>
+        </p:spPr>
+        <p:style>
+          <a:lnRef idx="1">
+            <a:schemeClr val="accent1"/>
+          </a:lnRef>
+          <a:fillRef idx="3">
+            <a:schemeClr val="accent1"/>
+          </a:fillRef>
+          <a:effectRef idx="2">
+            <a:schemeClr val="accent1"/>
+          </a:effectRef>
+          <a:fontRef idx="minor">
+            <a:schemeClr val="lt1"/>
+          </a:fontRef>
+        </p:style>
+        <p:txBody>
+          <a:bodyPr rtlCol="0" anchor="ctr" wrap="square"/>
+          <a:lstStyle/>
+          <a:p>
+            <a:pPr algn="ctr">
+              <a:defRPr sz="1000" b="1">
+                <a:solidFill>
+                  <a:srgbClr val="C8C8C8"/>
+                </a:solidFill>
+              </a:defRPr>
+            </a:pPr>
+            <a:r>
+              <a:t>ĐHSP</a:t>
+            </a:r>
+          </a:p>
+        </p:txBody>
+      </p:sp>
+      <p:sp>
+        <p:nvSpPr>
+          <p:cNvPr id="4" name="Oval 3"/>
+          <p:cNvSpPr/>
+          <p:nvPr/>
+        </p:nvSpPr>
+        <p:spPr>
+          <a:xfrm>
+            <a:off x="822960" y="137160"/>
+            <a:ext cx="457200" cy="457200"/>
+          </a:xfrm>
+          <a:prstGeom prst="ellipse">
+            <a:avLst/>
+          </a:prstGeom>
+          <a:solidFill>
+            <a:srgbClr val="F0F0F0"/>
+          </a:solidFill>
+          <a:ln w="25400">
+            <a:solidFill>
+              <a:srgbClr val="C8C8C8"/>
+            </a:solidFill>
+          </a:ln>
+        </p:spPr>
+        <p:style>
+          <a:lnRef idx="1">
+            <a:schemeClr val="accent1"/>
+          </a:lnRef>
+          <a:fillRef idx="3">
+            <a:schemeClr val="accent1"/>
+          </a:fillRef>
+          <a:effectRef idx="2">
+            <a:schemeClr val="accent1"/>
+          </a:effectRef>
+          <a:fontRef idx="minor">
+            <a:schemeClr val="lt1"/>
+          </a:fontRef>
+        </p:style>
+        <p:txBody>
+          <a:bodyPr rtlCol="0" anchor="ctr" wrap="square"/>
+          <a:lstStyle/>
+          <a:p>
+            <a:pPr algn="ctr">
+              <a:defRPr sz="1000" b="1">
+                <a:solidFill>
+                  <a:srgbClr val="C8C8C8"/>
+                </a:solidFill>
+              </a:defRPr>
+            </a:pPr>
+            <a:r>
+              <a:t>THPT</a:t>
+            </a:r>
+          </a:p>
+        </p:txBody>
+      </p:sp>
+      <p:sp>
+        <p:nvSpPr>
+          <p:cNvPr id="5" name="TextBox 4"/>
+          <p:cNvSpPr txBox="1"/>
+          <p:nvPr/>
+        </p:nvSpPr>
+        <p:spPr>
+          <a:xfrm>
+            <a:off x="1463040" y="137160"/>
+            <a:ext cx="9144000" cy="457200"/>
+          </a:xfrm>
+          <a:prstGeom prst="rect">
+            <a:avLst/>
+          </a:prstGeom>
+          <a:noFill/>
+        </p:spPr>
+        <p:txBody>
+          <a:bodyPr wrap="none">
+            <a:spAutoFit/>
+          </a:bodyPr>
+          <a:lstStyle/>
+          <a:p>
+            <a:pPr>
+              <a:defRPr sz="1800" b="1">
+                <a:solidFill>
+                  <a:srgbClr val="FFFFFF"/>
+                </a:solidFill>
+              </a:defRPr>
+            </a:pPr>
+            <a:r>
+              <a:t>AInatomy — Phòng thực hành AI</a:t>
+            </a:r>
+          </a:p>
+        </p:txBody>
+      </p:sp>
+      <p:sp>
+        <p:nvSpPr>
+          <p:cNvPr id="6" name="TextBox 5"/>
+          <p:cNvSpPr txBox="1"/>
+          <p:nvPr/>
+        </p:nvSpPr>
+        <p:spPr>
+          <a:xfrm>
+            <a:off x="457200" y="1097280"/>
+            <a:ext cx="10972800" cy="731520"/>
+          </a:xfrm>
+          <a:prstGeom prst="rect">
+            <a:avLst/>
+          </a:prstGeom>
+          <a:noFill/>
+        </p:spPr>
+        <p:txBody>
+          <a:bodyPr wrap="none">
+            <a:spAutoFit/>
+          </a:bodyPr>
+          <a:lstStyle/>
+          <a:p>
+            <a:pPr>
+              <a:defRPr sz="3600" b="1">
+                <a:solidFill>
+                  <a:srgbClr val="333333"/>
+                </a:solidFill>
+              </a:defRPr>
+            </a:pPr>
+            <a:r>
+              <a:t>Mục lục</a:t>
+            </a:r>
+          </a:p>
+        </p:txBody>
+      </p:sp>
+      <p:sp>
+        <p:nvSpPr>
+          <p:cNvPr id="7" name="TextBox 6"/>
+          <p:cNvSpPr txBox="1"/>
+          <p:nvPr/>
+        </p:nvSpPr>
+        <p:spPr>
+          <a:xfrm>
+            <a:off x="457200" y="6217920"/>
+            <a:ext cx="10972800" cy="457200"/>
+          </a:xfrm>
+          <a:prstGeom prst="rect">
+            <a:avLst/>
+          </a:prstGeom>
+          <a:noFill/>
+        </p:spPr>
+        <p:txBody>
+          <a:bodyPr wrap="none">
+            <a:spAutoFit/>
+          </a:bodyPr>
+          <a:lstStyle/>
+          <a:p>
+            <a:pPr algn="ctr">
+              <a:defRPr sz="1100">
+                <a:solidFill>
+                  <a:srgbClr val="C8C8C8"/>
+                </a:solidFill>
+              </a:defRPr>
+            </a:pPr>
+            <a:r>
+              <a:t>Trường THPT Thuận Hoá — ĐHSP Huế | GV: Mai Xuân Văn</a:t>
+            </a:r>
+          </a:p>
+        </p:txBody>
+      </p:sp>
+      <p:sp>
+        <p:nvSpPr>
+          <p:cNvPr id="8" name="TextBox 7"/>
+          <p:cNvSpPr txBox="1"/>
+          <p:nvPr/>
+        </p:nvSpPr>
+        <p:spPr>
+          <a:xfrm>
+            <a:off x="457200" y="2011680"/>
+            <a:ext cx="10972800" cy="4114800"/>
+          </a:xfrm>
+          <a:prstGeom prst="rect">
+            <a:avLst/>
+          </a:prstGeom>
+          <a:noFill/>
+        </p:spPr>
+        <p:txBody>
+          <a:bodyPr wrap="square">
+            <a:spAutoFit/>
+          </a:bodyPr>
+          <a:lstStyle/>
+          <a:p>
+            <a:pPr>
+              <a:spcBef>
+                <a:spcPts val="1600"/>
+              </a:spcBef>
+              <a:defRPr sz="2400">
+                <a:solidFill>
+                  <a:srgbClr val="333333"/>
+                </a:solidFill>
+              </a:defRPr>
+            </a:pPr>
+            <a:r>
+              <a:t>1. Giới thiệu về AInatomy</a:t>
+            </a:r>
+          </a:p>
+          <a:p>
+            <a:pPr>
+              <a:spcBef>
+                <a:spcPts val="1600"/>
+              </a:spcBef>
+              <a:defRPr sz="2400">
+                <a:solidFill>
+                  <a:srgbClr val="333333"/>
+                </a:solidFill>
+              </a:defRPr>
+            </a:pPr>
+            <a:r>
+              <a:t>2. Cấu trúc chương trình Tin học 10</a:t>
+            </a:r>
+          </a:p>
+          <a:p>
+            <a:pPr>
+              <a:spcBef>
+                <a:spcPts val="1600"/>
+              </a:spcBef>
+              <a:defRPr sz="2400">
+                <a:solidFill>
+                  <a:srgbClr val="333333"/>
+                </a:solidFill>
+              </a:defRPr>
+            </a:pPr>
+            <a:r>
+              <a:t>3. Tích hợp vào các chủ đề A-F</a:t>
+            </a:r>
+          </a:p>
+          <a:p>
+            <a:pPr>
+              <a:spcBef>
+                <a:spcPts val="1600"/>
+              </a:spcBef>
+              <a:defRPr sz="2400">
+                <a:solidFill>
+                  <a:srgbClr val="333333"/>
+                </a:solidFill>
+              </a:defRPr>
+            </a:pPr>
+            <a:r>
+              <a:t>4. Phân phối 12 tiết đề xuất</a:t>
+            </a:r>
+          </a:p>
+          <a:p>
+            <a:pPr>
+              <a:spcBef>
+                <a:spcPts val="1600"/>
+              </a:spcBef>
+              <a:defRPr sz="2400">
+                <a:solidFill>
+                  <a:srgbClr val="333333"/>
+                </a:solidFill>
+              </a:defRPr>
+            </a:pPr>
+            <a:r>
+              <a:t>5. Hướng dẫn sử dụng</a:t>
+            </a:r>
+          </a:p>
+          <a:p>
+            <a:pPr>
+              <a:spcBef>
+                <a:spcPts val="1600"/>
+              </a:spcBef>
+              <a:defRPr sz="2400">
+                <a:solidFill>
+                  <a:srgbClr val="333333"/>
+                </a:solidFill>
+              </a:defRPr>
+            </a:pPr>
+            <a:r>
+              <a:t>6. Tài liệu tham khảo</a:t>
+            </a:r>
+          </a:p>
+        </p:txBody>
+      </p:sp>
+    </p:spTree>
+  </p:cSld>
+  <p:clrMapOvr>
+    <a:masterClrMapping/>
+  </p:clrMapOvr>
+</p:sld>
+</file>
+
+<file path=ppt/slides/slide4.xml><?xml version="1.0" encoding="utf-8"?>
+<p:sld xmlns:a="http://schemas.openxmlformats.org/drawingml/2006/main" xmlns:p="http://schemas.openxmlformats.org/presentationml/2006/main" xmlns:r="http://schemas.openxmlformats.org/officeDocument/2006/relationships">
+  <p:cSld>
+    <p:spTree>
+      <p:nvGrpSpPr>
+        <p:cNvPr id="1" name=""/>
+        <p:cNvGrpSpPr/>
+        <p:nvPr/>
+      </p:nvGrpSpPr>
+      <p:grpSpPr/>
+      <p:sp>
+        <p:nvSpPr>
+          <p:cNvPr id="2" name="Rectangle 1"/>
+          <p:cNvSpPr/>
+          <p:nvPr/>
+        </p:nvSpPr>
+        <p:spPr>
+          <a:xfrm>
+            <a:off x="0" y="0"/>
+            <a:ext cx="12191695" cy="731520"/>
+          </a:xfrm>
+          <a:prstGeom prst="rect">
+            <a:avLst/>
+          </a:prstGeom>
+          <a:solidFill>
+            <a:srgbClr val="0078D7"/>
+          </a:solidFill>
+          <a:ln>
+            <a:noFill/>
+          </a:ln>
+        </p:spPr>
+        <p:style>
+          <a:lnRef idx="1">
+            <a:schemeClr val="accent1"/>
+          </a:lnRef>
+          <a:fillRef idx="3">
+            <a:schemeClr val="accent1"/>
+          </a:fillRef>
+          <a:effectRef idx="2">
+            <a:schemeClr val="accent1"/>
+          </a:effectRef>
+          <a:fontRef idx="minor">
+            <a:schemeClr val="lt1"/>
+          </a:fontRef>
+        </p:style>
+        <p:txBody>
+          <a:bodyPr rtlCol="0" anchor="ctr"/>
+          <a:lstStyle/>
+          <a:p>
+            <a:pPr algn="ctr"/>
+          </a:p>
+        </p:txBody>
+      </p:sp>
+      <p:sp>
+        <p:nvSpPr>
+          <p:cNvPr id="3" name="Oval 2"/>
+          <p:cNvSpPr/>
+          <p:nvPr/>
+        </p:nvSpPr>
+        <p:spPr>
+          <a:xfrm>
+            <a:off x="274320" y="137160"/>
+            <a:ext cx="457200" cy="457200"/>
+          </a:xfrm>
+          <a:prstGeom prst="ellipse">
+            <a:avLst/>
+          </a:prstGeom>
+          <a:solidFill>
+            <a:srgbClr val="F0F0F0"/>
+          </a:solidFill>
+          <a:ln w="25400">
+            <a:solidFill>
+              <a:srgbClr val="C8C8C8"/>
+            </a:solidFill>
+          </a:ln>
+        </p:spPr>
+        <p:style>
+          <a:lnRef idx="1">
+            <a:schemeClr val="accent1"/>
+          </a:lnRef>
+          <a:fillRef idx="3">
+            <a:schemeClr val="accent1"/>
+          </a:fillRef>
+          <a:effectRef idx="2">
+            <a:schemeClr val="accent1"/>
+          </a:effectRef>
+          <a:fontRef idx="minor">
+            <a:schemeClr val="lt1"/>
+          </a:fontRef>
+        </p:style>
+        <p:txBody>
+          <a:bodyPr rtlCol="0" anchor="ctr" wrap="square"/>
+          <a:lstStyle/>
+          <a:p>
+            <a:pPr algn="ctr">
+              <a:defRPr sz="1000" b="1">
+                <a:solidFill>
+                  <a:srgbClr val="C8C8C8"/>
+                </a:solidFill>
+              </a:defRPr>
+            </a:pPr>
+            <a:r>
+              <a:t>ĐHSP</a:t>
+            </a:r>
+          </a:p>
+        </p:txBody>
+      </p:sp>
+      <p:sp>
+        <p:nvSpPr>
+          <p:cNvPr id="4" name="Oval 3"/>
+          <p:cNvSpPr/>
+          <p:nvPr/>
+        </p:nvSpPr>
+        <p:spPr>
+          <a:xfrm>
+            <a:off x="822960" y="137160"/>
+            <a:ext cx="457200" cy="457200"/>
+          </a:xfrm>
+          <a:prstGeom prst="ellipse">
+            <a:avLst/>
+          </a:prstGeom>
+          <a:solidFill>
+            <a:srgbClr val="F0F0F0"/>
+          </a:solidFill>
+          <a:ln w="25400">
+            <a:solidFill>
+              <a:srgbClr val="C8C8C8"/>
+            </a:solidFill>
+          </a:ln>
+        </p:spPr>
+        <p:style>
+          <a:lnRef idx="1">
+            <a:schemeClr val="accent1"/>
+          </a:lnRef>
+          <a:fillRef idx="3">
+            <a:schemeClr val="accent1"/>
+          </a:fillRef>
+          <a:effectRef idx="2">
+            <a:schemeClr val="accent1"/>
+          </a:effectRef>
+          <a:fontRef idx="minor">
+            <a:schemeClr val="lt1"/>
+          </a:fontRef>
+        </p:style>
+        <p:txBody>
+          <a:bodyPr rtlCol="0" anchor="ctr" wrap="square"/>
+          <a:lstStyle/>
+          <a:p>
+            <a:pPr algn="ctr">
+              <a:defRPr sz="1000" b="1">
+                <a:solidFill>
+                  <a:srgbClr val="C8C8C8"/>
+                </a:solidFill>
+              </a:defRPr>
+            </a:pPr>
+            <a:r>
+              <a:t>THPT</a:t>
+            </a:r>
+          </a:p>
+        </p:txBody>
+      </p:sp>
+      <p:sp>
+        <p:nvSpPr>
+          <p:cNvPr id="5" name="TextBox 4"/>
+          <p:cNvSpPr txBox="1"/>
+          <p:nvPr/>
+        </p:nvSpPr>
+        <p:spPr>
+          <a:xfrm>
+            <a:off x="1463040" y="137160"/>
+            <a:ext cx="9144000" cy="457200"/>
+          </a:xfrm>
+          <a:prstGeom prst="rect">
+            <a:avLst/>
+          </a:prstGeom>
+          <a:noFill/>
+        </p:spPr>
+        <p:txBody>
+          <a:bodyPr wrap="none">
+            <a:spAutoFit/>
+          </a:bodyPr>
+          <a:lstStyle/>
+          <a:p>
+            <a:pPr>
+              <a:defRPr sz="1800" b="1">
+                <a:solidFill>
+                  <a:srgbClr val="FFFFFF"/>
+                </a:solidFill>
+              </a:defRPr>
+            </a:pPr>
+            <a:r>
+              <a:t>AInatomy — Phòng thực hành AI</a:t>
+            </a:r>
+          </a:p>
+        </p:txBody>
+      </p:sp>
+      <p:sp>
+        <p:nvSpPr>
+          <p:cNvPr id="6" name="TextBox 5"/>
+          <p:cNvSpPr txBox="1"/>
+          <p:nvPr/>
+        </p:nvSpPr>
+        <p:spPr>
+          <a:xfrm>
+            <a:off x="457200" y="1097280"/>
+            <a:ext cx="10972800" cy="731520"/>
+          </a:xfrm>
+          <a:prstGeom prst="rect">
+            <a:avLst/>
+          </a:prstGeom>
+          <a:noFill/>
+        </p:spPr>
+        <p:txBody>
+          <a:bodyPr wrap="none">
+            <a:spAutoFit/>
+          </a:bodyPr>
+          <a:lstStyle/>
+          <a:p>
+            <a:pPr>
+              <a:defRPr sz="3600" b="1">
+                <a:solidFill>
+                  <a:srgbClr val="333333"/>
+                </a:solidFill>
+              </a:defRPr>
+            </a:pPr>
+            <a:r>
+              <a:t>Tích hợp vào chương trình</a:t>
+            </a:r>
+          </a:p>
+        </p:txBody>
+      </p:sp>
+      <p:sp>
+        <p:nvSpPr>
+          <p:cNvPr id="7" name="TextBox 6"/>
+          <p:cNvSpPr txBox="1"/>
+          <p:nvPr/>
+        </p:nvSpPr>
+        <p:spPr>
+          <a:xfrm>
+            <a:off x="457200" y="6217920"/>
+            <a:ext cx="10972800" cy="457200"/>
+          </a:xfrm>
+          <a:prstGeom prst="rect">
+            <a:avLst/>
+          </a:prstGeom>
+          <a:noFill/>
+        </p:spPr>
+        <p:txBody>
+          <a:bodyPr wrap="none">
+            <a:spAutoFit/>
+          </a:bodyPr>
+          <a:lstStyle/>
+          <a:p>
+            <a:pPr algn="ctr">
+              <a:defRPr sz="1100">
+                <a:solidFill>
+                  <a:srgbClr val="C8C8C8"/>
+                </a:solidFill>
+              </a:defRPr>
+            </a:pPr>
+            <a:r>
+              <a:t>Trường THPT Thuận Hoá — ĐHSP Huế | GV: Mai Xuân Văn</a:t>
+            </a:r>
+          </a:p>
+        </p:txBody>
+      </p:sp>
+      <p:sp>
+        <p:nvSpPr>
+          <p:cNvPr id="8" name="TextBox 7"/>
+          <p:cNvSpPr txBox="1"/>
+          <p:nvPr/>
+        </p:nvSpPr>
+        <p:spPr>
+          <a:xfrm>
+            <a:off x="457200" y="2011680"/>
+            <a:ext cx="5029200" cy="3657600"/>
+          </a:xfrm>
+          <a:prstGeom prst="rect">
+            <a:avLst/>
+          </a:prstGeom>
+          <a:noFill/>
+        </p:spPr>
+        <p:txBody>
+          <a:bodyPr wrap="square">
+            <a:spAutoFit/>
+          </a:bodyPr>
+          <a:lstStyle/>
+          <a:p>
+            <a:pPr>
+              <a:spcAft>
+                <a:spcPts val="1200"/>
+              </a:spcAft>
+              <a:defRPr sz="2800" b="1">
+                <a:solidFill>
+                  <a:srgbClr val="0078D7"/>
+                </a:solidFill>
+              </a:defRPr>
+            </a:pPr>
+            <a:r>
+              <a:t>Chủ đề A-B-D</a:t>
+            </a:r>
+          </a:p>
+          <a:p>
+            <a:pPr>
+              <a:spcBef>
+                <a:spcPts val="600"/>
+              </a:spcBef>
+              <a:defRPr sz="1800">
+                <a:solidFill>
+                  <a:srgbClr val="333333"/>
+                </a:solidFill>
+              </a:defRPr>
+            </a:pPr>
+            <a:r>
+              <a:t>A: Máy tính và xã hội tri thức</a:t>
+            </a:r>
+          </a:p>
+          <a:p>
+            <a:pPr>
+              <a:spcBef>
+                <a:spcPts val="600"/>
+              </a:spcBef>
+              <a:defRPr sz="1800">
+                <a:solidFill>
+                  <a:srgbClr val="333333"/>
+                </a:solidFill>
+              </a:defRPr>
+            </a:pPr>
+            <a:r>
+              <a:t>B: Mạng máy tính và Internet</a:t>
+            </a:r>
+          </a:p>
+          <a:p>
+            <a:pPr>
+              <a:spcBef>
+                <a:spcPts val="600"/>
+              </a:spcBef>
+              <a:defRPr sz="1800">
+                <a:solidFill>
+                  <a:srgbClr val="333333"/>
+                </a:solidFill>
+              </a:defRPr>
+            </a:pPr>
+            <a:r>
+              <a:t>D: Đạo đức, pháp luật số</a:t>
+            </a:r>
+          </a:p>
+          <a:p>
+            <a:pPr>
+              <a:spcBef>
+                <a:spcPts val="600"/>
+              </a:spcBef>
+              <a:defRPr sz="1800">
+                <a:solidFill>
+                  <a:srgbClr val="333333"/>
+                </a:solidFill>
+              </a:defRPr>
+            </a:pPr>
+          </a:p>
+          <a:p>
+            <a:pPr>
+              <a:spcBef>
+                <a:spcPts val="600"/>
+              </a:spcBef>
+              <a:defRPr sz="1800">
+                <a:solidFill>
+                  <a:srgbClr val="333333"/>
+                </a:solidFill>
+              </a:defRPr>
+            </a:pPr>
+            <a:r>
+              <a:t>Hoạt động chính:</a:t>
+            </a:r>
+          </a:p>
+          <a:p>
+            <a:pPr>
+              <a:spcBef>
+                <a:spcPts val="600"/>
+              </a:spcBef>
+              <a:defRPr sz="1800">
+                <a:solidFill>
+                  <a:srgbClr val="333333"/>
+                </a:solidFill>
+              </a:defRPr>
+            </a:pPr>
+            <a:r>
+              <a:t>• Kịch bản 9 cảnh</a:t>
+            </a:r>
+          </a:p>
+          <a:p>
+            <a:pPr>
+              <a:spcBef>
+                <a:spcPts val="600"/>
+              </a:spcBef>
+              <a:defRPr sz="1800">
+                <a:solidFill>
+                  <a:srgbClr val="333333"/>
+                </a:solidFill>
+              </a:defRPr>
+            </a:pPr>
+            <a:r>
+              <a:t>• Đấu trường bắt lỗi AI</a:t>
+            </a:r>
+          </a:p>
+          <a:p>
+            <a:pPr>
+              <a:spcBef>
+                <a:spcPts val="600"/>
+              </a:spcBef>
+              <a:defRPr sz="1800">
+                <a:solidFill>
+                  <a:srgbClr val="333333"/>
+                </a:solidFill>
+              </a:defRPr>
+            </a:pPr>
+            <a:r>
+              <a:t>• Tình huống &amp; trách nhiệm</a:t>
+            </a:r>
+          </a:p>
+        </p:txBody>
+      </p:sp>
+      <p:sp>
+        <p:nvSpPr>
+          <p:cNvPr id="9" name="TextBox 8"/>
+          <p:cNvSpPr txBox="1"/>
+          <p:nvPr/>
+        </p:nvSpPr>
+        <p:spPr>
+          <a:xfrm>
+            <a:off x="5943600" y="2011680"/>
+            <a:ext cx="5029200" cy="3657600"/>
+          </a:xfrm>
+          <a:prstGeom prst="rect">
+            <a:avLst/>
+          </a:prstGeom>
+          <a:noFill/>
+        </p:spPr>
+        <p:txBody>
+          <a:bodyPr wrap="square">
+            <a:spAutoFit/>
+          </a:bodyPr>
+          <a:lstStyle/>
+          <a:p>
+            <a:pPr>
+              <a:spcAft>
+                <a:spcPts val="1200"/>
+              </a:spcAft>
+              <a:defRPr sz="2800" b="1">
+                <a:solidFill>
+                  <a:srgbClr val="0078D7"/>
+                </a:solidFill>
+              </a:defRPr>
+            </a:pPr>
+            <a:r>
+              <a:t>Chủ đề E-F-G</a:t>
+            </a:r>
+          </a:p>
+          <a:p>
+            <a:pPr>
+              <a:spcBef>
+                <a:spcPts val="600"/>
+              </a:spcBef>
+              <a:defRPr sz="1800">
+                <a:solidFill>
+                  <a:srgbClr val="333333"/>
+                </a:solidFill>
+              </a:defRPr>
+            </a:pPr>
+            <a:r>
+              <a:t>E: Thiết kế đồ họa (ICT)</a:t>
+            </a:r>
+          </a:p>
+          <a:p>
+            <a:pPr>
+              <a:spcBef>
+                <a:spcPts val="600"/>
+              </a:spcBef>
+              <a:defRPr sz="1800">
+                <a:solidFill>
+                  <a:srgbClr val="333333"/>
+                </a:solidFill>
+              </a:defRPr>
+            </a:pPr>
+            <a:r>
+              <a:t>F: Giải quyết vấn đề với máy tính</a:t>
+            </a:r>
+          </a:p>
+          <a:p>
+            <a:pPr>
+              <a:spcBef>
+                <a:spcPts val="600"/>
+              </a:spcBef>
+              <a:defRPr sz="1800">
+                <a:solidFill>
+                  <a:srgbClr val="333333"/>
+                </a:solidFill>
+              </a:defRPr>
+            </a:pPr>
+            <a:r>
+              <a:t>G: Hướng nghiệp (CS)</a:t>
+            </a:r>
+          </a:p>
+          <a:p>
+            <a:pPr>
+              <a:spcBef>
+                <a:spcPts val="600"/>
+              </a:spcBef>
+              <a:defRPr sz="1800">
+                <a:solidFill>
+                  <a:srgbClr val="333333"/>
+                </a:solidFill>
+              </a:defRPr>
+            </a:pPr>
+          </a:p>
+          <a:p>
+            <a:pPr>
+              <a:spcBef>
+                <a:spcPts val="600"/>
+              </a:spcBef>
+              <a:defRPr sz="1800">
+                <a:solidFill>
+                  <a:srgbClr val="333333"/>
+                </a:solidFill>
+              </a:defRPr>
+            </a:pPr>
+            <a:r>
+              <a:t>Hoạt động chính:</a:t>
+            </a:r>
+          </a:p>
+          <a:p>
+            <a:pPr>
+              <a:spcBef>
+                <a:spcPts val="600"/>
+              </a:spcBef>
+              <a:defRPr sz="1800">
+                <a:solidFill>
+                  <a:srgbClr val="333333"/>
+                </a:solidFill>
+              </a:defRPr>
+            </a:pPr>
+            <a:r>
+              <a:t>• Tầng 1 - Xưởng huấn luyện</a:t>
+            </a:r>
+          </a:p>
+          <a:p>
+            <a:pPr>
+              <a:spcBef>
+                <a:spcPts val="600"/>
+              </a:spcBef>
+              <a:defRPr sz="1800">
+                <a:solidFill>
+                  <a:srgbClr val="333333"/>
+                </a:solidFill>
+              </a:defRPr>
+            </a:pPr>
+            <a:r>
+              <a:t>• Nhà máy AI 7 trạm</a:t>
+            </a:r>
+          </a:p>
+          <a:p>
+            <a:pPr>
+              <a:spcBef>
+                <a:spcPts val="600"/>
+              </a:spcBef>
+              <a:defRPr sz="1800">
+                <a:solidFill>
+                  <a:srgbClr val="333333"/>
+                </a:solidFill>
+              </a:defRPr>
+            </a:pPr>
+            <a:r>
+              <a:t>• Kiến thức Tin học</a:t>
+            </a:r>
+          </a:p>
+        </p:txBody>
+      </p:sp>
+    </p:spTree>
+  </p:cSld>
+  <p:clrMapOvr>
+    <a:masterClrMapping/>
+  </p:clrMapOvr>
+</p:sld>
+</file>
+
+<file path=ppt/slides/slide5.xml><?xml version="1.0" encoding="utf-8"?>
+<p:sld xmlns:a="http://schemas.openxmlformats.org/drawingml/2006/main" xmlns:p="http://schemas.openxmlformats.org/presentationml/2006/main" xmlns:r="http://schemas.openxmlformats.org/officeDocument/2006/relationships">
+  <p:cSld>
+    <p:spTree>
+      <p:nvGrpSpPr>
+        <p:cNvPr id="1" name=""/>
+        <p:cNvGrpSpPr/>
+        <p:nvPr/>
+      </p:nvGrpSpPr>
+      <p:grpSpPr/>
+      <p:sp>
+        <p:nvSpPr>
+          <p:cNvPr id="2" name="Rectangle 1"/>
+          <p:cNvSpPr/>
+          <p:nvPr/>
+        </p:nvSpPr>
+        <p:spPr>
+          <a:xfrm>
+            <a:off x="0" y="0"/>
+            <a:ext cx="12191695" cy="1097280"/>
+          </a:xfrm>
+          <a:prstGeom prst="rect">
+            <a:avLst/>
+          </a:prstGeom>
+          <a:solidFill>
+            <a:srgbClr val="0078D7"/>
+          </a:solidFill>
+          <a:ln>
+            <a:noFill/>
+          </a:ln>
+        </p:spPr>
+        <p:style>
+          <a:lnRef idx="1">
+            <a:schemeClr val="accent1"/>
+          </a:lnRef>
+          <a:fillRef idx="3">
+            <a:schemeClr val="accent1"/>
+          </a:fillRef>
+          <a:effectRef idx="2">
+            <a:schemeClr val="accent1"/>
+          </a:effectRef>
+          <a:fontRef idx="minor">
+            <a:schemeClr val="lt1"/>
+          </a:fontRef>
+        </p:style>
+        <p:txBody>
+          <a:bodyPr rtlCol="0" anchor="ctr"/>
+          <a:lstStyle/>
+          <a:p>
+            <a:pPr algn="ctr"/>
+          </a:p>
+        </p:txBody>
+      </p:sp>
+      <p:sp>
+        <p:nvSpPr>
+          <p:cNvPr id="3" name="Oval 2"/>
+          <p:cNvSpPr/>
+          <p:nvPr/>
+        </p:nvSpPr>
+        <p:spPr>
+          <a:xfrm>
+            <a:off x="365760" y="182880"/>
+            <a:ext cx="731520" cy="731520"/>
+          </a:xfrm>
+          <a:prstGeom prst="ellipse">
+            <a:avLst/>
+          </a:prstGeom>
+          <a:solidFill>
+            <a:srgbClr val="F0F0F0"/>
+          </a:solidFill>
+          <a:ln w="25400">
+            <a:solidFill>
+              <a:srgbClr val="C8C8C8"/>
+            </a:solidFill>
+          </a:ln>
+        </p:spPr>
+        <p:style>
+          <a:lnRef idx="1">
+            <a:schemeClr val="accent1"/>
+          </a:lnRef>
+          <a:fillRef idx="3">
+            <a:schemeClr val="accent1"/>
+          </a:fillRef>
+          <a:effectRef idx="2">
+            <a:schemeClr val="accent1"/>
+          </a:effectRef>
+          <a:fontRef idx="minor">
+            <a:schemeClr val="lt1"/>
+          </a:fontRef>
+        </p:style>
+        <p:txBody>
+          <a:bodyPr rtlCol="0" anchor="ctr" wrap="square"/>
+          <a:lstStyle/>
+          <a:p>
+            <a:pPr algn="ctr">
+              <a:defRPr sz="1000" b="1">
+                <a:solidFill>
+                  <a:srgbClr val="C8C8C8"/>
+                </a:solidFill>
+              </a:defRPr>
+            </a:pPr>
+            <a:r>
+              <a:t>LOGO</a:t>
+            </a:r>
+          </a:p>
+          <a:p>
+            <a:r>
+              <a:t>ĐHSP</a:t>
+            </a:r>
+          </a:p>
+        </p:txBody>
+      </p:sp>
+      <p:sp>
+        <p:nvSpPr>
+          <p:cNvPr id="4" name="Oval 3"/>
+          <p:cNvSpPr/>
+          <p:nvPr/>
+        </p:nvSpPr>
+        <p:spPr>
+          <a:xfrm>
+            <a:off x="1280160" y="182880"/>
+            <a:ext cx="731520" cy="731520"/>
+          </a:xfrm>
+          <a:prstGeom prst="ellipse">
+            <a:avLst/>
+          </a:prstGeom>
+          <a:solidFill>
+            <a:srgbClr val="F0F0F0"/>
+          </a:solidFill>
+          <a:ln w="25400">
+            <a:solidFill>
+              <a:srgbClr val="C8C8C8"/>
+            </a:solidFill>
+          </a:ln>
+        </p:spPr>
+        <p:style>
+          <a:lnRef idx="1">
+            <a:schemeClr val="accent1"/>
+          </a:lnRef>
+          <a:fillRef idx="3">
+            <a:schemeClr val="accent1"/>
+          </a:fillRef>
+          <a:effectRef idx="2">
+            <a:schemeClr val="accent1"/>
+          </a:effectRef>
+          <a:fontRef idx="minor">
+            <a:schemeClr val="lt1"/>
+          </a:fontRef>
+        </p:style>
+        <p:txBody>
+          <a:bodyPr rtlCol="0" anchor="ctr" wrap="square"/>
+          <a:lstStyle/>
+          <a:p>
+            <a:pPr algn="ctr">
+              <a:defRPr sz="1000" b="1">
+                <a:solidFill>
+                  <a:srgbClr val="C8C8C8"/>
+                </a:solidFill>
+              </a:defRPr>
+            </a:pPr>
+            <a:r>
+              <a:t>LOGO</a:t>
+            </a:r>
+          </a:p>
+          <a:p>
+            <a:r>
+              <a:t>THPT</a:t>
+            </a:r>
+          </a:p>
+        </p:txBody>
+      </p:sp>
+      <p:sp>
+        <p:nvSpPr>
+          <p:cNvPr id="5" name="TextBox 4"/>
+          <p:cNvSpPr txBox="1"/>
+          <p:nvPr/>
+        </p:nvSpPr>
+        <p:spPr>
+          <a:xfrm>
+            <a:off x="1371600" y="2560320"/>
+            <a:ext cx="9144000" cy="1371600"/>
+          </a:xfrm>
+          <a:prstGeom prst="rect">
+            <a:avLst/>
+          </a:prstGeom>
+          <a:noFill/>
+        </p:spPr>
+        <p:txBody>
+          <a:bodyPr wrap="square">
+            <a:spAutoFit/>
+          </a:bodyPr>
+          <a:lstStyle/>
+          <a:p>
+            <a:pPr algn="ctr">
+              <a:defRPr sz="5400" b="1">
+                <a:solidFill>
+                  <a:srgbClr val="333333"/>
+                </a:solidFill>
+              </a:defRPr>
+            </a:pPr>
+            <a:r>
+              <a:t>Cảm ơn</a:t>
+            </a:r>
+          </a:p>
+        </p:txBody>
+      </p:sp>
+      <p:sp>
+        <p:nvSpPr>
+          <p:cNvPr id="6" name="TextBox 5"/>
+          <p:cNvSpPr txBox="1"/>
+          <p:nvPr/>
+        </p:nvSpPr>
+        <p:spPr>
+          <a:xfrm>
+            <a:off x="1371600" y="4114800"/>
+            <a:ext cx="9144000" cy="1371600"/>
+          </a:xfrm>
+          <a:prstGeom prst="rect">
+            <a:avLst/>
+          </a:prstGeom>
+          <a:noFill/>
+        </p:spPr>
+        <p:txBody>
+          <a:bodyPr wrap="square">
+            <a:spAutoFit/>
+          </a:bodyPr>
+          <a:lstStyle/>
+          <a:p>
+            <a:pPr algn="ctr">
+              <a:defRPr sz="2000">
+                <a:solidFill>
+                  <a:srgbClr val="333333"/>
+                </a:solidFill>
+              </a:defRPr>
+            </a:pPr>
+            <a:r>
+              <a:t>Trường THPT Thuận Hoá</a:t>
+            </a:r>
+            <a:br/>
+            <a:r>
+              <a:t>Đại học Sư Phạm, Đại học Huế</a:t>
+            </a:r>
+            <a:br/>
+            <a:r>
+              <a:t>GV: Mai Xuân Văn</a:t>
+            </a:r>
+          </a:p>
+        </p:txBody>
+      </p:sp>
+      <p:sp>
+        <p:nvSpPr>
+          <p:cNvPr id="7" name="TextBox 6"/>
+          <p:cNvSpPr txBox="1"/>
+          <p:nvPr/>
+        </p:nvSpPr>
+        <p:spPr>
+          <a:xfrm>
+            <a:off x="457200" y="5943600"/>
+            <a:ext cx="10972800" cy="731520"/>
+          </a:xfrm>
+          <a:prstGeom prst="rect">
+            <a:avLst/>
+          </a:prstGeom>
+          <a:noFill/>
+        </p:spPr>
+        <p:txBody>
+          <a:bodyPr wrap="none">
+            <a:spAutoFit/>
+          </a:bodyPr>
+          <a:lstStyle/>
+          <a:p>
+            <a:pPr algn="ctr">
+              <a:defRPr sz="1400">
+                <a:solidFill>
+                  <a:srgbClr val="C8C8C8"/>
+                </a:solidFill>
+              </a:defRPr>
+            </a:pPr>
+            <a:r>
+              <a:t>AInatomy — Phòng thực hành Trí tuệ nhân tạo</a:t>
+            </a:r>
+          </a:p>
+        </p:txBody>
+      </p:sp>
+    </p:spTree>
+  </p:cSld>
+  <p:clrMapOvr>
+    <a:masterClrMapping/>
+  </p:clrMapOvr>
+</p:sld>
+</file>
+
+<file path=ppt/slides/slide6.xml><?xml version="1.0" encoding="utf-8"?>
+<p:sld xmlns:a="http://schemas.openxmlformats.org/drawingml/2006/main" xmlns:p="http://schemas.openxmlformats.org/presentationml/2006/main" xmlns:r="http://schemas.openxmlformats.org/officeDocument/2006/relationships">
+  <p:cSld>
+    <p:spTree>
+      <p:nvGrpSpPr>
+        <p:cNvPr id="1" name=""/>
+        <p:cNvGrpSpPr/>
+        <p:nvPr/>
+      </p:nvGrpSpPr>
+      <p:grpSpPr/>
+      <p:sp>
+        <p:nvSpPr>
+          <p:cNvPr id="2" name="Rectangle 1"/>
+          <p:cNvSpPr/>
+          <p:nvPr/>
+        </p:nvSpPr>
+        <p:spPr>
+          <a:xfrm>
+            <a:off x="0" y="0"/>
+            <a:ext cx="12191695" cy="731520"/>
+          </a:xfrm>
+          <a:prstGeom prst="rect">
+            <a:avLst/>
+          </a:prstGeom>
+          <a:solidFill>
+            <a:srgbClr val="0078D7"/>
+          </a:solidFill>
+          <a:ln>
+            <a:noFill/>
+          </a:ln>
+        </p:spPr>
+        <p:style>
+          <a:lnRef idx="1">
+            <a:schemeClr val="accent1"/>
+          </a:lnRef>
+          <a:fillRef idx="3">
+            <a:schemeClr val="accent1"/>
+          </a:fillRef>
+          <a:effectRef idx="2">
+            <a:schemeClr val="accent1"/>
+          </a:effectRef>
+          <a:fontRef idx="minor">
+            <a:schemeClr val="lt1"/>
+          </a:fontRef>
+        </p:style>
+        <p:txBody>
+          <a:bodyPr rtlCol="0" anchor="ctr"/>
+          <a:lstStyle/>
+          <a:p>
+            <a:pPr algn="ctr"/>
+          </a:p>
+        </p:txBody>
+      </p:sp>
+      <p:sp>
+        <p:nvSpPr>
+          <p:cNvPr id="3" name="Oval 2"/>
+          <p:cNvSpPr/>
+          <p:nvPr/>
+        </p:nvSpPr>
+        <p:spPr>
+          <a:xfrm>
+            <a:off x="274320" y="137160"/>
+            <a:ext cx="457200" cy="457200"/>
+          </a:xfrm>
+          <a:prstGeom prst="ellipse">
+            <a:avLst/>
+          </a:prstGeom>
+          <a:solidFill>
+            <a:srgbClr val="F0F0F0"/>
+          </a:solidFill>
+          <a:ln w="25400">
+            <a:solidFill>
+              <a:srgbClr val="C8C8C8"/>
+            </a:solidFill>
+          </a:ln>
+        </p:spPr>
+        <p:style>
+          <a:lnRef idx="1">
+            <a:schemeClr val="accent1"/>
+          </a:lnRef>
+          <a:fillRef idx="3">
+            <a:schemeClr val="accent1"/>
+          </a:fillRef>
+          <a:effectRef idx="2">
+            <a:schemeClr val="accent1"/>
+          </a:effectRef>
+          <a:fontRef idx="minor">
+            <a:schemeClr val="lt1"/>
+          </a:fontRef>
+        </p:style>
+        <p:txBody>
+          <a:bodyPr rtlCol="0" anchor="ctr" wrap="square"/>
+          <a:lstStyle/>
+          <a:p>
+            <a:pPr algn="ctr">
+              <a:defRPr sz="1000" b="1">
+                <a:solidFill>
+                  <a:srgbClr val="C8C8C8"/>
+                </a:solidFill>
+              </a:defRPr>
+            </a:pPr>
+            <a:r>
+              <a:t>ĐHSP</a:t>
+            </a:r>
+          </a:p>
+        </p:txBody>
+      </p:sp>
+      <p:sp>
+        <p:nvSpPr>
+          <p:cNvPr id="4" name="Oval 3"/>
+          <p:cNvSpPr/>
+          <p:nvPr/>
+        </p:nvSpPr>
+        <p:spPr>
+          <a:xfrm>
+            <a:off x="822960" y="137160"/>
+            <a:ext cx="457200" cy="457200"/>
+          </a:xfrm>
+          <a:prstGeom prst="ellipse">
+            <a:avLst/>
+          </a:prstGeom>
+          <a:solidFill>
+            <a:srgbClr val="F0F0F0"/>
+          </a:solidFill>
+          <a:ln w="25400">
+            <a:solidFill>
+              <a:srgbClr val="C8C8C8"/>
+            </a:solidFill>
+          </a:ln>
+        </p:spPr>
+        <p:style>
+          <a:lnRef idx="1">
+            <a:schemeClr val="accent1"/>
+          </a:lnRef>
+          <a:fillRef idx="3">
+            <a:schemeClr val="accent1"/>
+          </a:fillRef>
+          <a:effectRef idx="2">
+            <a:schemeClr val="accent1"/>
+          </a:effectRef>
+          <a:fontRef idx="minor">
+            <a:schemeClr val="lt1"/>
+          </a:fontRef>
+        </p:style>
+        <p:txBody>
+          <a:bodyPr rtlCol="0" anchor="ctr" wrap="square"/>
+          <a:lstStyle/>
+          <a:p>
+            <a:pPr algn="ctr">
+              <a:defRPr sz="1000" b="1">
+                <a:solidFill>
+                  <a:srgbClr val="C8C8C8"/>
+                </a:solidFill>
+              </a:defRPr>
+            </a:pPr>
+            <a:r>
+              <a:t>THPT</a:t>
+            </a:r>
+          </a:p>
+        </p:txBody>
+      </p:sp>
+      <p:sp>
+        <p:nvSpPr>
+          <p:cNvPr id="5" name="TextBox 4"/>
+          <p:cNvSpPr txBox="1"/>
+          <p:nvPr/>
+        </p:nvSpPr>
+        <p:spPr>
+          <a:xfrm>
+            <a:off x="1463040" y="137160"/>
+            <a:ext cx="9144000" cy="457200"/>
+          </a:xfrm>
+          <a:prstGeom prst="rect">
+            <a:avLst/>
+          </a:prstGeom>
+          <a:noFill/>
+        </p:spPr>
+        <p:txBody>
+          <a:bodyPr wrap="none">
+            <a:spAutoFit/>
+          </a:bodyPr>
+          <a:lstStyle/>
+          <a:p>
+            <a:pPr>
+              <a:defRPr sz="1800" b="1">
+                <a:solidFill>
+                  <a:srgbClr val="FFFFFF"/>
+                </a:solidFill>
+              </a:defRPr>
+            </a:pPr>
+            <a:r>
+              <a:t>AInatomy — Phòng thực hành AI</a:t>
+            </a:r>
+          </a:p>
+        </p:txBody>
+      </p:sp>
+      <p:sp>
+        <p:nvSpPr>
+          <p:cNvPr id="6" name="TextBox 5"/>
+          <p:cNvSpPr txBox="1"/>
+          <p:nvPr/>
+        </p:nvSpPr>
+        <p:spPr>
+          <a:xfrm>
+            <a:off x="457200" y="1097280"/>
+            <a:ext cx="10972800" cy="731520"/>
+          </a:xfrm>
+          <a:prstGeom prst="rect">
+            <a:avLst/>
+          </a:prstGeom>
+          <a:noFill/>
+        </p:spPr>
+        <p:txBody>
+          <a:bodyPr wrap="none">
+            <a:spAutoFit/>
+          </a:bodyPr>
+          <a:lstStyle/>
+          <a:p>
+            <a:pPr>
+              <a:defRPr sz="3600" b="1">
+                <a:solidFill>
+                  <a:srgbClr val="333333"/>
+                </a:solidFill>
+              </a:defRPr>
+            </a:pPr>
+            <a:r>
+              <a:t>AInatomy - Phòng thực hành AI</a:t>
+            </a:r>
+          </a:p>
+        </p:txBody>
+      </p:sp>
+      <p:sp>
+        <p:nvSpPr>
+          <p:cNvPr id="7" name="TextBox 6"/>
+          <p:cNvSpPr txBox="1"/>
+          <p:nvPr/>
+        </p:nvSpPr>
+        <p:spPr>
+          <a:xfrm>
+            <a:off x="457200" y="6217920"/>
+            <a:ext cx="10972800" cy="457200"/>
+          </a:xfrm>
+          <a:prstGeom prst="rect">
+            <a:avLst/>
+          </a:prstGeom>
+          <a:noFill/>
+        </p:spPr>
+        <p:txBody>
+          <a:bodyPr wrap="none">
+            <a:spAutoFit/>
+          </a:bodyPr>
+          <a:lstStyle/>
+          <a:p>
+            <a:pPr algn="ctr">
+              <a:defRPr sz="1100">
+                <a:solidFill>
+                  <a:srgbClr val="C8C8C8"/>
+                </a:solidFill>
+              </a:defRPr>
+            </a:pPr>
+            <a:r>
+              <a:t>Trường THPT Thuận Hoá — ĐHSP Huế | GV: Mai Xuân Văn</a:t>
+            </a:r>
+          </a:p>
+        </p:txBody>
+      </p:sp>
+      <p:sp>
+        <p:nvSpPr>
+          <p:cNvPr id="8" name="TextBox 7"/>
+          <p:cNvSpPr txBox="1"/>
+          <p:nvPr/>
+        </p:nvSpPr>
+        <p:spPr>
+          <a:xfrm>
+            <a:off x="457200" y="2011680"/>
+            <a:ext cx="10972800" cy="1371600"/>
+          </a:xfrm>
+          <a:prstGeom prst="rect">
+            <a:avLst/>
+          </a:prstGeom>
+          <a:noFill/>
+        </p:spPr>
+        <p:txBody>
+          <a:bodyPr wrap="square">
+            <a:spAutoFit/>
+          </a:bodyPr>
+          <a:lstStyle/>
+          <a:p>
+            <a:pPr>
+              <a:spcAft>
+                <a:spcPts val="1200"/>
+              </a:spcAft>
+              <a:defRPr sz="2000">
+                <a:solidFill>
+                  <a:srgbClr val="333333"/>
+                </a:solidFill>
+              </a:defRPr>
+            </a:pPr>
+            <a:r>
+              <a:t>Hệ thống học về AI thông qua việc bắt lỗi AI, phủ 22/22 YCCĐ lớp 10 theo QĐ 2422/QĐ-BGDĐT</a:t>
+            </a:r>
+          </a:p>
+        </p:txBody>
+      </p:sp>
+      <p:sp>
+        <p:nvSpPr>
+          <p:cNvPr id="9" name="TextBox 8"/>
+          <p:cNvSpPr txBox="1"/>
+          <p:nvPr/>
+        </p:nvSpPr>
+        <p:spPr>
+          <a:xfrm>
+            <a:off x="457200" y="3474720"/>
+            <a:ext cx="10972800" cy="2560320"/>
+          </a:xfrm>
+          <a:prstGeom prst="rect">
+            <a:avLst/>
+          </a:prstGeom>
+          <a:noFill/>
+        </p:spPr>
+        <p:txBody>
+          <a:bodyPr wrap="square">
+            <a:spAutoFit/>
+          </a:bodyPr>
+          <a:lstStyle/>
+          <a:p/>
+          <a:p>
+            <a:pPr>
+              <a:spcBef>
+                <a:spcPts val="800"/>
+              </a:spcBef>
+              <a:defRPr sz="2000" b="1">
+                <a:solidFill>
+                  <a:srgbClr val="0078D7"/>
+                </a:solidFill>
+              </a:defRPr>
+            </a:pPr>
+            <a:r>
+              <a:t>1. Kịch bản 9 cảnh</a:t>
+            </a:r>
+          </a:p>
+          <a:p>
+            <a:pPr>
+              <a:spcBef>
+                <a:spcPts val="200"/>
+              </a:spcBef>
+              <a:defRPr sz="1600">
+                <a:solidFill>
+                  <a:srgbClr val="333333"/>
+                </a:solidFill>
+              </a:defRPr>
+            </a:pPr>
+            <a:r>
+              <a:t>   Hành trình của bức ảnh từ đầu vào đến đầu ra</a:t>
+            </a:r>
+          </a:p>
+          <a:p>
+            <a:pPr>
+              <a:spcBef>
+                <a:spcPts val="800"/>
+              </a:spcBef>
+              <a:defRPr sz="2000" b="1">
+                <a:solidFill>
+                  <a:srgbClr val="0078D7"/>
+                </a:solidFill>
+              </a:defRPr>
+            </a:pPr>
+            <a:r>
+              <a:t>2. Đấu trường bắt lỗi AI</a:t>
+            </a:r>
+          </a:p>
+          <a:p>
+            <a:pPr>
+              <a:spcBef>
+                <a:spcPts val="200"/>
+              </a:spcBef>
+              <a:defRPr sz="1600">
+                <a:solidFill>
+                  <a:srgbClr val="333333"/>
+                </a:solidFill>
+              </a:defRPr>
+            </a:pPr>
+            <a:r>
+              <a:t>   12 tình huống, 5 loại lỗi AI</a:t>
+            </a:r>
+          </a:p>
+          <a:p>
+            <a:pPr>
+              <a:spcBef>
+                <a:spcPts val="800"/>
+              </a:spcBef>
+              <a:defRPr sz="2000" b="1">
+                <a:solidFill>
+                  <a:srgbClr val="0078D7"/>
+                </a:solidFill>
+              </a:defRPr>
+            </a:pPr>
+            <a:r>
+              <a:t>3. Nhà máy AI 7 trạm</a:t>
+            </a:r>
+          </a:p>
+          <a:p>
+            <a:pPr>
+              <a:spcBef>
+                <a:spcPts val="200"/>
+              </a:spcBef>
+              <a:defRPr sz="1600">
+                <a:solidFill>
+                  <a:srgbClr val="333333"/>
+                </a:solidFill>
+              </a:defRPr>
+            </a:pPr>
+            <a:r>
+              <a:t>   Từ nhập liệu đến ứng dụng</a:t>
+            </a:r>
+          </a:p>
+          <a:p>
+            <a:pPr>
+              <a:spcBef>
+                <a:spcPts val="800"/>
+              </a:spcBef>
+              <a:defRPr sz="2000" b="1">
+                <a:solidFill>
+                  <a:srgbClr val="0078D7"/>
+                </a:solidFill>
+              </a:defRPr>
+            </a:pPr>
+            <a:r>
+              <a:t>4. Tầng 1 - Xưởng huấn luyện</a:t>
+            </a:r>
+          </a:p>
+          <a:p>
+            <a:pPr>
+              <a:spcBef>
+                <a:spcPts val="200"/>
+              </a:spcBef>
+              <a:defRPr sz="1600">
+                <a:solidFill>
+                  <a:srgbClr val="333333"/>
+                </a:solidFill>
+              </a:defRPr>
+            </a:pPr>
+            <a:r>
+              <a:t>   Tự huấn luyện mô hình, thấy thiên kiến</a:t>
+            </a:r>
+          </a:p>
+          <a:p>
+            <a:pPr>
+              <a:spcBef>
+                <a:spcPts val="800"/>
+              </a:spcBef>
+              <a:defRPr sz="2000" b="1">
+                <a:solidFill>
+                  <a:srgbClr val="0078D7"/>
+                </a:solidFill>
+              </a:defRPr>
+            </a:pPr>
+            <a:r>
+              <a:t>5. Bản đồ năng lực</a:t>
+            </a:r>
+          </a:p>
+          <a:p>
+            <a:pPr>
+              <a:spcBef>
+                <a:spcPts val="200"/>
+              </a:spcBef>
+              <a:defRPr sz="1600">
+                <a:solidFill>
+                  <a:srgbClr val="333333"/>
+                </a:solidFill>
+              </a:defRPr>
+            </a:pPr>
+            <a:r>
+              <a:t>   Theo dõi tiến bộ theo 12 khối UNESCO</a:t>
+            </a:r>
+          </a:p>
+        </p:txBody>
+      </p:sp>
+    </p:spTree>
+  </p:cSld>
+  <p:clrMapOvr>
+    <a:masterClrMapping/>
+  </p:clrMapOvr>
+</p:sld>
+</file>
+
+<file path=ppt/slides/slide7.xml><?xml version="1.0" encoding="utf-8"?>
+<p:sld xmlns:a="http://schemas.openxmlformats.org/drawingml/2006/main" xmlns:p="http://schemas.openxmlformats.org/presentationml/2006/main" xmlns:r="http://schemas.openxmlformats.org/officeDocument/2006/relationships">
+  <p:cSld>
+    <p:spTree>
+      <p:nvGrpSpPr>
+        <p:cNvPr id="1" name=""/>
+        <p:cNvGrpSpPr/>
+        <p:nvPr/>
+      </p:nvGrpSpPr>
+      <p:grpSpPr/>
+      <p:sp>
+        <p:nvSpPr>
+          <p:cNvPr id="2" name="Rectangle 1"/>
+          <p:cNvSpPr/>
+          <p:nvPr/>
+        </p:nvSpPr>
+        <p:spPr>
+          <a:xfrm>
+            <a:off x="0" y="0"/>
+            <a:ext cx="12191695" cy="731520"/>
+          </a:xfrm>
+          <a:prstGeom prst="rect">
+            <a:avLst/>
+          </a:prstGeom>
+          <a:solidFill>
+            <a:srgbClr val="0078D7"/>
+          </a:solidFill>
+          <a:ln>
+            <a:noFill/>
+          </a:ln>
+        </p:spPr>
+        <p:style>
+          <a:lnRef idx="1">
+            <a:schemeClr val="accent1"/>
+          </a:lnRef>
+          <a:fillRef idx="3">
+            <a:schemeClr val="accent1"/>
+          </a:fillRef>
+          <a:effectRef idx="2">
+            <a:schemeClr val="accent1"/>
+          </a:effectRef>
+          <a:fontRef idx="minor">
+            <a:schemeClr val="lt1"/>
+          </a:fontRef>
+        </p:style>
+        <p:txBody>
+          <a:bodyPr rtlCol="0" anchor="ctr"/>
+          <a:lstStyle/>
+          <a:p>
+            <a:pPr algn="ctr"/>
+          </a:p>
+        </p:txBody>
+      </p:sp>
+      <p:sp>
+        <p:nvSpPr>
+          <p:cNvPr id="3" name="Oval 2"/>
+          <p:cNvSpPr/>
+          <p:nvPr/>
+        </p:nvSpPr>
+        <p:spPr>
+          <a:xfrm>
+            <a:off x="274320" y="137160"/>
+            <a:ext cx="457200" cy="457200"/>
+          </a:xfrm>
+          <a:prstGeom prst="ellipse">
+            <a:avLst/>
+          </a:prstGeom>
+          <a:solidFill>
+            <a:srgbClr val="F0F0F0"/>
+          </a:solidFill>
+          <a:ln w="25400">
+            <a:solidFill>
+              <a:srgbClr val="C8C8C8"/>
+            </a:solidFill>
+          </a:ln>
+        </p:spPr>
+        <p:style>
+          <a:lnRef idx="1">
+            <a:schemeClr val="accent1"/>
+          </a:lnRef>
+          <a:fillRef idx="3">
+            <a:schemeClr val="accent1"/>
+          </a:fillRef>
+          <a:effectRef idx="2">
+            <a:schemeClr val="accent1"/>
+          </a:effectRef>
+          <a:fontRef idx="minor">
+            <a:schemeClr val="lt1"/>
+          </a:fontRef>
+        </p:style>
+        <p:txBody>
+          <a:bodyPr rtlCol="0" anchor="ctr" wrap="square"/>
+          <a:lstStyle/>
+          <a:p>
+            <a:pPr algn="ctr">
+              <a:defRPr sz="1000" b="1">
+                <a:solidFill>
+                  <a:srgbClr val="C8C8C8"/>
+                </a:solidFill>
+              </a:defRPr>
+            </a:pPr>
+            <a:r>
+              <a:t>ĐHSP</a:t>
+            </a:r>
+          </a:p>
+        </p:txBody>
+      </p:sp>
+      <p:sp>
+        <p:nvSpPr>
+          <p:cNvPr id="4" name="Oval 3"/>
+          <p:cNvSpPr/>
+          <p:nvPr/>
+        </p:nvSpPr>
+        <p:spPr>
+          <a:xfrm>
+            <a:off x="822960" y="137160"/>
+            <a:ext cx="457200" cy="457200"/>
+          </a:xfrm>
+          <a:prstGeom prst="ellipse">
+            <a:avLst/>
+          </a:prstGeom>
+          <a:solidFill>
+            <a:srgbClr val="F0F0F0"/>
+          </a:solidFill>
+          <a:ln w="25400">
+            <a:solidFill>
+              <a:srgbClr val="C8C8C8"/>
+            </a:solidFill>
+          </a:ln>
+        </p:spPr>
+        <p:style>
+          <a:lnRef idx="1">
+            <a:schemeClr val="accent1"/>
+          </a:lnRef>
+          <a:fillRef idx="3">
+            <a:schemeClr val="accent1"/>
+          </a:fillRef>
+          <a:effectRef idx="2">
+            <a:schemeClr val="accent1"/>
+          </a:effectRef>
+          <a:fontRef idx="minor">
+            <a:schemeClr val="lt1"/>
+          </a:fontRef>
+        </p:style>
+        <p:txBody>
+          <a:bodyPr rtlCol="0" anchor="ctr" wrap="square"/>
+          <a:lstStyle/>
+          <a:p>
+            <a:pPr algn="ctr">
+              <a:defRPr sz="1000" b="1">
+                <a:solidFill>
+                  <a:srgbClr val="C8C8C8"/>
+                </a:solidFill>
+              </a:defRPr>
+            </a:pPr>
+            <a:r>
+              <a:t>THPT</a:t>
+            </a:r>
+          </a:p>
+        </p:txBody>
+      </p:sp>
+      <p:sp>
+        <p:nvSpPr>
+          <p:cNvPr id="5" name="TextBox 4"/>
+          <p:cNvSpPr txBox="1"/>
+          <p:nvPr/>
+        </p:nvSpPr>
+        <p:spPr>
+          <a:xfrm>
+            <a:off x="1463040" y="137160"/>
+            <a:ext cx="9144000" cy="457200"/>
+          </a:xfrm>
+          <a:prstGeom prst="rect">
+            <a:avLst/>
+          </a:prstGeom>
+          <a:noFill/>
+        </p:spPr>
+        <p:txBody>
+          <a:bodyPr wrap="none">
+            <a:spAutoFit/>
+          </a:bodyPr>
+          <a:lstStyle/>
+          <a:p>
+            <a:pPr>
+              <a:defRPr sz="1800" b="1">
+                <a:solidFill>
+                  <a:srgbClr val="FFFFFF"/>
+                </a:solidFill>
+              </a:defRPr>
+            </a:pPr>
+            <a:r>
+              <a:t>AInatomy — Phòng thực hành AI</a:t>
+            </a:r>
+          </a:p>
+        </p:txBody>
+      </p:sp>
+      <p:sp>
+        <p:nvSpPr>
+          <p:cNvPr id="6" name="TextBox 5"/>
+          <p:cNvSpPr txBox="1"/>
+          <p:nvPr/>
+        </p:nvSpPr>
+        <p:spPr>
+          <a:xfrm>
+            <a:off x="457200" y="1097280"/>
+            <a:ext cx="10972800" cy="731520"/>
+          </a:xfrm>
+          <a:prstGeom prst="rect">
+            <a:avLst/>
+          </a:prstGeom>
+          <a:noFill/>
+        </p:spPr>
+        <p:txBody>
+          <a:bodyPr wrap="none">
+            <a:spAutoFit/>
+          </a:bodyPr>
+          <a:lstStyle/>
+          <a:p>
+            <a:pPr>
+              <a:defRPr sz="3600" b="1">
+                <a:solidFill>
+                  <a:srgbClr val="333333"/>
+                </a:solidFill>
+              </a:defRPr>
+            </a:pPr>
+            <a:r>
+              <a:t>Tích hợp chương trình Tin học 10</a:t>
+            </a:r>
+          </a:p>
+        </p:txBody>
+      </p:sp>
+      <p:sp>
+        <p:nvSpPr>
+          <p:cNvPr id="7" name="TextBox 6"/>
+          <p:cNvSpPr txBox="1"/>
+          <p:nvPr/>
+        </p:nvSpPr>
+        <p:spPr>
+          <a:xfrm>
+            <a:off x="457200" y="6217920"/>
+            <a:ext cx="10972800" cy="457200"/>
+          </a:xfrm>
+          <a:prstGeom prst="rect">
+            <a:avLst/>
+          </a:prstGeom>
+          <a:noFill/>
+        </p:spPr>
+        <p:txBody>
+          <a:bodyPr wrap="none">
+            <a:spAutoFit/>
+          </a:bodyPr>
+          <a:lstStyle/>
+          <a:p>
+            <a:pPr algn="ctr">
+              <a:defRPr sz="1100">
+                <a:solidFill>
+                  <a:srgbClr val="C8C8C8"/>
+                </a:solidFill>
+              </a:defRPr>
+            </a:pPr>
+            <a:r>
+              <a:t>Trường THPT Thuận Hoá — ĐHSP Huế | GV: Mai Xuân Văn</a:t>
+            </a:r>
+          </a:p>
+        </p:txBody>
+      </p:sp>
+      <p:sp>
+        <p:nvSpPr>
+          <p:cNvPr id="8" name="TextBox 7"/>
+          <p:cNvSpPr txBox="1"/>
+          <p:nvPr/>
+        </p:nvSpPr>
+        <p:spPr>
+          <a:xfrm>
+            <a:off x="457200" y="2011680"/>
+            <a:ext cx="10972800" cy="1097280"/>
+          </a:xfrm>
+          <a:prstGeom prst="rect">
+            <a:avLst/>
+          </a:prstGeom>
+          <a:noFill/>
+        </p:spPr>
+        <p:txBody>
+          <a:bodyPr wrap="square">
+            <a:spAutoFit/>
+          </a:bodyPr>
+          <a:lstStyle/>
+          <a:p/>
+          <a:p>
+            <a:pPr>
+              <a:spcBef>
+                <a:spcPts val="800"/>
+              </a:spcBef>
+            </a:pPr>
+            <a:r>
+              <a:rPr sz="2400" b="1">
+                <a:solidFill>
+                  <a:srgbClr val="27AE60"/>
+                </a:solidFill>
+              </a:rPr>
+              <a:t>28 bài </a:t>
+            </a:r>
+            <a:r>
+              <a:rPr sz="2000">
+                <a:solidFill>
+                  <a:srgbClr val="333333"/>
+                </a:solidFill>
+              </a:rPr>
+              <a:t>trong SGK Tin học 10 được hỗ trợ</a:t>
+            </a:r>
+          </a:p>
+          <a:p>
+            <a:pPr>
+              <a:spcBef>
+                <a:spcPts val="800"/>
+              </a:spcBef>
+            </a:pPr>
+            <a:r>
+              <a:rPr sz="2400" b="1">
+                <a:solidFill>
+                  <a:srgbClr val="27AE60"/>
+                </a:solidFill>
+              </a:rPr>
+              <a:t>22/22 YCCĐ </a:t>
+            </a:r>
+            <a:r>
+              <a:rPr sz="2000">
+                <a:solidFill>
+                  <a:srgbClr val="333333"/>
+                </a:solidFill>
+              </a:rPr>
+              <a:t>lớp 10 theo QĐ 2422 đều được phủ</a:t>
+            </a:r>
+          </a:p>
+          <a:p>
+            <a:pPr>
+              <a:spcBef>
+                <a:spcPts val="800"/>
+              </a:spcBef>
+            </a:pPr>
+            <a:r>
+              <a:rPr sz="2400" b="1">
+                <a:solidFill>
+                  <a:srgbClr val="27AE60"/>
+                </a:solidFill>
+              </a:rPr>
+              <a:t>6 chủ đề </a:t>
+            </a:r>
+            <a:r>
+              <a:rPr sz="2000">
+                <a:solidFill>
+                  <a:srgbClr val="333333"/>
+                </a:solidFill>
+              </a:rPr>
+              <a:t>A-F trong chương trình</a:t>
+            </a:r>
+          </a:p>
+        </p:txBody>
+      </p:sp>
+      <p:sp>
+        <p:nvSpPr>
+          <p:cNvPr id="9" name="TextBox 8"/>
+          <p:cNvSpPr txBox="1"/>
+          <p:nvPr/>
+        </p:nvSpPr>
+        <p:spPr>
+          <a:xfrm>
+            <a:off x="457200" y="3474720"/>
+            <a:ext cx="10972800" cy="2560320"/>
+          </a:xfrm>
+          <a:prstGeom prst="rect">
+            <a:avLst/>
+          </a:prstGeom>
+          <a:noFill/>
+        </p:spPr>
+        <p:txBody>
+          <a:bodyPr wrap="square">
+            <a:spAutoFit/>
+          </a:bodyPr>
+          <a:lstStyle/>
+          <a:p>
+            <a:pPr>
+              <a:spcAft>
+                <a:spcPts val="800"/>
+              </a:spcAft>
+              <a:defRPr sz="2200" b="1">
+                <a:solidFill>
+                  <a:srgbClr val="0078D7"/>
+                </a:solidFill>
+              </a:defRPr>
+            </a:pPr>
+            <a:r>
+              <a:t>Ví dụ: Chủ đề A - Máy tính và xã hội tri thức</a:t>
+            </a:r>
+          </a:p>
+          <a:p>
+            <a:pPr>
+              <a:spcBef>
+                <a:spcPts val="600"/>
+              </a:spcBef>
+              <a:defRPr sz="1600">
+                <a:solidFill>
+                  <a:srgbClr val="333333"/>
+                </a:solidFill>
+              </a:defRPr>
+            </a:pPr>
+            <a:r>
+              <a:t>• Bài 1: Dữ liệu, thông tin → Kịch bản 9 cảnh + Trạm 0 (15-20 phút)</a:t>
+            </a:r>
+          </a:p>
+          <a:p>
+            <a:pPr>
+              <a:spcBef>
+                <a:spcPts val="600"/>
+              </a:spcBef>
+              <a:defRPr sz="1600">
+                <a:solidFill>
+                  <a:srgbClr val="333333"/>
+                </a:solidFill>
+              </a:defRPr>
+            </a:pPr>
+            <a:r>
+              <a:t>• Bài 2: Sự ưu việt của máy tính → Đấu trường bắt lỗi AI (20-25 phút)</a:t>
+            </a:r>
+          </a:p>
+          <a:p>
+            <a:pPr>
+              <a:spcBef>
+                <a:spcPts val="600"/>
+              </a:spcBef>
+              <a:defRPr sz="1600">
+                <a:solidFill>
+                  <a:srgbClr val="333333"/>
+                </a:solidFill>
+              </a:defRPr>
+            </a:pPr>
+            <a:r>
+              <a:t>• Bài 3: Thực hành thiết bị số → Tình huống + Kiến thức (10 phút)</a:t>
+            </a:r>
+          </a:p>
+          <a:p>
+            <a:pPr>
+              <a:spcBef>
+                <a:spcPts val="600"/>
+              </a:spcBef>
+              <a:defRPr sz="1600">
+                <a:solidFill>
+                  <a:srgbClr val="333333"/>
+                </a:solidFill>
+              </a:defRPr>
+            </a:pPr>
+            <a:r>
+              <a:t>• Bài 4: Tin học trong kinh tế, xã hội → Nhà máy AI Trạm 0, 5 (15 phút)</a:t>
+            </a:r>
+          </a:p>
+        </p:txBody>
+      </p:sp>
+    </p:spTree>
+  </p:cSld>
+  <p:clrMapOvr>
+    <a:masterClrMapping/>
+  </p:clrMapOvr>
+</p:sld>
+</file>
+
+<file path=ppt/slides/slide8.xml><?xml version="1.0" encoding="utf-8"?>
+<p:sld xmlns:a="http://schemas.openxmlformats.org/drawingml/2006/main" xmlns:p="http://schemas.openxmlformats.org/presentationml/2006/main" xmlns:r="http://schemas.openxmlformats.org/officeDocument/2006/relationships">
+  <p:cSld>
+    <p:spTree>
+      <p:nvGrpSpPr>
+        <p:cNvPr id="1" name=""/>
+        <p:cNvGrpSpPr/>
+        <p:nvPr/>
+      </p:nvGrpSpPr>
+      <p:grpSpPr/>
+      <p:sp>
+        <p:nvSpPr>
+          <p:cNvPr id="2" name="Rectangle 1"/>
+          <p:cNvSpPr/>
+          <p:nvPr/>
+        </p:nvSpPr>
+        <p:spPr>
+          <a:xfrm>
+            <a:off x="0" y="0"/>
+            <a:ext cx="12191695" cy="731520"/>
+          </a:xfrm>
+          <a:prstGeom prst="rect">
+            <a:avLst/>
+          </a:prstGeom>
+          <a:solidFill>
+            <a:srgbClr val="0078D7"/>
+          </a:solidFill>
+          <a:ln>
+            <a:noFill/>
+          </a:ln>
+        </p:spPr>
+        <p:style>
+          <a:lnRef idx="1">
+            <a:schemeClr val="accent1"/>
+          </a:lnRef>
+          <a:fillRef idx="3">
+            <a:schemeClr val="accent1"/>
+          </a:fillRef>
+          <a:effectRef idx="2">
+            <a:schemeClr val="accent1"/>
+          </a:effectRef>
+          <a:fontRef idx="minor">
+            <a:schemeClr val="lt1"/>
+          </a:fontRef>
+        </p:style>
+        <p:txBody>
+          <a:bodyPr rtlCol="0" anchor="ctr"/>
+          <a:lstStyle/>
+          <a:p>
+            <a:pPr algn="ctr"/>
+          </a:p>
+        </p:txBody>
+      </p:sp>
+      <p:sp>
+        <p:nvSpPr>
+          <p:cNvPr id="3" name="Oval 2"/>
+          <p:cNvSpPr/>
+          <p:nvPr/>
+        </p:nvSpPr>
+        <p:spPr>
+          <a:xfrm>
+            <a:off x="274320" y="137160"/>
+            <a:ext cx="457200" cy="457200"/>
+          </a:xfrm>
+          <a:prstGeom prst="ellipse">
+            <a:avLst/>
+          </a:prstGeom>
+          <a:solidFill>
+            <a:srgbClr val="F0F0F0"/>
+          </a:solidFill>
+          <a:ln w="25400">
+            <a:solidFill>
+              <a:srgbClr val="C8C8C8"/>
+            </a:solidFill>
+          </a:ln>
+        </p:spPr>
+        <p:style>
+          <a:lnRef idx="1">
+            <a:schemeClr val="accent1"/>
+          </a:lnRef>
+          <a:fillRef idx="3">
+            <a:schemeClr val="accent1"/>
+          </a:fillRef>
+          <a:effectRef idx="2">
+            <a:schemeClr val="accent1"/>
+          </a:effectRef>
+          <a:fontRef idx="minor">
+            <a:schemeClr val="lt1"/>
+          </a:fontRef>
+        </p:style>
+        <p:txBody>
+          <a:bodyPr rtlCol="0" anchor="ctr" wrap="square"/>
+          <a:lstStyle/>
+          <a:p>
+            <a:pPr algn="ctr">
+              <a:defRPr sz="1000" b="1">
+                <a:solidFill>
+                  <a:srgbClr val="C8C8C8"/>
+                </a:solidFill>
+              </a:defRPr>
+            </a:pPr>
+            <a:r>
+              <a:t>ĐHSP</a:t>
+            </a:r>
+          </a:p>
+        </p:txBody>
+      </p:sp>
+      <p:sp>
+        <p:nvSpPr>
+          <p:cNvPr id="4" name="Oval 3"/>
+          <p:cNvSpPr/>
+          <p:nvPr/>
+        </p:nvSpPr>
+        <p:spPr>
+          <a:xfrm>
+            <a:off x="822960" y="137160"/>
+            <a:ext cx="457200" cy="457200"/>
+          </a:xfrm>
+          <a:prstGeom prst="ellipse">
+            <a:avLst/>
+          </a:prstGeom>
+          <a:solidFill>
+            <a:srgbClr val="F0F0F0"/>
+          </a:solidFill>
+          <a:ln w="25400">
+            <a:solidFill>
+              <a:srgbClr val="C8C8C8"/>
+            </a:solidFill>
+          </a:ln>
+        </p:spPr>
+        <p:style>
+          <a:lnRef idx="1">
+            <a:schemeClr val="accent1"/>
+          </a:lnRef>
+          <a:fillRef idx="3">
+            <a:schemeClr val="accent1"/>
+          </a:fillRef>
+          <a:effectRef idx="2">
+            <a:schemeClr val="accent1"/>
+          </a:effectRef>
+          <a:fontRef idx="minor">
+            <a:schemeClr val="lt1"/>
+          </a:fontRef>
+        </p:style>
+        <p:txBody>
+          <a:bodyPr rtlCol="0" anchor="ctr" wrap="square"/>
+          <a:lstStyle/>
+          <a:p>
+            <a:pPr algn="ctr">
+              <a:defRPr sz="1000" b="1">
+                <a:solidFill>
+                  <a:srgbClr val="C8C8C8"/>
+                </a:solidFill>
+              </a:defRPr>
+            </a:pPr>
+            <a:r>
+              <a:t>THPT</a:t>
+            </a:r>
+          </a:p>
+        </p:txBody>
+      </p:sp>
+      <p:sp>
+        <p:nvSpPr>
+          <p:cNvPr id="5" name="TextBox 4"/>
+          <p:cNvSpPr txBox="1"/>
+          <p:nvPr/>
+        </p:nvSpPr>
+        <p:spPr>
+          <a:xfrm>
+            <a:off x="1463040" y="137160"/>
+            <a:ext cx="9144000" cy="457200"/>
+          </a:xfrm>
+          <a:prstGeom prst="rect">
+            <a:avLst/>
+          </a:prstGeom>
+          <a:noFill/>
+        </p:spPr>
+        <p:txBody>
+          <a:bodyPr wrap="none">
+            <a:spAutoFit/>
+          </a:bodyPr>
+          <a:lstStyle/>
+          <a:p>
+            <a:pPr>
+              <a:defRPr sz="1800" b="1">
+                <a:solidFill>
+                  <a:srgbClr val="FFFFFF"/>
+                </a:solidFill>
+              </a:defRPr>
+            </a:pPr>
+            <a:r>
+              <a:t>AInatomy — Phòng thực hành AI</a:t>
+            </a:r>
+          </a:p>
+        </p:txBody>
+      </p:sp>
+      <p:sp>
+        <p:nvSpPr>
+          <p:cNvPr id="6" name="TextBox 5"/>
+          <p:cNvSpPr txBox="1"/>
+          <p:nvPr/>
+        </p:nvSpPr>
+        <p:spPr>
+          <a:xfrm>
+            <a:off x="457200" y="1097280"/>
+            <a:ext cx="10972800" cy="731520"/>
+          </a:xfrm>
+          <a:prstGeom prst="rect">
+            <a:avLst/>
+          </a:prstGeom>
+          <a:noFill/>
+        </p:spPr>
+        <p:txBody>
+          <a:bodyPr wrap="none">
+            <a:spAutoFit/>
+          </a:bodyPr>
+          <a:lstStyle/>
+          <a:p>
+            <a:pPr>
+              <a:defRPr sz="3600" b="1">
+                <a:solidFill>
+                  <a:srgbClr val="333333"/>
+                </a:solidFill>
+              </a:defRPr>
+            </a:pPr>
+            <a:r>
+              <a:t>Hướng dẫn sử dụng</a:t>
+            </a:r>
+          </a:p>
+        </p:txBody>
+      </p:sp>
+      <p:sp>
+        <p:nvSpPr>
+          <p:cNvPr id="7" name="TextBox 6"/>
+          <p:cNvSpPr txBox="1"/>
+          <p:nvPr/>
+        </p:nvSpPr>
+        <p:spPr>
+          <a:xfrm>
+            <a:off x="457200" y="6217920"/>
+            <a:ext cx="10972800" cy="457200"/>
+          </a:xfrm>
+          <a:prstGeom prst="rect">
+            <a:avLst/>
+          </a:prstGeom>
+          <a:noFill/>
+        </p:spPr>
+        <p:txBody>
+          <a:bodyPr wrap="none">
+            <a:spAutoFit/>
+          </a:bodyPr>
+          <a:lstStyle/>
+          <a:p>
+            <a:pPr algn="ctr">
+              <a:defRPr sz="1100">
+                <a:solidFill>
+                  <a:srgbClr val="C8C8C8"/>
+                </a:solidFill>
+              </a:defRPr>
+            </a:pPr>
+            <a:r>
+              <a:t>Trường THPT Thuận Hoá — ĐHSP Huế | GV: Mai Xuân Văn</a:t>
+            </a:r>
+          </a:p>
+        </p:txBody>
+      </p:sp>
+      <p:sp>
+        <p:nvSpPr>
+          <p:cNvPr id="8" name="TextBox 7"/>
+          <p:cNvSpPr txBox="1"/>
+          <p:nvPr/>
+        </p:nvSpPr>
+        <p:spPr>
+          <a:xfrm>
+            <a:off x="457200" y="2011680"/>
+            <a:ext cx="5029200" cy="3840480"/>
+          </a:xfrm>
+          <a:prstGeom prst="rect">
+            <a:avLst/>
+          </a:prstGeom>
+          <a:noFill/>
+        </p:spPr>
+        <p:txBody>
+          <a:bodyPr wrap="square">
+            <a:spAutoFit/>
+          </a:bodyPr>
+          <a:lstStyle/>
+          <a:p>
+            <a:pPr>
+              <a:spcAft>
+                <a:spcPts val="1000"/>
+              </a:spcAft>
+              <a:defRPr sz="2400" b="1">
+                <a:solidFill>
+                  <a:srgbClr val="0078D7"/>
+                </a:solidFill>
+              </a:defRPr>
+            </a:pPr>
+            <a:r>
+              <a:t>3 cách chạy</a:t>
+            </a:r>
+          </a:p>
+          <a:p>
+            <a:pPr>
+              <a:spcBef>
+                <a:spcPts val="800"/>
+              </a:spcBef>
+              <a:defRPr sz="1600">
+                <a:solidFill>
+                  <a:srgbClr val="333333"/>
+                </a:solidFill>
+              </a:defRPr>
+            </a:pPr>
+            <a:r>
+              <a:t>• USB: Chép thư mục, mở index.html</a:t>
+            </a:r>
+          </a:p>
+          <a:p>
+            <a:pPr>
+              <a:spcBef>
+                <a:spcPts val="800"/>
+              </a:spcBef>
+              <a:defRPr sz="1600">
+                <a:solidFill>
+                  <a:srgbClr val="333333"/>
+                </a:solidFill>
+              </a:defRPr>
+            </a:pPr>
+            <a:r>
+              <a:t>• Máy chủ lớp: Chia sẻ qua mạng LAN</a:t>
+            </a:r>
+          </a:p>
+          <a:p>
+            <a:pPr>
+              <a:spcBef>
+                <a:spcPts val="800"/>
+              </a:spcBef>
+              <a:defRPr sz="1600">
+                <a:solidFill>
+                  <a:srgbClr val="333333"/>
+                </a:solidFill>
+              </a:defRPr>
+            </a:pPr>
+            <a:r>
+              <a:t>• Máy cá nhân: Mở trực tiếp từ thư mục</a:t>
+            </a:r>
+          </a:p>
+        </p:txBody>
+      </p:sp>
+      <p:sp>
+        <p:nvSpPr>
+          <p:cNvPr id="9" name="TextBox 8"/>
+          <p:cNvSpPr txBox="1"/>
+          <p:nvPr/>
+        </p:nvSpPr>
+        <p:spPr>
+          <a:xfrm>
+            <a:off x="5943600" y="2011680"/>
+            <a:ext cx="5029200" cy="3840480"/>
+          </a:xfrm>
+          <a:prstGeom prst="rect">
+            <a:avLst/>
+          </a:prstGeom>
+          <a:noFill/>
+        </p:spPr>
+        <p:txBody>
+          <a:bodyPr wrap="square">
+            <a:spAutoFit/>
+          </a:bodyPr>
+          <a:lstStyle/>
+          <a:p>
+            <a:pPr>
+              <a:spcAft>
+                <a:spcPts val="1000"/>
+              </a:spcAft>
+              <a:defRPr sz="2400" b="1">
+                <a:solidFill>
+                  <a:srgbClr val="0078D7"/>
+                </a:solidFill>
+              </a:defRPr>
+            </a:pPr>
+            <a:r>
+              <a:t>Yêu cầu</a:t>
+            </a:r>
+          </a:p>
+          <a:p>
+            <a:pPr>
+              <a:spcBef>
+                <a:spcPts val="800"/>
+              </a:spcBef>
+              <a:defRPr sz="1600">
+                <a:solidFill>
+                  <a:srgbClr val="333333"/>
+                </a:solidFill>
+              </a:defRPr>
+            </a:pPr>
+            <a:r>
+              <a:t>✓ Không cần Internet</a:t>
+            </a:r>
+          </a:p>
+          <a:p>
+            <a:pPr>
+              <a:spcBef>
+                <a:spcPts val="800"/>
+              </a:spcBef>
+              <a:defRPr sz="1600">
+                <a:solidFill>
+                  <a:srgbClr val="333333"/>
+                </a:solidFill>
+              </a:defRPr>
+            </a:pPr>
+            <a:r>
+              <a:t>✓ Không cần tài khoản</a:t>
+            </a:r>
+          </a:p>
+          <a:p>
+            <a:pPr>
+              <a:spcBef>
+                <a:spcPts val="800"/>
+              </a:spcBef>
+              <a:defRPr sz="1600">
+                <a:solidFill>
+                  <a:srgbClr val="333333"/>
+                </a:solidFill>
+              </a:defRPr>
+            </a:pPr>
+            <a:r>
+              <a:t>✓ Trình duyệt bất kỳ</a:t>
+            </a:r>
+          </a:p>
+          <a:p>
+            <a:pPr>
+              <a:spcBef>
+                <a:spcPts val="800"/>
+              </a:spcBef>
+              <a:defRPr sz="1600">
+                <a:solidFill>
+                  <a:srgbClr val="333333"/>
+                </a:solidFill>
+              </a:defRPr>
+            </a:pPr>
+            <a:r>
+              <a:t>✓ Máy cấu hình yếu vẫn chạy</a:t>
+            </a:r>
+          </a:p>
+          <a:p>
+            <a:pPr>
+              <a:spcBef>
+                <a:spcPts val="800"/>
+              </a:spcBef>
+              <a:defRPr sz="1600">
+                <a:solidFill>
+                  <a:srgbClr val="333333"/>
+                </a:solidFill>
+              </a:defRPr>
+            </a:pPr>
+            <a:r>
+              <a:t>✓ Dữ liệu lưu cục bộ</a:t>
             </a:r>
           </a:p>
         </p:txBody>

</xml_diff>

<commit_message>
Thêm logo thật từ Wikipedia và template slide báo cáo 7 trang
- Tải logo ĐHSP Huế từ Wikipedia (SVG → PNG 3750x3750)
- Tải logo THPT Thuận Hoá từ website trường (JPG 955x956)
- Tạo template_thuanhoa.pptx với 7 slides: bìa, vấn đề, giải pháp, tích hợp chương trình, kết quả, demo, cảm ơn
- Nghiên cứu workflow: Marp, Slidev, reveal.js, mkdeck
</commit_message>
<xml_diff>
--- a/template_thuanhoa.pptx
+++ b/template_thuanhoa.pptx
@@ -12,7 +12,6 @@
     <p:sldId id="260" r:id="rId11"/>
     <p:sldId id="261" r:id="rId12"/>
     <p:sldId id="262" r:id="rId13"/>
-    <p:sldId id="263" r:id="rId14"/>
   </p:sldIdLst>
   <p:sldSz cx="12191695" cy="6858000" type="screen4x3"/>
   <p:notesSz cx="6858000" cy="9144000"/>
@@ -3104,7 +3103,7 @@
         <p:spPr>
           <a:xfrm>
             <a:off x="0" y="0"/>
-            <a:ext cx="12191695" cy="1097280"/>
+            <a:ext cx="12191695" cy="914400"/>
           </a:xfrm>
           <a:prstGeom prst="rect">
             <a:avLst/>
@@ -3138,124 +3137,54 @@
           </a:p>
         </p:txBody>
       </p:sp>
-      <p:sp>
-        <p:nvSpPr>
-          <p:cNvPr id="3" name="Oval 2"/>
-          <p:cNvSpPr/>
+      <p:pic>
+        <p:nvPicPr>
+          <p:cNvPr id="3" name="Picture 2" descr="logo_dhsp_hue.png"/>
+          <p:cNvPicPr>
+            <a:picLocks noChangeAspect="1"/>
+          </p:cNvPicPr>
           <p:nvPr/>
-        </p:nvSpPr>
-        <p:spPr>
-          <a:xfrm>
-            <a:off x="365760" y="182880"/>
-            <a:ext cx="731520" cy="731520"/>
-          </a:xfrm>
-          <a:prstGeom prst="ellipse">
+        </p:nvPicPr>
+        <p:blipFill>
+          <a:blip r:embed="rId2"/>
+          <a:stretch>
+            <a:fillRect/>
+          </a:stretch>
+        </p:blipFill>
+        <p:spPr>
+          <a:xfrm>
+            <a:off x="274320" y="137160"/>
+            <a:ext cx="640080" cy="640080"/>
+          </a:xfrm>
+          <a:prstGeom prst="rect">
             <a:avLst/>
           </a:prstGeom>
-          <a:solidFill>
-            <a:srgbClr val="F0F0F0"/>
-          </a:solidFill>
-          <a:ln w="25400">
-            <a:solidFill>
-              <a:srgbClr val="C8C8C8"/>
-            </a:solidFill>
-          </a:ln>
-        </p:spPr>
-        <p:style>
-          <a:lnRef idx="1">
-            <a:schemeClr val="accent1"/>
-          </a:lnRef>
-          <a:fillRef idx="3">
-            <a:schemeClr val="accent1"/>
-          </a:fillRef>
-          <a:effectRef idx="2">
-            <a:schemeClr val="accent1"/>
-          </a:effectRef>
-          <a:fontRef idx="minor">
-            <a:schemeClr val="lt1"/>
-          </a:fontRef>
-        </p:style>
-        <p:txBody>
-          <a:bodyPr rtlCol="0" anchor="ctr" wrap="square"/>
-          <a:lstStyle/>
-          <a:p>
-            <a:pPr algn="ctr">
-              <a:defRPr sz="1000" b="1">
-                <a:solidFill>
-                  <a:srgbClr val="C8C8C8"/>
-                </a:solidFill>
-              </a:defRPr>
-            </a:pPr>
-            <a:r>
-              <a:t>LOGO</a:t>
-            </a:r>
-          </a:p>
-          <a:p>
-            <a:r>
-              <a:t>ĐHSP</a:t>
-            </a:r>
-          </a:p>
-        </p:txBody>
-      </p:sp>
-      <p:sp>
-        <p:nvSpPr>
-          <p:cNvPr id="4" name="Oval 3"/>
-          <p:cNvSpPr/>
+        </p:spPr>
+      </p:pic>
+      <p:pic>
+        <p:nvPicPr>
+          <p:cNvPr id="4" name="Picture 3" descr="logo_thpt_thuan_hoa.jpg"/>
+          <p:cNvPicPr>
+            <a:picLocks noChangeAspect="1"/>
+          </p:cNvPicPr>
           <p:nvPr/>
-        </p:nvSpPr>
-        <p:spPr>
-          <a:xfrm>
-            <a:off x="1280160" y="182880"/>
-            <a:ext cx="731520" cy="731520"/>
-          </a:xfrm>
-          <a:prstGeom prst="ellipse">
+        </p:nvPicPr>
+        <p:blipFill>
+          <a:blip r:embed="rId3"/>
+          <a:stretch>
+            <a:fillRect/>
+          </a:stretch>
+        </p:blipFill>
+        <p:spPr>
+          <a:xfrm>
+            <a:off x="1051560" y="137160"/>
+            <a:ext cx="640080" cy="640080"/>
+          </a:xfrm>
+          <a:prstGeom prst="rect">
             <a:avLst/>
           </a:prstGeom>
-          <a:solidFill>
-            <a:srgbClr val="F0F0F0"/>
-          </a:solidFill>
-          <a:ln w="25400">
-            <a:solidFill>
-              <a:srgbClr val="C8C8C8"/>
-            </a:solidFill>
-          </a:ln>
-        </p:spPr>
-        <p:style>
-          <a:lnRef idx="1">
-            <a:schemeClr val="accent1"/>
-          </a:lnRef>
-          <a:fillRef idx="3">
-            <a:schemeClr val="accent1"/>
-          </a:fillRef>
-          <a:effectRef idx="2">
-            <a:schemeClr val="accent1"/>
-          </a:effectRef>
-          <a:fontRef idx="minor">
-            <a:schemeClr val="lt1"/>
-          </a:fontRef>
-        </p:style>
-        <p:txBody>
-          <a:bodyPr rtlCol="0" anchor="ctr" wrap="square"/>
-          <a:lstStyle/>
-          <a:p>
-            <a:pPr algn="ctr">
-              <a:defRPr sz="1000" b="1">
-                <a:solidFill>
-                  <a:srgbClr val="C8C8C8"/>
-                </a:solidFill>
-              </a:defRPr>
-            </a:pPr>
-            <a:r>
-              <a:t>LOGO</a:t>
-            </a:r>
-          </a:p>
-          <a:p>
-            <a:r>
-              <a:t>THPT</a:t>
-            </a:r>
-          </a:p>
-        </p:txBody>
-      </p:sp>
+        </p:spPr>
+      </p:pic>
       <p:sp>
         <p:nvSpPr>
           <p:cNvPr id="5" name="TextBox 4"/>
@@ -3264,8 +3193,8 @@
         </p:nvSpPr>
         <p:spPr>
           <a:xfrm>
-            <a:off x="1371600" y="2286000"/>
-            <a:ext cx="9144000" cy="1828800"/>
+            <a:off x="2011680" y="137160"/>
+            <a:ext cx="9144000" cy="457200"/>
           </a:xfrm>
           <a:prstGeom prst="rect">
             <a:avLst/>
@@ -3273,20 +3202,20 @@
           <a:noFill/>
         </p:spPr>
         <p:txBody>
-          <a:bodyPr wrap="square">
+          <a:bodyPr wrap="none">
             <a:spAutoFit/>
           </a:bodyPr>
           <a:lstStyle/>
           <a:p>
-            <a:pPr algn="ctr">
-              <a:defRPr sz="6000" b="1">
-                <a:solidFill>
-                  <a:srgbClr val="333333"/>
+            <a:pPr>
+              <a:defRPr sz="2000" b="1">
+                <a:solidFill>
+                  <a:srgbClr val="FFFFFF"/>
                 </a:solidFill>
               </a:defRPr>
             </a:pPr>
             <a:r>
-              <a:t>AInatomy</a:t>
+              <a:t>AInatomy — Phòng thực hành AI</a:t>
             </a:r>
           </a:p>
         </p:txBody>
@@ -3299,8 +3228,8 @@
         </p:nvSpPr>
         <p:spPr>
           <a:xfrm>
-            <a:off x="1371600" y="4114800"/>
-            <a:ext cx="9144000" cy="914400"/>
+            <a:off x="1371600" y="2286000"/>
+            <a:ext cx="9144000" cy="1371600"/>
           </a:xfrm>
           <a:prstGeom prst="rect">
             <a:avLst/>
@@ -3308,20 +3237,20 @@
           <a:noFill/>
         </p:spPr>
         <p:txBody>
-          <a:bodyPr wrap="square">
+          <a:bodyPr wrap="none">
             <a:spAutoFit/>
           </a:bodyPr>
           <a:lstStyle/>
           <a:p>
             <a:pPr algn="ctr">
-              <a:defRPr sz="2800">
+              <a:defRPr sz="5600" b="1">
                 <a:solidFill>
                   <a:srgbClr val="333333"/>
                 </a:solidFill>
               </a:defRPr>
             </a:pPr>
             <a:r>
-              <a:t>Phòng thực hành Trí tuệ nhân tạo</a:t>
+              <a:t>AInatomy</a:t>
             </a:r>
           </a:p>
         </p:txBody>
@@ -3334,8 +3263,8 @@
         </p:nvSpPr>
         <p:spPr>
           <a:xfrm>
-            <a:off x="457200" y="5943600"/>
-            <a:ext cx="10972800" cy="731520"/>
+            <a:off x="1371600" y="3657600"/>
+            <a:ext cx="9144000" cy="914400"/>
           </a:xfrm>
           <a:prstGeom prst="rect">
             <a:avLst/>
@@ -3343,7 +3272,42 @@
           <a:noFill/>
         </p:spPr>
         <p:txBody>
-          <a:bodyPr wrap="square">
+          <a:bodyPr wrap="none">
+            <a:spAutoFit/>
+          </a:bodyPr>
+          <a:lstStyle/>
+          <a:p>
+            <a:pPr algn="ctr">
+              <a:defRPr sz="2400">
+                <a:solidFill>
+                  <a:srgbClr val="333333"/>
+                </a:solidFill>
+              </a:defRPr>
+            </a:pPr>
+            <a:r>
+              <a:t>Phòng thực hành Trí tuệ nhân tạo — Báo cáo cuộc thi</a:t>
+            </a:r>
+          </a:p>
+        </p:txBody>
+      </p:sp>
+      <p:sp>
+        <p:nvSpPr>
+          <p:cNvPr id="8" name="TextBox 7"/>
+          <p:cNvSpPr txBox="1"/>
+          <p:nvPr/>
+        </p:nvSpPr>
+        <p:spPr>
+          <a:xfrm>
+            <a:off x="457200" y="5303520"/>
+            <a:ext cx="10972800" cy="914400"/>
+          </a:xfrm>
+          <a:prstGeom prst="rect">
+            <a:avLst/>
+          </a:prstGeom>
+          <a:noFill/>
+        </p:spPr>
+        <p:txBody>
+          <a:bodyPr wrap="none">
             <a:spAutoFit/>
           </a:bodyPr>
           <a:lstStyle/>
@@ -3426,114 +3390,54 @@
           </a:p>
         </p:txBody>
       </p:sp>
-      <p:sp>
-        <p:nvSpPr>
-          <p:cNvPr id="3" name="Oval 2"/>
-          <p:cNvSpPr/>
+      <p:pic>
+        <p:nvPicPr>
+          <p:cNvPr id="3" name="Picture 2" descr="logo_dhsp_hue.png"/>
+          <p:cNvPicPr>
+            <a:picLocks noChangeAspect="1"/>
+          </p:cNvPicPr>
           <p:nvPr/>
-        </p:nvSpPr>
+        </p:nvPicPr>
+        <p:blipFill>
+          <a:blip r:embed="rId2"/>
+          <a:stretch>
+            <a:fillRect/>
+          </a:stretch>
+        </p:blipFill>
         <p:spPr>
           <a:xfrm>
             <a:off x="274320" y="137160"/>
             <a:ext cx="457200" cy="457200"/>
           </a:xfrm>
-          <a:prstGeom prst="ellipse">
+          <a:prstGeom prst="rect">
             <a:avLst/>
           </a:prstGeom>
-          <a:solidFill>
-            <a:srgbClr val="F0F0F0"/>
-          </a:solidFill>
-          <a:ln w="25400">
-            <a:solidFill>
-              <a:srgbClr val="C8C8C8"/>
-            </a:solidFill>
-          </a:ln>
-        </p:spPr>
-        <p:style>
-          <a:lnRef idx="1">
-            <a:schemeClr val="accent1"/>
-          </a:lnRef>
-          <a:fillRef idx="3">
-            <a:schemeClr val="accent1"/>
-          </a:fillRef>
-          <a:effectRef idx="2">
-            <a:schemeClr val="accent1"/>
-          </a:effectRef>
-          <a:fontRef idx="minor">
-            <a:schemeClr val="lt1"/>
-          </a:fontRef>
-        </p:style>
-        <p:txBody>
-          <a:bodyPr rtlCol="0" anchor="ctr" wrap="square"/>
-          <a:lstStyle/>
-          <a:p>
-            <a:pPr algn="ctr">
-              <a:defRPr sz="1000" b="1">
-                <a:solidFill>
-                  <a:srgbClr val="C8C8C8"/>
-                </a:solidFill>
-              </a:defRPr>
-            </a:pPr>
-            <a:r>
-              <a:t>ĐHSP</a:t>
-            </a:r>
-          </a:p>
-        </p:txBody>
-      </p:sp>
-      <p:sp>
-        <p:nvSpPr>
-          <p:cNvPr id="4" name="Oval 3"/>
-          <p:cNvSpPr/>
+        </p:spPr>
+      </p:pic>
+      <p:pic>
+        <p:nvPicPr>
+          <p:cNvPr id="4" name="Picture 3" descr="logo_thpt_thuan_hoa.jpg"/>
+          <p:cNvPicPr>
+            <a:picLocks noChangeAspect="1"/>
+          </p:cNvPicPr>
           <p:nvPr/>
-        </p:nvSpPr>
-        <p:spPr>
-          <a:xfrm>
-            <a:off x="822960" y="137160"/>
+        </p:nvPicPr>
+        <p:blipFill>
+          <a:blip r:embed="rId3"/>
+          <a:stretch>
+            <a:fillRect/>
+          </a:stretch>
+        </p:blipFill>
+        <p:spPr>
+          <a:xfrm>
+            <a:off x="868680" y="137160"/>
             <a:ext cx="457200" cy="457200"/>
           </a:xfrm>
-          <a:prstGeom prst="ellipse">
+          <a:prstGeom prst="rect">
             <a:avLst/>
           </a:prstGeom>
-          <a:solidFill>
-            <a:srgbClr val="F0F0F0"/>
-          </a:solidFill>
-          <a:ln w="25400">
-            <a:solidFill>
-              <a:srgbClr val="C8C8C8"/>
-            </a:solidFill>
-          </a:ln>
-        </p:spPr>
-        <p:style>
-          <a:lnRef idx="1">
-            <a:schemeClr val="accent1"/>
-          </a:lnRef>
-          <a:fillRef idx="3">
-            <a:schemeClr val="accent1"/>
-          </a:fillRef>
-          <a:effectRef idx="2">
-            <a:schemeClr val="accent1"/>
-          </a:effectRef>
-          <a:fontRef idx="minor">
-            <a:schemeClr val="lt1"/>
-          </a:fontRef>
-        </p:style>
-        <p:txBody>
-          <a:bodyPr rtlCol="0" anchor="ctr" wrap="square"/>
-          <a:lstStyle/>
-          <a:p>
-            <a:pPr algn="ctr">
-              <a:defRPr sz="1000" b="1">
-                <a:solidFill>
-                  <a:srgbClr val="C8C8C8"/>
-                </a:solidFill>
-              </a:defRPr>
-            </a:pPr>
-            <a:r>
-              <a:t>THPT</a:t>
-            </a:r>
-          </a:p>
-        </p:txBody>
-      </p:sp>
+        </p:spPr>
+      </p:pic>
       <p:sp>
         <p:nvSpPr>
           <p:cNvPr id="5" name="TextBox 4"/>
@@ -3542,7 +3446,7 @@
         </p:nvSpPr>
         <p:spPr>
           <a:xfrm>
-            <a:off x="1463040" y="137160"/>
+            <a:off x="2011680" y="137160"/>
             <a:ext cx="9144000" cy="457200"/>
           </a:xfrm>
           <a:prstGeom prst="rect">
@@ -3557,7 +3461,7 @@
           <a:lstStyle/>
           <a:p>
             <a:pPr>
-              <a:defRPr sz="1800" b="1">
+              <a:defRPr sz="1600" b="1">
                 <a:solidFill>
                   <a:srgbClr val="FFFFFF"/>
                 </a:solidFill>
@@ -3577,8 +3481,8 @@
         </p:nvSpPr>
         <p:spPr>
           <a:xfrm>
-            <a:off x="457200" y="1097280"/>
-            <a:ext cx="10972800" cy="731520"/>
+            <a:off x="457200" y="1005840"/>
+            <a:ext cx="10972800" cy="640080"/>
           </a:xfrm>
           <a:prstGeom prst="rect">
             <a:avLst/>
@@ -3592,14 +3496,14 @@
           <a:lstStyle/>
           <a:p>
             <a:pPr>
-              <a:defRPr sz="3600" b="1">
+              <a:defRPr sz="3200" b="1">
                 <a:solidFill>
                   <a:srgbClr val="333333"/>
                 </a:solidFill>
               </a:defRPr>
             </a:pPr>
             <a:r>
-              <a:t>Giới thiệu về hệ thống</a:t>
+              <a:t>Vấn đề</a:t>
             </a:r>
           </a:p>
         </p:txBody>
@@ -3612,8 +3516,8 @@
         </p:nvSpPr>
         <p:spPr>
           <a:xfrm>
-            <a:off x="457200" y="2011680"/>
-            <a:ext cx="10972800" cy="3657600"/>
+            <a:off x="457200" y="6309360"/>
+            <a:ext cx="10972800" cy="365760"/>
           </a:xfrm>
           <a:prstGeom prst="rect">
             <a:avLst/>
@@ -3621,83 +3525,20 @@
           <a:noFill/>
         </p:spPr>
         <p:txBody>
-          <a:bodyPr wrap="square">
+          <a:bodyPr wrap="none">
             <a:spAutoFit/>
           </a:bodyPr>
           <a:lstStyle/>
           <a:p>
-            <a:pPr>
-              <a:spcBef>
-                <a:spcPts val="1200"/>
-              </a:spcBef>
-              <a:defRPr sz="2000">
-                <a:solidFill>
-                  <a:srgbClr val="333333"/>
+            <a:pPr algn="ctr">
+              <a:defRPr sz="1100">
+                <a:solidFill>
+                  <a:srgbClr val="C8C8C8"/>
                 </a:solidFill>
               </a:defRPr>
             </a:pPr>
             <a:r>
-              <a:t>Phòng thí nghiệm AI offline, tiếng Việt</a:t>
-            </a:r>
-          </a:p>
-          <a:p>
-            <a:pPr>
-              <a:spcBef>
-                <a:spcPts val="1200"/>
-              </a:spcBef>
-              <a:defRPr sz="2000">
-                <a:solidFill>
-                  <a:srgbClr val="333333"/>
-                </a:solidFill>
-              </a:defRPr>
-            </a:pPr>
-            <a:r>
-              <a:t>Không cần tài khoản, không thu phí</a:t>
-            </a:r>
-          </a:p>
-          <a:p>
-            <a:pPr>
-              <a:spcBef>
-                <a:spcPts val="1200"/>
-              </a:spcBef>
-              <a:defRPr sz="2000">
-                <a:solidFill>
-                  <a:srgbClr val="333333"/>
-                </a:solidFill>
-              </a:defRPr>
-            </a:pPr>
-            <a:r>
-              <a:t>Bám sát QĐ 2422/QĐ-BGDĐT</a:t>
-            </a:r>
-          </a:p>
-          <a:p>
-            <a:pPr>
-              <a:spcBef>
-                <a:spcPts val="1200"/>
-              </a:spcBef>
-              <a:defRPr sz="2000">
-                <a:solidFill>
-                  <a:srgbClr val="333333"/>
-                </a:solidFill>
-              </a:defRPr>
-            </a:pPr>
-            <a:r>
-              <a:t>Phủ 22/22 YCCĐ lớp 10</a:t>
-            </a:r>
-          </a:p>
-          <a:p>
-            <a:pPr>
-              <a:spcBef>
-                <a:spcPts val="1200"/>
-              </a:spcBef>
-              <a:defRPr sz="2000">
-                <a:solidFill>
-                  <a:srgbClr val="333333"/>
-                </a:solidFill>
-              </a:defRPr>
-            </a:pPr>
-            <a:r>
-              <a:t>Học sinh bắt lỗi AI thay vì hỏi AI</a:t>
+              <a:t>Trường THPT Thuận Hoá — ĐHSP Huế | GV: Mai Xuân Văn</a:t>
             </a:r>
           </a:p>
         </p:txBody>
@@ -3710,8 +3551,8 @@
         </p:nvSpPr>
         <p:spPr>
           <a:xfrm>
-            <a:off x="457200" y="6217920"/>
-            <a:ext cx="10972800" cy="457200"/>
+            <a:off x="457200" y="1828800"/>
+            <a:ext cx="10972800" cy="4114800"/>
           </a:xfrm>
           <a:prstGeom prst="rect">
             <a:avLst/>
@@ -3719,20 +3560,68 @@
           <a:noFill/>
         </p:spPr>
         <p:txBody>
-          <a:bodyPr wrap="none">
+          <a:bodyPr wrap="square">
             <a:spAutoFit/>
           </a:bodyPr>
           <a:lstStyle/>
           <a:p>
-            <a:pPr algn="ctr">
-              <a:defRPr sz="1100">
-                <a:solidFill>
-                  <a:srgbClr val="C8C8C8"/>
+            <a:pPr>
+              <a:spcBef>
+                <a:spcPts val="1000"/>
+              </a:spcBef>
+              <a:defRPr sz="2200">
+                <a:solidFill>
+                  <a:srgbClr val="333333"/>
                 </a:solidFill>
               </a:defRPr>
             </a:pPr>
             <a:r>
-              <a:t>Trường THPT Thuận Hoá — ĐHSP Huế | GV: Mai Xuân Văn</a:t>
+              <a:t>• Học sinh học AI thụ động: hỏi → nhận đáp án → không hiểu</a:t>
+            </a:r>
+          </a:p>
+          <a:p>
+            <a:pPr>
+              <a:spcBef>
+                <a:spcPts val="1000"/>
+              </a:spcBef>
+              <a:defRPr sz="2200">
+                <a:solidFill>
+                  <a:srgbClr val="333333"/>
+                </a:solidFill>
+              </a:defRPr>
+            </a:pPr>
+            <a:r>
+              <a:t>• Công cụ AI thương mại (ChatGPT, Gemini) cần internet + tài khoản</a:t>
+            </a:r>
+          </a:p>
+          <a:p>
+            <a:pPr>
+              <a:spcBef>
+                <a:spcPts val="1000"/>
+              </a:spcBef>
+              <a:defRPr sz="2200">
+                <a:solidFill>
+                  <a:srgbClr val="333333"/>
+                </a:solidFill>
+              </a:defRPr>
+            </a:pPr>
+            <a:r>
+              <a:t>• Giáo viên thiếu công cụ trực quan để dạy khái niệm AI</a:t>
+            </a:r>
+          </a:p>
+          <a:p>
+            <a:pPr>
+              <a:spcBef>
+                <a:spcPts val="1000"/>
+              </a:spcBef>
+              <a:defRPr sz="2200">
+                <a:solidFill>
+                  <a:srgbClr val="333333"/>
+                </a:solidFill>
+              </a:defRPr>
+            </a:pPr>
+            <a:r>
+              <a:t>• Chương trình QĐ 2422/QĐ-BGDĐT yêu cầu 22 YCCĐ lớp 10 — chưa có công cụ offline phủ đủ</a:t>
             </a:r>
           </a:p>
         </p:txBody>
@@ -3798,114 +3687,54 @@
           </a:p>
         </p:txBody>
       </p:sp>
-      <p:sp>
-        <p:nvSpPr>
-          <p:cNvPr id="3" name="Oval 2"/>
-          <p:cNvSpPr/>
+      <p:pic>
+        <p:nvPicPr>
+          <p:cNvPr id="3" name="Picture 2" descr="logo_dhsp_hue.png"/>
+          <p:cNvPicPr>
+            <a:picLocks noChangeAspect="1"/>
+          </p:cNvPicPr>
           <p:nvPr/>
-        </p:nvSpPr>
+        </p:nvPicPr>
+        <p:blipFill>
+          <a:blip r:embed="rId2"/>
+          <a:stretch>
+            <a:fillRect/>
+          </a:stretch>
+        </p:blipFill>
         <p:spPr>
           <a:xfrm>
             <a:off x="274320" y="137160"/>
             <a:ext cx="457200" cy="457200"/>
           </a:xfrm>
-          <a:prstGeom prst="ellipse">
+          <a:prstGeom prst="rect">
             <a:avLst/>
           </a:prstGeom>
-          <a:solidFill>
-            <a:srgbClr val="F0F0F0"/>
-          </a:solidFill>
-          <a:ln w="25400">
-            <a:solidFill>
-              <a:srgbClr val="C8C8C8"/>
-            </a:solidFill>
-          </a:ln>
-        </p:spPr>
-        <p:style>
-          <a:lnRef idx="1">
-            <a:schemeClr val="accent1"/>
-          </a:lnRef>
-          <a:fillRef idx="3">
-            <a:schemeClr val="accent1"/>
-          </a:fillRef>
-          <a:effectRef idx="2">
-            <a:schemeClr val="accent1"/>
-          </a:effectRef>
-          <a:fontRef idx="minor">
-            <a:schemeClr val="lt1"/>
-          </a:fontRef>
-        </p:style>
-        <p:txBody>
-          <a:bodyPr rtlCol="0" anchor="ctr" wrap="square"/>
-          <a:lstStyle/>
-          <a:p>
-            <a:pPr algn="ctr">
-              <a:defRPr sz="1000" b="1">
-                <a:solidFill>
-                  <a:srgbClr val="C8C8C8"/>
-                </a:solidFill>
-              </a:defRPr>
-            </a:pPr>
-            <a:r>
-              <a:t>ĐHSP</a:t>
-            </a:r>
-          </a:p>
-        </p:txBody>
-      </p:sp>
-      <p:sp>
-        <p:nvSpPr>
-          <p:cNvPr id="4" name="Oval 3"/>
-          <p:cNvSpPr/>
+        </p:spPr>
+      </p:pic>
+      <p:pic>
+        <p:nvPicPr>
+          <p:cNvPr id="4" name="Picture 3" descr="logo_thpt_thuan_hoa.jpg"/>
+          <p:cNvPicPr>
+            <a:picLocks noChangeAspect="1"/>
+          </p:cNvPicPr>
           <p:nvPr/>
-        </p:nvSpPr>
-        <p:spPr>
-          <a:xfrm>
-            <a:off x="822960" y="137160"/>
+        </p:nvPicPr>
+        <p:blipFill>
+          <a:blip r:embed="rId3"/>
+          <a:stretch>
+            <a:fillRect/>
+          </a:stretch>
+        </p:blipFill>
+        <p:spPr>
+          <a:xfrm>
+            <a:off x="868680" y="137160"/>
             <a:ext cx="457200" cy="457200"/>
           </a:xfrm>
-          <a:prstGeom prst="ellipse">
+          <a:prstGeom prst="rect">
             <a:avLst/>
           </a:prstGeom>
-          <a:solidFill>
-            <a:srgbClr val="F0F0F0"/>
-          </a:solidFill>
-          <a:ln w="25400">
-            <a:solidFill>
-              <a:srgbClr val="C8C8C8"/>
-            </a:solidFill>
-          </a:ln>
-        </p:spPr>
-        <p:style>
-          <a:lnRef idx="1">
-            <a:schemeClr val="accent1"/>
-          </a:lnRef>
-          <a:fillRef idx="3">
-            <a:schemeClr val="accent1"/>
-          </a:fillRef>
-          <a:effectRef idx="2">
-            <a:schemeClr val="accent1"/>
-          </a:effectRef>
-          <a:fontRef idx="minor">
-            <a:schemeClr val="lt1"/>
-          </a:fontRef>
-        </p:style>
-        <p:txBody>
-          <a:bodyPr rtlCol="0" anchor="ctr" wrap="square"/>
-          <a:lstStyle/>
-          <a:p>
-            <a:pPr algn="ctr">
-              <a:defRPr sz="1000" b="1">
-                <a:solidFill>
-                  <a:srgbClr val="C8C8C8"/>
-                </a:solidFill>
-              </a:defRPr>
-            </a:pPr>
-            <a:r>
-              <a:t>THPT</a:t>
-            </a:r>
-          </a:p>
-        </p:txBody>
-      </p:sp>
+        </p:spPr>
+      </p:pic>
       <p:sp>
         <p:nvSpPr>
           <p:cNvPr id="5" name="TextBox 4"/>
@@ -3914,7 +3743,7 @@
         </p:nvSpPr>
         <p:spPr>
           <a:xfrm>
-            <a:off x="1463040" y="137160"/>
+            <a:off x="2011680" y="137160"/>
             <a:ext cx="9144000" cy="457200"/>
           </a:xfrm>
           <a:prstGeom prst="rect">
@@ -3929,7 +3758,7 @@
           <a:lstStyle/>
           <a:p>
             <a:pPr>
-              <a:defRPr sz="1800" b="1">
+              <a:defRPr sz="1600" b="1">
                 <a:solidFill>
                   <a:srgbClr val="FFFFFF"/>
                 </a:solidFill>
@@ -3949,8 +3778,8 @@
         </p:nvSpPr>
         <p:spPr>
           <a:xfrm>
-            <a:off x="457200" y="1097280"/>
-            <a:ext cx="10972800" cy="731520"/>
+            <a:off x="457200" y="1005840"/>
+            <a:ext cx="10972800" cy="640080"/>
           </a:xfrm>
           <a:prstGeom prst="rect">
             <a:avLst/>
@@ -3964,14 +3793,14 @@
           <a:lstStyle/>
           <a:p>
             <a:pPr>
-              <a:defRPr sz="3600" b="1">
+              <a:defRPr sz="3200" b="1">
                 <a:solidFill>
                   <a:srgbClr val="333333"/>
                 </a:solidFill>
               </a:defRPr>
             </a:pPr>
             <a:r>
-              <a:t>Mục lục</a:t>
+              <a:t>Giải pháp: AInatomy</a:t>
             </a:r>
           </a:p>
         </p:txBody>
@@ -3984,8 +3813,8 @@
         </p:nvSpPr>
         <p:spPr>
           <a:xfrm>
-            <a:off x="457200" y="6217920"/>
-            <a:ext cx="10972800" cy="457200"/>
+            <a:off x="457200" y="6309360"/>
+            <a:ext cx="10972800" cy="365760"/>
           </a:xfrm>
           <a:prstGeom prst="rect">
             <a:avLst/>
@@ -4019,7 +3848,7 @@
         </p:nvSpPr>
         <p:spPr>
           <a:xfrm>
-            <a:off x="457200" y="2011680"/>
+            <a:off x="457200" y="1828800"/>
             <a:ext cx="10972800" cy="4114800"/>
           </a:xfrm>
           <a:prstGeom prst="rect">
@@ -4035,91 +3864,118 @@
           <a:p>
             <a:pPr>
               <a:spcBef>
-                <a:spcPts val="1600"/>
+                <a:spcPts val="1000"/>
               </a:spcBef>
-              <a:defRPr sz="2400">
+              <a:defRPr sz="1800">
                 <a:solidFill>
                   <a:srgbClr val="333333"/>
                 </a:solidFill>
               </a:defRPr>
             </a:pPr>
             <a:r>
-              <a:t>1. Giới thiệu về AInatomy</a:t>
+              <a:t>Phòng thí nghiệm AI offline, tiếng Việt, không tài khoản</a:t>
             </a:r>
           </a:p>
           <a:p>
             <a:pPr>
               <a:spcBef>
-                <a:spcPts val="1600"/>
+                <a:spcPts val="1000"/>
               </a:spcBef>
-              <a:defRPr sz="2400">
+              <a:defRPr sz="1800">
                 <a:solidFill>
                   <a:srgbClr val="333333"/>
                 </a:solidFill>
               </a:defRPr>
             </a:pPr>
-            <a:r>
-              <a:t>2. Cấu trúc chương trình Tin học 10</a:t>
-            </a:r>
           </a:p>
           <a:p>
             <a:pPr>
               <a:spcBef>
-                <a:spcPts val="1600"/>
+                <a:spcPts val="1000"/>
               </a:spcBef>
-              <a:defRPr sz="2400">
+              <a:defRPr sz="1800">
                 <a:solidFill>
                   <a:srgbClr val="333333"/>
                 </a:solidFill>
               </a:defRPr>
             </a:pPr>
             <a:r>
-              <a:t>3. Tích hợp vào các chủ đề A-F</a:t>
+              <a:t>5 phân hệ chính:</a:t>
             </a:r>
           </a:p>
           <a:p>
             <a:pPr>
               <a:spcBef>
-                <a:spcPts val="1600"/>
+                <a:spcPts val="1000"/>
               </a:spcBef>
-              <a:defRPr sz="2400">
+              <a:defRPr sz="1800">
                 <a:solidFill>
                   <a:srgbClr val="333333"/>
                 </a:solidFill>
               </a:defRPr>
             </a:pPr>
             <a:r>
-              <a:t>4. Phân phối 12 tiết đề xuất</a:t>
+              <a:t>  1. Kịch bản 9 cảnh — hành trình dữ liệu từ đầu vào đến đầu ra</a:t>
             </a:r>
           </a:p>
           <a:p>
             <a:pPr>
               <a:spcBef>
-                <a:spcPts val="1600"/>
+                <a:spcPts val="1000"/>
               </a:spcBef>
-              <a:defRPr sz="2400">
+              <a:defRPr sz="1800">
                 <a:solidFill>
                   <a:srgbClr val="333333"/>
                 </a:solidFill>
               </a:defRPr>
             </a:pPr>
             <a:r>
-              <a:t>5. Hướng dẫn sử dụng</a:t>
+              <a:t>  2. Đấu trường bắt lỗi AI — 12 tình huống, 5 loại lỗi</a:t>
             </a:r>
           </a:p>
           <a:p>
             <a:pPr>
               <a:spcBef>
-                <a:spcPts val="1600"/>
+                <a:spcPts val="1000"/>
               </a:spcBef>
-              <a:defRPr sz="2400">
+              <a:defRPr sz="1800">
                 <a:solidFill>
                   <a:srgbClr val="333333"/>
                 </a:solidFill>
               </a:defRPr>
             </a:pPr>
             <a:r>
-              <a:t>6. Tài liệu tham khảo</a:t>
+              <a:t>  3. Nhà máy AI 7 trạm — từ nhập liệu đến ứng dụng</a:t>
+            </a:r>
+          </a:p>
+          <a:p>
+            <a:pPr>
+              <a:spcBef>
+                <a:spcPts val="1000"/>
+              </a:spcBef>
+              <a:defRPr sz="1800">
+                <a:solidFill>
+                  <a:srgbClr val="333333"/>
+                </a:solidFill>
+              </a:defRPr>
+            </a:pPr>
+            <a:r>
+              <a:t>  4. Xưởng huấn luyện — tự huấn luyện, thấy thiên kiến</a:t>
+            </a:r>
+          </a:p>
+          <a:p>
+            <a:pPr>
+              <a:spcBef>
+                <a:spcPts val="1000"/>
+              </a:spcBef>
+              <a:defRPr sz="1800">
+                <a:solidFill>
+                  <a:srgbClr val="333333"/>
+                </a:solidFill>
+              </a:defRPr>
+            </a:pPr>
+            <a:r>
+              <a:t>  5. Bản đồ năng lực — theo dõi tiến bộ 12 khối UNESCO</a:t>
             </a:r>
           </a:p>
         </p:txBody>
@@ -4185,114 +4041,54 @@
           </a:p>
         </p:txBody>
       </p:sp>
-      <p:sp>
-        <p:nvSpPr>
-          <p:cNvPr id="3" name="Oval 2"/>
-          <p:cNvSpPr/>
+      <p:pic>
+        <p:nvPicPr>
+          <p:cNvPr id="3" name="Picture 2" descr="logo_dhsp_hue.png"/>
+          <p:cNvPicPr>
+            <a:picLocks noChangeAspect="1"/>
+          </p:cNvPicPr>
           <p:nvPr/>
-        </p:nvSpPr>
+        </p:nvPicPr>
+        <p:blipFill>
+          <a:blip r:embed="rId2"/>
+          <a:stretch>
+            <a:fillRect/>
+          </a:stretch>
+        </p:blipFill>
         <p:spPr>
           <a:xfrm>
             <a:off x="274320" y="137160"/>
             <a:ext cx="457200" cy="457200"/>
           </a:xfrm>
-          <a:prstGeom prst="ellipse">
+          <a:prstGeom prst="rect">
             <a:avLst/>
           </a:prstGeom>
-          <a:solidFill>
-            <a:srgbClr val="F0F0F0"/>
-          </a:solidFill>
-          <a:ln w="25400">
-            <a:solidFill>
-              <a:srgbClr val="C8C8C8"/>
-            </a:solidFill>
-          </a:ln>
-        </p:spPr>
-        <p:style>
-          <a:lnRef idx="1">
-            <a:schemeClr val="accent1"/>
-          </a:lnRef>
-          <a:fillRef idx="3">
-            <a:schemeClr val="accent1"/>
-          </a:fillRef>
-          <a:effectRef idx="2">
-            <a:schemeClr val="accent1"/>
-          </a:effectRef>
-          <a:fontRef idx="minor">
-            <a:schemeClr val="lt1"/>
-          </a:fontRef>
-        </p:style>
-        <p:txBody>
-          <a:bodyPr rtlCol="0" anchor="ctr" wrap="square"/>
-          <a:lstStyle/>
-          <a:p>
-            <a:pPr algn="ctr">
-              <a:defRPr sz="1000" b="1">
-                <a:solidFill>
-                  <a:srgbClr val="C8C8C8"/>
-                </a:solidFill>
-              </a:defRPr>
-            </a:pPr>
-            <a:r>
-              <a:t>ĐHSP</a:t>
-            </a:r>
-          </a:p>
-        </p:txBody>
-      </p:sp>
-      <p:sp>
-        <p:nvSpPr>
-          <p:cNvPr id="4" name="Oval 3"/>
-          <p:cNvSpPr/>
+        </p:spPr>
+      </p:pic>
+      <p:pic>
+        <p:nvPicPr>
+          <p:cNvPr id="4" name="Picture 3" descr="logo_thpt_thuan_hoa.jpg"/>
+          <p:cNvPicPr>
+            <a:picLocks noChangeAspect="1"/>
+          </p:cNvPicPr>
           <p:nvPr/>
-        </p:nvSpPr>
-        <p:spPr>
-          <a:xfrm>
-            <a:off x="822960" y="137160"/>
+        </p:nvPicPr>
+        <p:blipFill>
+          <a:blip r:embed="rId3"/>
+          <a:stretch>
+            <a:fillRect/>
+          </a:stretch>
+        </p:blipFill>
+        <p:spPr>
+          <a:xfrm>
+            <a:off x="868680" y="137160"/>
             <a:ext cx="457200" cy="457200"/>
           </a:xfrm>
-          <a:prstGeom prst="ellipse">
+          <a:prstGeom prst="rect">
             <a:avLst/>
           </a:prstGeom>
-          <a:solidFill>
-            <a:srgbClr val="F0F0F0"/>
-          </a:solidFill>
-          <a:ln w="25400">
-            <a:solidFill>
-              <a:srgbClr val="C8C8C8"/>
-            </a:solidFill>
-          </a:ln>
-        </p:spPr>
-        <p:style>
-          <a:lnRef idx="1">
-            <a:schemeClr val="accent1"/>
-          </a:lnRef>
-          <a:fillRef idx="3">
-            <a:schemeClr val="accent1"/>
-          </a:fillRef>
-          <a:effectRef idx="2">
-            <a:schemeClr val="accent1"/>
-          </a:effectRef>
-          <a:fontRef idx="minor">
-            <a:schemeClr val="lt1"/>
-          </a:fontRef>
-        </p:style>
-        <p:txBody>
-          <a:bodyPr rtlCol="0" anchor="ctr" wrap="square"/>
-          <a:lstStyle/>
-          <a:p>
-            <a:pPr algn="ctr">
-              <a:defRPr sz="1000" b="1">
-                <a:solidFill>
-                  <a:srgbClr val="C8C8C8"/>
-                </a:solidFill>
-              </a:defRPr>
-            </a:pPr>
-            <a:r>
-              <a:t>THPT</a:t>
-            </a:r>
-          </a:p>
-        </p:txBody>
-      </p:sp>
+        </p:spPr>
+      </p:pic>
       <p:sp>
         <p:nvSpPr>
           <p:cNvPr id="5" name="TextBox 4"/>
@@ -4301,7 +4097,7 @@
         </p:nvSpPr>
         <p:spPr>
           <a:xfrm>
-            <a:off x="1463040" y="137160"/>
+            <a:off x="2011680" y="137160"/>
             <a:ext cx="9144000" cy="457200"/>
           </a:xfrm>
           <a:prstGeom prst="rect">
@@ -4316,7 +4112,7 @@
           <a:lstStyle/>
           <a:p>
             <a:pPr>
-              <a:defRPr sz="1800" b="1">
+              <a:defRPr sz="1600" b="1">
                 <a:solidFill>
                   <a:srgbClr val="FFFFFF"/>
                 </a:solidFill>
@@ -4336,8 +4132,8 @@
         </p:nvSpPr>
         <p:spPr>
           <a:xfrm>
-            <a:off x="457200" y="1097280"/>
-            <a:ext cx="10972800" cy="731520"/>
+            <a:off x="457200" y="1005840"/>
+            <a:ext cx="10972800" cy="640080"/>
           </a:xfrm>
           <a:prstGeom prst="rect">
             <a:avLst/>
@@ -4351,14 +4147,14 @@
           <a:lstStyle/>
           <a:p>
             <a:pPr>
-              <a:defRPr sz="3600" b="1">
+              <a:defRPr sz="3200" b="1">
                 <a:solidFill>
                   <a:srgbClr val="333333"/>
                 </a:solidFill>
               </a:defRPr>
             </a:pPr>
             <a:r>
-              <a:t>Tích hợp vào chương trình</a:t>
+              <a:t>Tích hợp chương trình Tin học 10</a:t>
             </a:r>
           </a:p>
         </p:txBody>
@@ -4371,8 +4167,8 @@
         </p:nvSpPr>
         <p:spPr>
           <a:xfrm>
-            <a:off x="457200" y="6217920"/>
-            <a:ext cx="10972800" cy="457200"/>
+            <a:off x="457200" y="6309360"/>
+            <a:ext cx="10972800" cy="365760"/>
           </a:xfrm>
           <a:prstGeom prst="rect">
             <a:avLst/>
@@ -4406,8 +4202,8 @@
         </p:nvSpPr>
         <p:spPr>
           <a:xfrm>
-            <a:off x="457200" y="2011680"/>
-            <a:ext cx="5029200" cy="3657600"/>
+            <a:off x="457200" y="1828800"/>
+            <a:ext cx="5029200" cy="4114800"/>
           </a:xfrm>
           <a:prstGeom prst="rect">
             <a:avLst/>
@@ -4421,17 +4217,14 @@
           <a:lstStyle/>
           <a:p>
             <a:pPr>
-              <a:spcAft>
-                <a:spcPts val="1200"/>
-              </a:spcAft>
-              <a:defRPr sz="2800" b="1">
+              <a:defRPr sz="2200" b="1">
                 <a:solidFill>
                   <a:srgbClr val="0078D7"/>
                 </a:solidFill>
               </a:defRPr>
             </a:pPr>
             <a:r>
-              <a:t>Chủ đề A-B-D</a:t>
+              <a:t>28 bài SGK → 22/22 YCCĐ</a:t>
             </a:r>
           </a:p>
           <a:p>
@@ -4439,14 +4232,14 @@
               <a:spcBef>
                 <a:spcPts val="600"/>
               </a:spcBef>
-              <a:defRPr sz="1800">
+              <a:defRPr sz="1600">
                 <a:solidFill>
                   <a:srgbClr val="333333"/>
                 </a:solidFill>
               </a:defRPr>
             </a:pPr>
             <a:r>
-              <a:t>A: Máy tính và xã hội tri thức</a:t>
+              <a:t>• Chủ đề A: Máy tính &amp; xã hội tri thức</a:t>
             </a:r>
           </a:p>
           <a:p>
@@ -4454,14 +4247,14 @@
               <a:spcBef>
                 <a:spcPts val="600"/>
               </a:spcBef>
-              <a:defRPr sz="1800">
+              <a:defRPr sz="1600">
                 <a:solidFill>
                   <a:srgbClr val="333333"/>
                 </a:solidFill>
               </a:defRPr>
             </a:pPr>
             <a:r>
-              <a:t>B: Mạng máy tính và Internet</a:t>
+              <a:t>• Chủ đề B: Mạng máy tính &amp; Internet</a:t>
             </a:r>
           </a:p>
           <a:p>
@@ -4469,14 +4262,14 @@
               <a:spcBef>
                 <a:spcPts val="600"/>
               </a:spcBef>
-              <a:defRPr sz="1800">
+              <a:defRPr sz="1600">
                 <a:solidFill>
                   <a:srgbClr val="333333"/>
                 </a:solidFill>
               </a:defRPr>
             </a:pPr>
             <a:r>
-              <a:t>D: Đạo đức, pháp luật số</a:t>
+              <a:t>• Chủ đề D: Đạo đức, pháp luật số</a:t>
             </a:r>
           </a:p>
           <a:p>
@@ -4484,26 +4277,29 @@
               <a:spcBef>
                 <a:spcPts val="600"/>
               </a:spcBef>
-              <a:defRPr sz="1800">
+              <a:defRPr sz="1600">
                 <a:solidFill>
                   <a:srgbClr val="333333"/>
                 </a:solidFill>
               </a:defRPr>
             </a:pPr>
+            <a:r>
+              <a:t>• Chủ đề E: Thiết kế đồ họa (ICT)</a:t>
+            </a:r>
           </a:p>
           <a:p>
             <a:pPr>
               <a:spcBef>
                 <a:spcPts val="600"/>
               </a:spcBef>
-              <a:defRPr sz="1800">
+              <a:defRPr sz="1600">
                 <a:solidFill>
                   <a:srgbClr val="333333"/>
                 </a:solidFill>
               </a:defRPr>
             </a:pPr>
             <a:r>
-              <a:t>Hoạt động chính:</a:t>
+              <a:t>• Chủ đề F: Giải quyết vấn đề</a:t>
             </a:r>
           </a:p>
           <a:p>
@@ -4511,14 +4307,49 @@
               <a:spcBef>
                 <a:spcPts val="600"/>
               </a:spcBef>
-              <a:defRPr sz="1800">
+              <a:defRPr sz="1600">
                 <a:solidFill>
                   <a:srgbClr val="333333"/>
                 </a:solidFill>
               </a:defRPr>
             </a:pPr>
             <a:r>
-              <a:t>• Kịch bản 9 cảnh</a:t>
+              <a:t>• Chủ đề G: Hướng nghiệp (CS)</a:t>
+            </a:r>
+          </a:p>
+        </p:txBody>
+      </p:sp>
+      <p:sp>
+        <p:nvSpPr>
+          <p:cNvPr id="9" name="TextBox 8"/>
+          <p:cNvSpPr txBox="1"/>
+          <p:nvPr/>
+        </p:nvSpPr>
+        <p:spPr>
+          <a:xfrm>
+            <a:off x="5943600" y="1828800"/>
+            <a:ext cx="5029200" cy="4114800"/>
+          </a:xfrm>
+          <a:prstGeom prst="rect">
+            <a:avLst/>
+          </a:prstGeom>
+          <a:noFill/>
+        </p:spPr>
+        <p:txBody>
+          <a:bodyPr wrap="square">
+            <a:spAutoFit/>
+          </a:bodyPr>
+          <a:lstStyle/>
+          <a:p>
+            <a:pPr>
+              <a:defRPr sz="2200" b="1">
+                <a:solidFill>
+                  <a:srgbClr val="0078D7"/>
+                </a:solidFill>
+              </a:defRPr>
+            </a:pPr>
+            <a:r>
+              <a:t>Căn cứ pháp lý</a:t>
             </a:r>
           </a:p>
           <a:p>
@@ -4526,14 +4357,14 @@
               <a:spcBef>
                 <a:spcPts val="600"/>
               </a:spcBef>
-              <a:defRPr sz="1800">
+              <a:defRPr sz="1600">
                 <a:solidFill>
                   <a:srgbClr val="333333"/>
                 </a:solidFill>
               </a:defRPr>
             </a:pPr>
             <a:r>
-              <a:t>• Đấu trường bắt lỗi AI</a:t>
+              <a:t>• QĐ 2422/QĐ-BGDĐT (18/8/2026)</a:t>
             </a:r>
           </a:p>
           <a:p>
@@ -4541,52 +4372,14 @@
               <a:spcBef>
                 <a:spcPts val="600"/>
               </a:spcBef>
-              <a:defRPr sz="1800">
+              <a:defRPr sz="1600">
                 <a:solidFill>
                   <a:srgbClr val="333333"/>
                 </a:solidFill>
               </a:defRPr>
             </a:pPr>
             <a:r>
-              <a:t>• Tình huống &amp; trách nhiệm</a:t>
-            </a:r>
-          </a:p>
-        </p:txBody>
-      </p:sp>
-      <p:sp>
-        <p:nvSpPr>
-          <p:cNvPr id="9" name="TextBox 8"/>
-          <p:cNvSpPr txBox="1"/>
-          <p:nvPr/>
-        </p:nvSpPr>
-        <p:spPr>
-          <a:xfrm>
-            <a:off x="5943600" y="2011680"/>
-            <a:ext cx="5029200" cy="3657600"/>
-          </a:xfrm>
-          <a:prstGeom prst="rect">
-            <a:avLst/>
-          </a:prstGeom>
-          <a:noFill/>
-        </p:spPr>
-        <p:txBody>
-          <a:bodyPr wrap="square">
-            <a:spAutoFit/>
-          </a:bodyPr>
-          <a:lstStyle/>
-          <a:p>
-            <a:pPr>
-              <a:spcAft>
-                <a:spcPts val="1200"/>
-              </a:spcAft>
-              <a:defRPr sz="2800" b="1">
-                <a:solidFill>
-                  <a:srgbClr val="0078D7"/>
-                </a:solidFill>
-              </a:defRPr>
-            </a:pPr>
-            <a:r>
-              <a:t>Chủ đề E-F-G</a:t>
+              <a:t>• Khung nội dung giáo dục AI</a:t>
             </a:r>
           </a:p>
           <a:p>
@@ -4594,14 +4387,14 @@
               <a:spcBef>
                 <a:spcPts val="600"/>
               </a:spcBef>
-              <a:defRPr sz="1800">
+              <a:defRPr sz="1600">
                 <a:solidFill>
                   <a:srgbClr val="333333"/>
                 </a:solidFill>
               </a:defRPr>
             </a:pPr>
             <a:r>
-              <a:t>E: Thiết kế đồ họa (ICT)</a:t>
+              <a:t>• 4 mạch × 12 khối UNESCO</a:t>
             </a:r>
           </a:p>
           <a:p>
@@ -4609,14 +4402,14 @@
               <a:spcBef>
                 <a:spcPts val="600"/>
               </a:spcBef>
-              <a:defRPr sz="1800">
+              <a:defRPr sz="1600">
                 <a:solidFill>
                   <a:srgbClr val="333333"/>
                 </a:solidFill>
               </a:defRPr>
             </a:pPr>
             <a:r>
-              <a:t>F: Giải quyết vấn đề với máy tính</a:t>
+              <a:t>• CV 5588/BGDĐT-GDTrH</a:t>
             </a:r>
           </a:p>
           <a:p>
@@ -4624,86 +4417,14 @@
               <a:spcBef>
                 <a:spcPts val="600"/>
               </a:spcBef>
-              <a:defRPr sz="1800">
+              <a:defRPr sz="1600">
                 <a:solidFill>
                   <a:srgbClr val="333333"/>
                 </a:solidFill>
               </a:defRPr>
             </a:pPr>
             <a:r>
-              <a:t>G: Hướng nghiệp (CS)</a:t>
-            </a:r>
-          </a:p>
-          <a:p>
-            <a:pPr>
-              <a:spcBef>
-                <a:spcPts val="600"/>
-              </a:spcBef>
-              <a:defRPr sz="1800">
-                <a:solidFill>
-                  <a:srgbClr val="333333"/>
-                </a:solidFill>
-              </a:defRPr>
-            </a:pPr>
-          </a:p>
-          <a:p>
-            <a:pPr>
-              <a:spcBef>
-                <a:spcPts val="600"/>
-              </a:spcBef>
-              <a:defRPr sz="1800">
-                <a:solidFill>
-                  <a:srgbClr val="333333"/>
-                </a:solidFill>
-              </a:defRPr>
-            </a:pPr>
-            <a:r>
-              <a:t>Hoạt động chính:</a:t>
-            </a:r>
-          </a:p>
-          <a:p>
-            <a:pPr>
-              <a:spcBef>
-                <a:spcPts val="600"/>
-              </a:spcBef>
-              <a:defRPr sz="1800">
-                <a:solidFill>
-                  <a:srgbClr val="333333"/>
-                </a:solidFill>
-              </a:defRPr>
-            </a:pPr>
-            <a:r>
-              <a:t>• Tầng 1 - Xưởng huấn luyện</a:t>
-            </a:r>
-          </a:p>
-          <a:p>
-            <a:pPr>
-              <a:spcBef>
-                <a:spcPts val="600"/>
-              </a:spcBef>
-              <a:defRPr sz="1800">
-                <a:solidFill>
-                  <a:srgbClr val="333333"/>
-                </a:solidFill>
-              </a:defRPr>
-            </a:pPr>
-            <a:r>
-              <a:t>• Nhà máy AI 7 trạm</a:t>
-            </a:r>
-          </a:p>
-          <a:p>
-            <a:pPr>
-              <a:spcBef>
-                <a:spcPts val="600"/>
-              </a:spcBef>
-              <a:defRPr sz="1800">
-                <a:solidFill>
-                  <a:srgbClr val="333333"/>
-                </a:solidFill>
-              </a:defRPr>
-            </a:pPr>
-            <a:r>
-              <a:t>• Kiến thức Tin học</a:t>
+              <a:t>• Phân phối 12 tiết đề xuất</a:t>
             </a:r>
           </a:p>
         </p:txBody>
@@ -4735,7 +4456,7 @@
         <p:spPr>
           <a:xfrm>
             <a:off x="0" y="0"/>
-            <a:ext cx="12191695" cy="1097280"/>
+            <a:ext cx="12191695" cy="731520"/>
           </a:xfrm>
           <a:prstGeom prst="rect">
             <a:avLst/>
@@ -4769,124 +4490,54 @@
           </a:p>
         </p:txBody>
       </p:sp>
-      <p:sp>
-        <p:nvSpPr>
-          <p:cNvPr id="3" name="Oval 2"/>
-          <p:cNvSpPr/>
+      <p:pic>
+        <p:nvPicPr>
+          <p:cNvPr id="3" name="Picture 2" descr="logo_dhsp_hue.png"/>
+          <p:cNvPicPr>
+            <a:picLocks noChangeAspect="1"/>
+          </p:cNvPicPr>
           <p:nvPr/>
-        </p:nvSpPr>
-        <p:spPr>
-          <a:xfrm>
-            <a:off x="365760" y="182880"/>
-            <a:ext cx="731520" cy="731520"/>
-          </a:xfrm>
-          <a:prstGeom prst="ellipse">
+        </p:nvPicPr>
+        <p:blipFill>
+          <a:blip r:embed="rId2"/>
+          <a:stretch>
+            <a:fillRect/>
+          </a:stretch>
+        </p:blipFill>
+        <p:spPr>
+          <a:xfrm>
+            <a:off x="274320" y="137160"/>
+            <a:ext cx="457200" cy="457200"/>
+          </a:xfrm>
+          <a:prstGeom prst="rect">
             <a:avLst/>
           </a:prstGeom>
-          <a:solidFill>
-            <a:srgbClr val="F0F0F0"/>
-          </a:solidFill>
-          <a:ln w="25400">
-            <a:solidFill>
-              <a:srgbClr val="C8C8C8"/>
-            </a:solidFill>
-          </a:ln>
-        </p:spPr>
-        <p:style>
-          <a:lnRef idx="1">
-            <a:schemeClr val="accent1"/>
-          </a:lnRef>
-          <a:fillRef idx="3">
-            <a:schemeClr val="accent1"/>
-          </a:fillRef>
-          <a:effectRef idx="2">
-            <a:schemeClr val="accent1"/>
-          </a:effectRef>
-          <a:fontRef idx="minor">
-            <a:schemeClr val="lt1"/>
-          </a:fontRef>
-        </p:style>
-        <p:txBody>
-          <a:bodyPr rtlCol="0" anchor="ctr" wrap="square"/>
-          <a:lstStyle/>
-          <a:p>
-            <a:pPr algn="ctr">
-              <a:defRPr sz="1000" b="1">
-                <a:solidFill>
-                  <a:srgbClr val="C8C8C8"/>
-                </a:solidFill>
-              </a:defRPr>
-            </a:pPr>
-            <a:r>
-              <a:t>LOGO</a:t>
-            </a:r>
-          </a:p>
-          <a:p>
-            <a:r>
-              <a:t>ĐHSP</a:t>
-            </a:r>
-          </a:p>
-        </p:txBody>
-      </p:sp>
-      <p:sp>
-        <p:nvSpPr>
-          <p:cNvPr id="4" name="Oval 3"/>
-          <p:cNvSpPr/>
+        </p:spPr>
+      </p:pic>
+      <p:pic>
+        <p:nvPicPr>
+          <p:cNvPr id="4" name="Picture 3" descr="logo_thpt_thuan_hoa.jpg"/>
+          <p:cNvPicPr>
+            <a:picLocks noChangeAspect="1"/>
+          </p:cNvPicPr>
           <p:nvPr/>
-        </p:nvSpPr>
-        <p:spPr>
-          <a:xfrm>
-            <a:off x="1280160" y="182880"/>
-            <a:ext cx="731520" cy="731520"/>
-          </a:xfrm>
-          <a:prstGeom prst="ellipse">
+        </p:nvPicPr>
+        <p:blipFill>
+          <a:blip r:embed="rId3"/>
+          <a:stretch>
+            <a:fillRect/>
+          </a:stretch>
+        </p:blipFill>
+        <p:spPr>
+          <a:xfrm>
+            <a:off x="868680" y="137160"/>
+            <a:ext cx="457200" cy="457200"/>
+          </a:xfrm>
+          <a:prstGeom prst="rect">
             <a:avLst/>
           </a:prstGeom>
-          <a:solidFill>
-            <a:srgbClr val="F0F0F0"/>
-          </a:solidFill>
-          <a:ln w="25400">
-            <a:solidFill>
-              <a:srgbClr val="C8C8C8"/>
-            </a:solidFill>
-          </a:ln>
-        </p:spPr>
-        <p:style>
-          <a:lnRef idx="1">
-            <a:schemeClr val="accent1"/>
-          </a:lnRef>
-          <a:fillRef idx="3">
-            <a:schemeClr val="accent1"/>
-          </a:fillRef>
-          <a:effectRef idx="2">
-            <a:schemeClr val="accent1"/>
-          </a:effectRef>
-          <a:fontRef idx="minor">
-            <a:schemeClr val="lt1"/>
-          </a:fontRef>
-        </p:style>
-        <p:txBody>
-          <a:bodyPr rtlCol="0" anchor="ctr" wrap="square"/>
-          <a:lstStyle/>
-          <a:p>
-            <a:pPr algn="ctr">
-              <a:defRPr sz="1000" b="1">
-                <a:solidFill>
-                  <a:srgbClr val="C8C8C8"/>
-                </a:solidFill>
-              </a:defRPr>
-            </a:pPr>
-            <a:r>
-              <a:t>LOGO</a:t>
-            </a:r>
-          </a:p>
-          <a:p>
-            <a:r>
-              <a:t>THPT</a:t>
-            </a:r>
-          </a:p>
-        </p:txBody>
-      </p:sp>
+        </p:spPr>
+      </p:pic>
       <p:sp>
         <p:nvSpPr>
           <p:cNvPr id="5" name="TextBox 4"/>
@@ -4895,8 +4546,8 @@
         </p:nvSpPr>
         <p:spPr>
           <a:xfrm>
-            <a:off x="1371600" y="2560320"/>
-            <a:ext cx="9144000" cy="1371600"/>
+            <a:off x="2011680" y="137160"/>
+            <a:ext cx="9144000" cy="457200"/>
           </a:xfrm>
           <a:prstGeom prst="rect">
             <a:avLst/>
@@ -4904,20 +4555,20 @@
           <a:noFill/>
         </p:spPr>
         <p:txBody>
-          <a:bodyPr wrap="square">
+          <a:bodyPr wrap="none">
             <a:spAutoFit/>
           </a:bodyPr>
           <a:lstStyle/>
           <a:p>
-            <a:pPr algn="ctr">
-              <a:defRPr sz="5400" b="1">
-                <a:solidFill>
-                  <a:srgbClr val="333333"/>
+            <a:pPr>
+              <a:defRPr sz="1600" b="1">
+                <a:solidFill>
+                  <a:srgbClr val="FFFFFF"/>
                 </a:solidFill>
               </a:defRPr>
             </a:pPr>
             <a:r>
-              <a:t>Cảm ơn</a:t>
+              <a:t>AInatomy — Phòng thực hành AI</a:t>
             </a:r>
           </a:p>
         </p:txBody>
@@ -4930,8 +4581,8 @@
         </p:nvSpPr>
         <p:spPr>
           <a:xfrm>
-            <a:off x="1371600" y="4114800"/>
-            <a:ext cx="9144000" cy="1371600"/>
+            <a:off x="457200" y="1005840"/>
+            <a:ext cx="10972800" cy="640080"/>
           </a:xfrm>
           <a:prstGeom prst="rect">
             <a:avLst/>
@@ -4939,28 +4590,20 @@
           <a:noFill/>
         </p:spPr>
         <p:txBody>
-          <a:bodyPr wrap="square">
+          <a:bodyPr wrap="none">
             <a:spAutoFit/>
           </a:bodyPr>
           <a:lstStyle/>
           <a:p>
-            <a:pPr algn="ctr">
-              <a:defRPr sz="2000">
+            <a:pPr>
+              <a:defRPr sz="3200" b="1">
                 <a:solidFill>
                   <a:srgbClr val="333333"/>
                 </a:solidFill>
               </a:defRPr>
             </a:pPr>
             <a:r>
-              <a:t>Trường THPT Thuận Hoá</a:t>
-            </a:r>
-            <a:br/>
-            <a:r>
-              <a:t>Đại học Sư Phạm, Đại học Huế</a:t>
-            </a:r>
-            <a:br/>
-            <a:r>
-              <a:t>GV: Mai Xuân Văn</a:t>
+              <a:t>Kết quả</a:t>
             </a:r>
           </a:p>
         </p:txBody>
@@ -4973,8 +4616,8 @@
         </p:nvSpPr>
         <p:spPr>
           <a:xfrm>
-            <a:off x="457200" y="5943600"/>
-            <a:ext cx="10972800" cy="731520"/>
+            <a:off x="457200" y="6309360"/>
+            <a:ext cx="10972800" cy="365760"/>
           </a:xfrm>
           <a:prstGeom prst="rect">
             <a:avLst/>
@@ -4988,14 +4631,127 @@
           <a:lstStyle/>
           <a:p>
             <a:pPr algn="ctr">
-              <a:defRPr sz="1400">
+              <a:defRPr sz="1100">
                 <a:solidFill>
                   <a:srgbClr val="C8C8C8"/>
                 </a:solidFill>
               </a:defRPr>
             </a:pPr>
             <a:r>
-              <a:t>AInatomy — Phòng thực hành Trí tuệ nhân tạo</a:t>
+              <a:t>Trường THPT Thuận Hoá — ĐHSP Huế | GV: Mai Xuân Văn</a:t>
+            </a:r>
+          </a:p>
+        </p:txBody>
+      </p:sp>
+      <p:sp>
+        <p:nvSpPr>
+          <p:cNvPr id="8" name="TextBox 7"/>
+          <p:cNvSpPr txBox="1"/>
+          <p:nvPr/>
+        </p:nvSpPr>
+        <p:spPr>
+          <a:xfrm>
+            <a:off x="457200" y="1828800"/>
+            <a:ext cx="10972800" cy="4114800"/>
+          </a:xfrm>
+          <a:prstGeom prst="rect">
+            <a:avLst/>
+          </a:prstGeom>
+          <a:noFill/>
+        </p:spPr>
+        <p:txBody>
+          <a:bodyPr wrap="square">
+            <a:spAutoFit/>
+          </a:bodyPr>
+          <a:lstStyle/>
+          <a:p>
+            <a:pPr>
+              <a:spcBef>
+                <a:spcPts val="1000"/>
+              </a:spcBef>
+              <a:defRPr sz="2200">
+                <a:solidFill>
+                  <a:srgbClr val="333333"/>
+                </a:solidFill>
+              </a:defRPr>
+            </a:pPr>
+            <a:r>
+              <a:t>✓ 97/97 tiêu chí nghiệm thu tự động</a:t>
+            </a:r>
+          </a:p>
+          <a:p>
+            <a:pPr>
+              <a:spcBef>
+                <a:spcPts val="1000"/>
+              </a:spcBef>
+              <a:defRPr sz="2200">
+                <a:solidFill>
+                  <a:srgbClr val="333333"/>
+                </a:solidFill>
+              </a:defRPr>
+            </a:pPr>
+            <a:r>
+              <a:t>✓ 22/22 YCCĐ lớp 10 được phủ</a:t>
+            </a:r>
+          </a:p>
+          <a:p>
+            <a:pPr>
+              <a:spcBef>
+                <a:spcPts val="1000"/>
+              </a:spcBef>
+              <a:defRPr sz="2200">
+                <a:solidFill>
+                  <a:srgbClr val="333333"/>
+                </a:solidFill>
+              </a:defRPr>
+            </a:pPr>
+            <a:r>
+              <a:t>✓ 28 bài SGK Tin học 10 có hỗ trợ</a:t>
+            </a:r>
+          </a:p>
+          <a:p>
+            <a:pPr>
+              <a:spcBef>
+                <a:spcPts val="1000"/>
+              </a:spcBef>
+              <a:defRPr sz="2200">
+                <a:solidFill>
+                  <a:srgbClr val="333333"/>
+                </a:solidFill>
+              </a:defRPr>
+            </a:pPr>
+            <a:r>
+              <a:t>✓ 133 tệp trong manifest, hash khớp 100%</a:t>
+            </a:r>
+          </a:p>
+          <a:p>
+            <a:pPr>
+              <a:spcBef>
+                <a:spcPts val="1000"/>
+              </a:spcBef>
+              <a:defRPr sz="2200">
+                <a:solidFill>
+                  <a:srgbClr val="333333"/>
+                </a:solidFill>
+              </a:defRPr>
+            </a:pPr>
+            <a:r>
+              <a:t>✓ Chạy offline, không cần internet</a:t>
+            </a:r>
+          </a:p>
+          <a:p>
+            <a:pPr>
+              <a:spcBef>
+                <a:spcPts val="1000"/>
+              </a:spcBef>
+              <a:defRPr sz="2200">
+                <a:solidFill>
+                  <a:srgbClr val="333333"/>
+                </a:solidFill>
+              </a:defRPr>
+            </a:pPr>
+            <a:r>
+              <a:t>✓ Dữ liệu lưu cục bộ, ẩn danh</a:t>
             </a:r>
           </a:p>
         </p:txBody>
@@ -5061,114 +4817,54 @@
           </a:p>
         </p:txBody>
       </p:sp>
-      <p:sp>
-        <p:nvSpPr>
-          <p:cNvPr id="3" name="Oval 2"/>
-          <p:cNvSpPr/>
+      <p:pic>
+        <p:nvPicPr>
+          <p:cNvPr id="3" name="Picture 2" descr="logo_dhsp_hue.png"/>
+          <p:cNvPicPr>
+            <a:picLocks noChangeAspect="1"/>
+          </p:cNvPicPr>
           <p:nvPr/>
-        </p:nvSpPr>
+        </p:nvPicPr>
+        <p:blipFill>
+          <a:blip r:embed="rId2"/>
+          <a:stretch>
+            <a:fillRect/>
+          </a:stretch>
+        </p:blipFill>
         <p:spPr>
           <a:xfrm>
             <a:off x="274320" y="137160"/>
             <a:ext cx="457200" cy="457200"/>
           </a:xfrm>
-          <a:prstGeom prst="ellipse">
+          <a:prstGeom prst="rect">
             <a:avLst/>
           </a:prstGeom>
-          <a:solidFill>
-            <a:srgbClr val="F0F0F0"/>
-          </a:solidFill>
-          <a:ln w="25400">
-            <a:solidFill>
-              <a:srgbClr val="C8C8C8"/>
-            </a:solidFill>
-          </a:ln>
-        </p:spPr>
-        <p:style>
-          <a:lnRef idx="1">
-            <a:schemeClr val="accent1"/>
-          </a:lnRef>
-          <a:fillRef idx="3">
-            <a:schemeClr val="accent1"/>
-          </a:fillRef>
-          <a:effectRef idx="2">
-            <a:schemeClr val="accent1"/>
-          </a:effectRef>
-          <a:fontRef idx="minor">
-            <a:schemeClr val="lt1"/>
-          </a:fontRef>
-        </p:style>
-        <p:txBody>
-          <a:bodyPr rtlCol="0" anchor="ctr" wrap="square"/>
-          <a:lstStyle/>
-          <a:p>
-            <a:pPr algn="ctr">
-              <a:defRPr sz="1000" b="1">
-                <a:solidFill>
-                  <a:srgbClr val="C8C8C8"/>
-                </a:solidFill>
-              </a:defRPr>
-            </a:pPr>
-            <a:r>
-              <a:t>ĐHSP</a:t>
-            </a:r>
-          </a:p>
-        </p:txBody>
-      </p:sp>
-      <p:sp>
-        <p:nvSpPr>
-          <p:cNvPr id="4" name="Oval 3"/>
-          <p:cNvSpPr/>
+        </p:spPr>
+      </p:pic>
+      <p:pic>
+        <p:nvPicPr>
+          <p:cNvPr id="4" name="Picture 3" descr="logo_thpt_thuan_hoa.jpg"/>
+          <p:cNvPicPr>
+            <a:picLocks noChangeAspect="1"/>
+          </p:cNvPicPr>
           <p:nvPr/>
-        </p:nvSpPr>
-        <p:spPr>
-          <a:xfrm>
-            <a:off x="822960" y="137160"/>
+        </p:nvPicPr>
+        <p:blipFill>
+          <a:blip r:embed="rId3"/>
+          <a:stretch>
+            <a:fillRect/>
+          </a:stretch>
+        </p:blipFill>
+        <p:spPr>
+          <a:xfrm>
+            <a:off x="868680" y="137160"/>
             <a:ext cx="457200" cy="457200"/>
           </a:xfrm>
-          <a:prstGeom prst="ellipse">
+          <a:prstGeom prst="rect">
             <a:avLst/>
           </a:prstGeom>
-          <a:solidFill>
-            <a:srgbClr val="F0F0F0"/>
-          </a:solidFill>
-          <a:ln w="25400">
-            <a:solidFill>
-              <a:srgbClr val="C8C8C8"/>
-            </a:solidFill>
-          </a:ln>
-        </p:spPr>
-        <p:style>
-          <a:lnRef idx="1">
-            <a:schemeClr val="accent1"/>
-          </a:lnRef>
-          <a:fillRef idx="3">
-            <a:schemeClr val="accent1"/>
-          </a:fillRef>
-          <a:effectRef idx="2">
-            <a:schemeClr val="accent1"/>
-          </a:effectRef>
-          <a:fontRef idx="minor">
-            <a:schemeClr val="lt1"/>
-          </a:fontRef>
-        </p:style>
-        <p:txBody>
-          <a:bodyPr rtlCol="0" anchor="ctr" wrap="square"/>
-          <a:lstStyle/>
-          <a:p>
-            <a:pPr algn="ctr">
-              <a:defRPr sz="1000" b="1">
-                <a:solidFill>
-                  <a:srgbClr val="C8C8C8"/>
-                </a:solidFill>
-              </a:defRPr>
-            </a:pPr>
-            <a:r>
-              <a:t>THPT</a:t>
-            </a:r>
-          </a:p>
-        </p:txBody>
-      </p:sp>
+        </p:spPr>
+      </p:pic>
       <p:sp>
         <p:nvSpPr>
           <p:cNvPr id="5" name="TextBox 4"/>
@@ -5177,7 +4873,7 @@
         </p:nvSpPr>
         <p:spPr>
           <a:xfrm>
-            <a:off x="1463040" y="137160"/>
+            <a:off x="2011680" y="137160"/>
             <a:ext cx="9144000" cy="457200"/>
           </a:xfrm>
           <a:prstGeom prst="rect">
@@ -5192,7 +4888,7 @@
           <a:lstStyle/>
           <a:p>
             <a:pPr>
-              <a:defRPr sz="1800" b="1">
+              <a:defRPr sz="1600" b="1">
                 <a:solidFill>
                   <a:srgbClr val="FFFFFF"/>
                 </a:solidFill>
@@ -5212,8 +4908,8 @@
         </p:nvSpPr>
         <p:spPr>
           <a:xfrm>
-            <a:off x="457200" y="1097280"/>
-            <a:ext cx="10972800" cy="731520"/>
+            <a:off x="457200" y="1005840"/>
+            <a:ext cx="10972800" cy="640080"/>
           </a:xfrm>
           <a:prstGeom prst="rect">
             <a:avLst/>
@@ -5227,14 +4923,14 @@
           <a:lstStyle/>
           <a:p>
             <a:pPr>
-              <a:defRPr sz="3600" b="1">
+              <a:defRPr sz="3200" b="1">
                 <a:solidFill>
                   <a:srgbClr val="333333"/>
                 </a:solidFill>
               </a:defRPr>
             </a:pPr>
             <a:r>
-              <a:t>AInatomy - Phòng thực hành AI</a:t>
+              <a:t>Demo trực tiếp</a:t>
             </a:r>
           </a:p>
         </p:txBody>
@@ -5247,8 +4943,8 @@
         </p:nvSpPr>
         <p:spPr>
           <a:xfrm>
-            <a:off x="457200" y="6217920"/>
-            <a:ext cx="10972800" cy="457200"/>
+            <a:off x="457200" y="6309360"/>
+            <a:ext cx="10972800" cy="365760"/>
           </a:xfrm>
           <a:prstGeom prst="rect">
             <a:avLst/>
@@ -5282,8 +4978,8 @@
         </p:nvSpPr>
         <p:spPr>
           <a:xfrm>
-            <a:off x="457200" y="2011680"/>
-            <a:ext cx="10972800" cy="1371600"/>
+            <a:off x="914400" y="2286000"/>
+            <a:ext cx="10058400" cy="2743200"/>
           </a:xfrm>
           <a:prstGeom prst="rect">
             <a:avLst/>
@@ -5291,23 +4987,20 @@
           <a:noFill/>
         </p:spPr>
         <p:txBody>
-          <a:bodyPr wrap="square">
+          <a:bodyPr wrap="none">
             <a:spAutoFit/>
           </a:bodyPr>
           <a:lstStyle/>
           <a:p>
-            <a:pPr>
-              <a:spcAft>
-                <a:spcPts val="1200"/>
-              </a:spcAft>
-              <a:defRPr sz="2000">
-                <a:solidFill>
-                  <a:srgbClr val="333333"/>
+            <a:pPr algn="ctr">
+              <a:defRPr sz="2800" b="1">
+                <a:solidFill>
+                  <a:srgbClr val="0078D7"/>
                 </a:solidFill>
               </a:defRPr>
             </a:pPr>
             <a:r>
-              <a:t>Hệ thống học về AI thông qua việc bắt lỗi AI, phủ 22/22 YCCĐ lớp 10 theo QĐ 2422/QĐ-BGDĐT</a:t>
+              <a:t>https://mxuanvan02.github.io/ainatomy/</a:t>
             </a:r>
           </a:p>
         </p:txBody>
@@ -5320,8 +5013,8 @@
         </p:nvSpPr>
         <p:spPr>
           <a:xfrm>
-            <a:off x="457200" y="3474720"/>
-            <a:ext cx="10972800" cy="2560320"/>
+            <a:off x="914400" y="3657600"/>
+            <a:ext cx="10058400" cy="1828800"/>
           </a:xfrm>
           <a:prstGeom prst="rect">
             <a:avLst/>
@@ -5329,159 +5022,20 @@
           <a:noFill/>
         </p:spPr>
         <p:txBody>
-          <a:bodyPr wrap="square">
+          <a:bodyPr wrap="none">
             <a:spAutoFit/>
           </a:bodyPr>
           <a:lstStyle/>
-          <a:p/>
-          <a:p>
-            <a:pPr>
-              <a:spcBef>
-                <a:spcPts val="800"/>
-              </a:spcBef>
-              <a:defRPr sz="2000" b="1">
-                <a:solidFill>
-                  <a:srgbClr val="0078D7"/>
+          <a:p>
+            <a:pPr algn="ctr">
+              <a:defRPr sz="1800">
+                <a:solidFill>
+                  <a:srgbClr val="333333"/>
                 </a:solidFill>
               </a:defRPr>
             </a:pPr>
             <a:r>
-              <a:t>1. Kịch bản 9 cảnh</a:t>
-            </a:r>
-          </a:p>
-          <a:p>
-            <a:pPr>
-              <a:spcBef>
-                <a:spcPts val="200"/>
-              </a:spcBef>
-              <a:defRPr sz="1600">
-                <a:solidFill>
-                  <a:srgbClr val="333333"/>
-                </a:solidFill>
-              </a:defRPr>
-            </a:pPr>
-            <a:r>
-              <a:t>   Hành trình của bức ảnh từ đầu vào đến đầu ra</a:t>
-            </a:r>
-          </a:p>
-          <a:p>
-            <a:pPr>
-              <a:spcBef>
-                <a:spcPts val="800"/>
-              </a:spcBef>
-              <a:defRPr sz="2000" b="1">
-                <a:solidFill>
-                  <a:srgbClr val="0078D7"/>
-                </a:solidFill>
-              </a:defRPr>
-            </a:pPr>
-            <a:r>
-              <a:t>2. Đấu trường bắt lỗi AI</a:t>
-            </a:r>
-          </a:p>
-          <a:p>
-            <a:pPr>
-              <a:spcBef>
-                <a:spcPts val="200"/>
-              </a:spcBef>
-              <a:defRPr sz="1600">
-                <a:solidFill>
-                  <a:srgbClr val="333333"/>
-                </a:solidFill>
-              </a:defRPr>
-            </a:pPr>
-            <a:r>
-              <a:t>   12 tình huống, 5 loại lỗi AI</a:t>
-            </a:r>
-          </a:p>
-          <a:p>
-            <a:pPr>
-              <a:spcBef>
-                <a:spcPts val="800"/>
-              </a:spcBef>
-              <a:defRPr sz="2000" b="1">
-                <a:solidFill>
-                  <a:srgbClr val="0078D7"/>
-                </a:solidFill>
-              </a:defRPr>
-            </a:pPr>
-            <a:r>
-              <a:t>3. Nhà máy AI 7 trạm</a:t>
-            </a:r>
-          </a:p>
-          <a:p>
-            <a:pPr>
-              <a:spcBef>
-                <a:spcPts val="200"/>
-              </a:spcBef>
-              <a:defRPr sz="1600">
-                <a:solidFill>
-                  <a:srgbClr val="333333"/>
-                </a:solidFill>
-              </a:defRPr>
-            </a:pPr>
-            <a:r>
-              <a:t>   Từ nhập liệu đến ứng dụng</a:t>
-            </a:r>
-          </a:p>
-          <a:p>
-            <a:pPr>
-              <a:spcBef>
-                <a:spcPts val="800"/>
-              </a:spcBef>
-              <a:defRPr sz="2000" b="1">
-                <a:solidFill>
-                  <a:srgbClr val="0078D7"/>
-                </a:solidFill>
-              </a:defRPr>
-            </a:pPr>
-            <a:r>
-              <a:t>4. Tầng 1 - Xưởng huấn luyện</a:t>
-            </a:r>
-          </a:p>
-          <a:p>
-            <a:pPr>
-              <a:spcBef>
-                <a:spcPts val="200"/>
-              </a:spcBef>
-              <a:defRPr sz="1600">
-                <a:solidFill>
-                  <a:srgbClr val="333333"/>
-                </a:solidFill>
-              </a:defRPr>
-            </a:pPr>
-            <a:r>
-              <a:t>   Tự huấn luyện mô hình, thấy thiên kiến</a:t>
-            </a:r>
-          </a:p>
-          <a:p>
-            <a:pPr>
-              <a:spcBef>
-                <a:spcPts val="800"/>
-              </a:spcBef>
-              <a:defRPr sz="2000" b="1">
-                <a:solidFill>
-                  <a:srgbClr val="0078D7"/>
-                </a:solidFill>
-              </a:defRPr>
-            </a:pPr>
-            <a:r>
-              <a:t>5. Bản đồ năng lực</a:t>
-            </a:r>
-          </a:p>
-          <a:p>
-            <a:pPr>
-              <a:spcBef>
-                <a:spcPts val="200"/>
-              </a:spcBef>
-              <a:defRPr sz="1600">
-                <a:solidFill>
-                  <a:srgbClr val="333333"/>
-                </a:solidFill>
-              </a:defRPr>
-            </a:pPr>
-            <a:r>
-              <a:t>   Theo dõi tiến bộ theo 12 khối UNESCO</a:t>
+              <a:t>Mở trên trình duyệt — không cần cài đặt</a:t>
             </a:r>
           </a:p>
         </p:txBody>
@@ -5513,7 +5067,7 @@
         <p:spPr>
           <a:xfrm>
             <a:off x="0" y="0"/>
-            <a:ext cx="12191695" cy="731520"/>
+            <a:ext cx="12191695" cy="914400"/>
           </a:xfrm>
           <a:prstGeom prst="rect">
             <a:avLst/>
@@ -5547,114 +5101,54 @@
           </a:p>
         </p:txBody>
       </p:sp>
-      <p:sp>
-        <p:nvSpPr>
-          <p:cNvPr id="3" name="Oval 2"/>
-          <p:cNvSpPr/>
+      <p:pic>
+        <p:nvPicPr>
+          <p:cNvPr id="3" name="Picture 2" descr="logo_dhsp_hue.png"/>
+          <p:cNvPicPr>
+            <a:picLocks noChangeAspect="1"/>
+          </p:cNvPicPr>
           <p:nvPr/>
-        </p:nvSpPr>
+        </p:nvPicPr>
+        <p:blipFill>
+          <a:blip r:embed="rId2"/>
+          <a:stretch>
+            <a:fillRect/>
+          </a:stretch>
+        </p:blipFill>
         <p:spPr>
           <a:xfrm>
             <a:off x="274320" y="137160"/>
-            <a:ext cx="457200" cy="457200"/>
-          </a:xfrm>
-          <a:prstGeom prst="ellipse">
+            <a:ext cx="640080" cy="640080"/>
+          </a:xfrm>
+          <a:prstGeom prst="rect">
             <a:avLst/>
           </a:prstGeom>
-          <a:solidFill>
-            <a:srgbClr val="F0F0F0"/>
-          </a:solidFill>
-          <a:ln w="25400">
-            <a:solidFill>
-              <a:srgbClr val="C8C8C8"/>
-            </a:solidFill>
-          </a:ln>
-        </p:spPr>
-        <p:style>
-          <a:lnRef idx="1">
-            <a:schemeClr val="accent1"/>
-          </a:lnRef>
-          <a:fillRef idx="3">
-            <a:schemeClr val="accent1"/>
-          </a:fillRef>
-          <a:effectRef idx="2">
-            <a:schemeClr val="accent1"/>
-          </a:effectRef>
-          <a:fontRef idx="minor">
-            <a:schemeClr val="lt1"/>
-          </a:fontRef>
-        </p:style>
-        <p:txBody>
-          <a:bodyPr rtlCol="0" anchor="ctr" wrap="square"/>
-          <a:lstStyle/>
-          <a:p>
-            <a:pPr algn="ctr">
-              <a:defRPr sz="1000" b="1">
-                <a:solidFill>
-                  <a:srgbClr val="C8C8C8"/>
-                </a:solidFill>
-              </a:defRPr>
-            </a:pPr>
-            <a:r>
-              <a:t>ĐHSP</a:t>
-            </a:r>
-          </a:p>
-        </p:txBody>
-      </p:sp>
-      <p:sp>
-        <p:nvSpPr>
-          <p:cNvPr id="4" name="Oval 3"/>
-          <p:cNvSpPr/>
+        </p:spPr>
+      </p:pic>
+      <p:pic>
+        <p:nvPicPr>
+          <p:cNvPr id="4" name="Picture 3" descr="logo_thpt_thuan_hoa.jpg"/>
+          <p:cNvPicPr>
+            <a:picLocks noChangeAspect="1"/>
+          </p:cNvPicPr>
           <p:nvPr/>
-        </p:nvSpPr>
-        <p:spPr>
-          <a:xfrm>
-            <a:off x="822960" y="137160"/>
-            <a:ext cx="457200" cy="457200"/>
-          </a:xfrm>
-          <a:prstGeom prst="ellipse">
+        </p:nvPicPr>
+        <p:blipFill>
+          <a:blip r:embed="rId3"/>
+          <a:stretch>
+            <a:fillRect/>
+          </a:stretch>
+        </p:blipFill>
+        <p:spPr>
+          <a:xfrm>
+            <a:off x="1051560" y="137160"/>
+            <a:ext cx="640080" cy="640080"/>
+          </a:xfrm>
+          <a:prstGeom prst="rect">
             <a:avLst/>
           </a:prstGeom>
-          <a:solidFill>
-            <a:srgbClr val="F0F0F0"/>
-          </a:solidFill>
-          <a:ln w="25400">
-            <a:solidFill>
-              <a:srgbClr val="C8C8C8"/>
-            </a:solidFill>
-          </a:ln>
-        </p:spPr>
-        <p:style>
-          <a:lnRef idx="1">
-            <a:schemeClr val="accent1"/>
-          </a:lnRef>
-          <a:fillRef idx="3">
-            <a:schemeClr val="accent1"/>
-          </a:fillRef>
-          <a:effectRef idx="2">
-            <a:schemeClr val="accent1"/>
-          </a:effectRef>
-          <a:fontRef idx="minor">
-            <a:schemeClr val="lt1"/>
-          </a:fontRef>
-        </p:style>
-        <p:txBody>
-          <a:bodyPr rtlCol="0" anchor="ctr" wrap="square"/>
-          <a:lstStyle/>
-          <a:p>
-            <a:pPr algn="ctr">
-              <a:defRPr sz="1000" b="1">
-                <a:solidFill>
-                  <a:srgbClr val="C8C8C8"/>
-                </a:solidFill>
-              </a:defRPr>
-            </a:pPr>
-            <a:r>
-              <a:t>THPT</a:t>
-            </a:r>
-          </a:p>
-        </p:txBody>
-      </p:sp>
+        </p:spPr>
+      </p:pic>
       <p:sp>
         <p:nvSpPr>
           <p:cNvPr id="5" name="TextBox 4"/>
@@ -5663,7 +5157,7 @@
         </p:nvSpPr>
         <p:spPr>
           <a:xfrm>
-            <a:off x="1463040" y="137160"/>
+            <a:off x="2011680" y="137160"/>
             <a:ext cx="9144000" cy="457200"/>
           </a:xfrm>
           <a:prstGeom prst="rect">
@@ -5678,7 +5172,7 @@
           <a:lstStyle/>
           <a:p>
             <a:pPr>
-              <a:defRPr sz="1800" b="1">
+              <a:defRPr sz="2000" b="1">
                 <a:solidFill>
                   <a:srgbClr val="FFFFFF"/>
                 </a:solidFill>
@@ -5698,8 +5192,8 @@
         </p:nvSpPr>
         <p:spPr>
           <a:xfrm>
-            <a:off x="457200" y="1097280"/>
-            <a:ext cx="10972800" cy="731520"/>
+            <a:off x="1371600" y="2560320"/>
+            <a:ext cx="9144000" cy="1371600"/>
           </a:xfrm>
           <a:prstGeom prst="rect">
             <a:avLst/>
@@ -5712,15 +5206,15 @@
           </a:bodyPr>
           <a:lstStyle/>
           <a:p>
-            <a:pPr>
-              <a:defRPr sz="3600" b="1">
+            <a:pPr algn="ctr">
+              <a:defRPr sz="5400" b="1">
                 <a:solidFill>
                   <a:srgbClr val="333333"/>
                 </a:solidFill>
               </a:defRPr>
             </a:pPr>
             <a:r>
-              <a:t>Tích hợp chương trình Tin học 10</a:t>
+              <a:t>Cảm ơn</a:t>
             </a:r>
           </a:p>
         </p:txBody>
@@ -5733,8 +5227,8 @@
         </p:nvSpPr>
         <p:spPr>
           <a:xfrm>
-            <a:off x="457200" y="6217920"/>
-            <a:ext cx="10972800" cy="457200"/>
+            <a:off x="1371600" y="4114800"/>
+            <a:ext cx="9144000" cy="1371600"/>
           </a:xfrm>
           <a:prstGeom prst="rect">
             <a:avLst/>
@@ -5748,675 +5242,22 @@
           <a:lstStyle/>
           <a:p>
             <a:pPr algn="ctr">
-              <a:defRPr sz="1100">
-                <a:solidFill>
-                  <a:srgbClr val="C8C8C8"/>
+              <a:defRPr sz="2000">
+                <a:solidFill>
+                  <a:srgbClr val="333333"/>
                 </a:solidFill>
               </a:defRPr>
             </a:pPr>
             <a:r>
-              <a:t>Trường THPT Thuận Hoá — ĐHSP Huế | GV: Mai Xuân Văn</a:t>
-            </a:r>
-          </a:p>
-        </p:txBody>
-      </p:sp>
-      <p:sp>
-        <p:nvSpPr>
-          <p:cNvPr id="8" name="TextBox 7"/>
-          <p:cNvSpPr txBox="1"/>
-          <p:nvPr/>
-        </p:nvSpPr>
-        <p:spPr>
-          <a:xfrm>
-            <a:off x="457200" y="2011680"/>
-            <a:ext cx="10972800" cy="1097280"/>
-          </a:xfrm>
-          <a:prstGeom prst="rect">
-            <a:avLst/>
-          </a:prstGeom>
-          <a:noFill/>
-        </p:spPr>
-        <p:txBody>
-          <a:bodyPr wrap="square">
-            <a:spAutoFit/>
-          </a:bodyPr>
-          <a:lstStyle/>
-          <a:p/>
-          <a:p>
-            <a:pPr>
-              <a:spcBef>
-                <a:spcPts val="800"/>
-              </a:spcBef>
-            </a:pPr>
-            <a:r>
-              <a:rPr sz="2400" b="1">
-                <a:solidFill>
-                  <a:srgbClr val="27AE60"/>
-                </a:solidFill>
-              </a:rPr>
-              <a:t>28 bài </a:t>
-            </a:r>
-            <a:r>
-              <a:rPr sz="2000">
-                <a:solidFill>
-                  <a:srgbClr val="333333"/>
-                </a:solidFill>
-              </a:rPr>
-              <a:t>trong SGK Tin học 10 được hỗ trợ</a:t>
-            </a:r>
-          </a:p>
-          <a:p>
-            <a:pPr>
-              <a:spcBef>
-                <a:spcPts val="800"/>
-              </a:spcBef>
-            </a:pPr>
-            <a:r>
-              <a:rPr sz="2400" b="1">
-                <a:solidFill>
-                  <a:srgbClr val="27AE60"/>
-                </a:solidFill>
-              </a:rPr>
-              <a:t>22/22 YCCĐ </a:t>
-            </a:r>
-            <a:r>
-              <a:rPr sz="2000">
-                <a:solidFill>
-                  <a:srgbClr val="333333"/>
-                </a:solidFill>
-              </a:rPr>
-              <a:t>lớp 10 theo QĐ 2422 đều được phủ</a:t>
-            </a:r>
-          </a:p>
-          <a:p>
-            <a:pPr>
-              <a:spcBef>
-                <a:spcPts val="800"/>
-              </a:spcBef>
-            </a:pPr>
-            <a:r>
-              <a:rPr sz="2400" b="1">
-                <a:solidFill>
-                  <a:srgbClr val="27AE60"/>
-                </a:solidFill>
-              </a:rPr>
-              <a:t>6 chủ đề </a:t>
-            </a:r>
-            <a:r>
-              <a:rPr sz="2000">
-                <a:solidFill>
-                  <a:srgbClr val="333333"/>
-                </a:solidFill>
-              </a:rPr>
-              <a:t>A-F trong chương trình</a:t>
-            </a:r>
-          </a:p>
-        </p:txBody>
-      </p:sp>
-      <p:sp>
-        <p:nvSpPr>
-          <p:cNvPr id="9" name="TextBox 8"/>
-          <p:cNvSpPr txBox="1"/>
-          <p:nvPr/>
-        </p:nvSpPr>
-        <p:spPr>
-          <a:xfrm>
-            <a:off x="457200" y="3474720"/>
-            <a:ext cx="10972800" cy="2560320"/>
-          </a:xfrm>
-          <a:prstGeom prst="rect">
-            <a:avLst/>
-          </a:prstGeom>
-          <a:noFill/>
-        </p:spPr>
-        <p:txBody>
-          <a:bodyPr wrap="square">
-            <a:spAutoFit/>
-          </a:bodyPr>
-          <a:lstStyle/>
-          <a:p>
-            <a:pPr>
-              <a:spcAft>
-                <a:spcPts val="800"/>
-              </a:spcAft>
-              <a:defRPr sz="2200" b="1">
-                <a:solidFill>
-                  <a:srgbClr val="0078D7"/>
-                </a:solidFill>
-              </a:defRPr>
-            </a:pPr>
-            <a:r>
-              <a:t>Ví dụ: Chủ đề A - Máy tính và xã hội tri thức</a:t>
-            </a:r>
-          </a:p>
-          <a:p>
-            <a:pPr>
-              <a:spcBef>
-                <a:spcPts val="600"/>
-              </a:spcBef>
-              <a:defRPr sz="1600">
-                <a:solidFill>
-                  <a:srgbClr val="333333"/>
-                </a:solidFill>
-              </a:defRPr>
-            </a:pPr>
-            <a:r>
-              <a:t>• Bài 1: Dữ liệu, thông tin → Kịch bản 9 cảnh + Trạm 0 (15-20 phút)</a:t>
-            </a:r>
-          </a:p>
-          <a:p>
-            <a:pPr>
-              <a:spcBef>
-                <a:spcPts val="600"/>
-              </a:spcBef>
-              <a:defRPr sz="1600">
-                <a:solidFill>
-                  <a:srgbClr val="333333"/>
-                </a:solidFill>
-              </a:defRPr>
-            </a:pPr>
-            <a:r>
-              <a:t>• Bài 2: Sự ưu việt của máy tính → Đấu trường bắt lỗi AI (20-25 phút)</a:t>
-            </a:r>
-          </a:p>
-          <a:p>
-            <a:pPr>
-              <a:spcBef>
-                <a:spcPts val="600"/>
-              </a:spcBef>
-              <a:defRPr sz="1600">
-                <a:solidFill>
-                  <a:srgbClr val="333333"/>
-                </a:solidFill>
-              </a:defRPr>
-            </a:pPr>
-            <a:r>
-              <a:t>• Bài 3: Thực hành thiết bị số → Tình huống + Kiến thức (10 phút)</a:t>
-            </a:r>
-          </a:p>
-          <a:p>
-            <a:pPr>
-              <a:spcBef>
-                <a:spcPts val="600"/>
-              </a:spcBef>
-              <a:defRPr sz="1600">
-                <a:solidFill>
-                  <a:srgbClr val="333333"/>
-                </a:solidFill>
-              </a:defRPr>
-            </a:pPr>
-            <a:r>
-              <a:t>• Bài 4: Tin học trong kinh tế, xã hội → Nhà máy AI Trạm 0, 5 (15 phút)</a:t>
-            </a:r>
-          </a:p>
-        </p:txBody>
-      </p:sp>
-    </p:spTree>
-  </p:cSld>
-  <p:clrMapOvr>
-    <a:masterClrMapping/>
-  </p:clrMapOvr>
-</p:sld>
-</file>
-
-<file path=ppt/slides/slide8.xml><?xml version="1.0" encoding="utf-8"?>
-<p:sld xmlns:a="http://schemas.openxmlformats.org/drawingml/2006/main" xmlns:p="http://schemas.openxmlformats.org/presentationml/2006/main" xmlns:r="http://schemas.openxmlformats.org/officeDocument/2006/relationships">
-  <p:cSld>
-    <p:spTree>
-      <p:nvGrpSpPr>
-        <p:cNvPr id="1" name=""/>
-        <p:cNvGrpSpPr/>
-        <p:nvPr/>
-      </p:nvGrpSpPr>
-      <p:grpSpPr/>
-      <p:sp>
-        <p:nvSpPr>
-          <p:cNvPr id="2" name="Rectangle 1"/>
-          <p:cNvSpPr/>
-          <p:nvPr/>
-        </p:nvSpPr>
-        <p:spPr>
-          <a:xfrm>
-            <a:off x="0" y="0"/>
-            <a:ext cx="12191695" cy="731520"/>
-          </a:xfrm>
-          <a:prstGeom prst="rect">
-            <a:avLst/>
-          </a:prstGeom>
-          <a:solidFill>
-            <a:srgbClr val="0078D7"/>
-          </a:solidFill>
-          <a:ln>
-            <a:noFill/>
-          </a:ln>
-        </p:spPr>
-        <p:style>
-          <a:lnRef idx="1">
-            <a:schemeClr val="accent1"/>
-          </a:lnRef>
-          <a:fillRef idx="3">
-            <a:schemeClr val="accent1"/>
-          </a:fillRef>
-          <a:effectRef idx="2">
-            <a:schemeClr val="accent1"/>
-          </a:effectRef>
-          <a:fontRef idx="minor">
-            <a:schemeClr val="lt1"/>
-          </a:fontRef>
-        </p:style>
-        <p:txBody>
-          <a:bodyPr rtlCol="0" anchor="ctr"/>
-          <a:lstStyle/>
-          <a:p>
-            <a:pPr algn="ctr"/>
-          </a:p>
-        </p:txBody>
-      </p:sp>
-      <p:sp>
-        <p:nvSpPr>
-          <p:cNvPr id="3" name="Oval 2"/>
-          <p:cNvSpPr/>
-          <p:nvPr/>
-        </p:nvSpPr>
-        <p:spPr>
-          <a:xfrm>
-            <a:off x="274320" y="137160"/>
-            <a:ext cx="457200" cy="457200"/>
-          </a:xfrm>
-          <a:prstGeom prst="ellipse">
-            <a:avLst/>
-          </a:prstGeom>
-          <a:solidFill>
-            <a:srgbClr val="F0F0F0"/>
-          </a:solidFill>
-          <a:ln w="25400">
-            <a:solidFill>
-              <a:srgbClr val="C8C8C8"/>
-            </a:solidFill>
-          </a:ln>
-        </p:spPr>
-        <p:style>
-          <a:lnRef idx="1">
-            <a:schemeClr val="accent1"/>
-          </a:lnRef>
-          <a:fillRef idx="3">
-            <a:schemeClr val="accent1"/>
-          </a:fillRef>
-          <a:effectRef idx="2">
-            <a:schemeClr val="accent1"/>
-          </a:effectRef>
-          <a:fontRef idx="minor">
-            <a:schemeClr val="lt1"/>
-          </a:fontRef>
-        </p:style>
-        <p:txBody>
-          <a:bodyPr rtlCol="0" anchor="ctr" wrap="square"/>
-          <a:lstStyle/>
-          <a:p>
-            <a:pPr algn="ctr">
-              <a:defRPr sz="1000" b="1">
-                <a:solidFill>
-                  <a:srgbClr val="C8C8C8"/>
-                </a:solidFill>
-              </a:defRPr>
-            </a:pPr>
-            <a:r>
-              <a:t>ĐHSP</a:t>
-            </a:r>
-          </a:p>
-        </p:txBody>
-      </p:sp>
-      <p:sp>
-        <p:nvSpPr>
-          <p:cNvPr id="4" name="Oval 3"/>
-          <p:cNvSpPr/>
-          <p:nvPr/>
-        </p:nvSpPr>
-        <p:spPr>
-          <a:xfrm>
-            <a:off x="822960" y="137160"/>
-            <a:ext cx="457200" cy="457200"/>
-          </a:xfrm>
-          <a:prstGeom prst="ellipse">
-            <a:avLst/>
-          </a:prstGeom>
-          <a:solidFill>
-            <a:srgbClr val="F0F0F0"/>
-          </a:solidFill>
-          <a:ln w="25400">
-            <a:solidFill>
-              <a:srgbClr val="C8C8C8"/>
-            </a:solidFill>
-          </a:ln>
-        </p:spPr>
-        <p:style>
-          <a:lnRef idx="1">
-            <a:schemeClr val="accent1"/>
-          </a:lnRef>
-          <a:fillRef idx="3">
-            <a:schemeClr val="accent1"/>
-          </a:fillRef>
-          <a:effectRef idx="2">
-            <a:schemeClr val="accent1"/>
-          </a:effectRef>
-          <a:fontRef idx="minor">
-            <a:schemeClr val="lt1"/>
-          </a:fontRef>
-        </p:style>
-        <p:txBody>
-          <a:bodyPr rtlCol="0" anchor="ctr" wrap="square"/>
-          <a:lstStyle/>
-          <a:p>
-            <a:pPr algn="ctr">
-              <a:defRPr sz="1000" b="1">
-                <a:solidFill>
-                  <a:srgbClr val="C8C8C8"/>
-                </a:solidFill>
-              </a:defRPr>
-            </a:pPr>
-            <a:r>
-              <a:t>THPT</a:t>
-            </a:r>
-          </a:p>
-        </p:txBody>
-      </p:sp>
-      <p:sp>
-        <p:nvSpPr>
-          <p:cNvPr id="5" name="TextBox 4"/>
-          <p:cNvSpPr txBox="1"/>
-          <p:nvPr/>
-        </p:nvSpPr>
-        <p:spPr>
-          <a:xfrm>
-            <a:off x="1463040" y="137160"/>
-            <a:ext cx="9144000" cy="457200"/>
-          </a:xfrm>
-          <a:prstGeom prst="rect">
-            <a:avLst/>
-          </a:prstGeom>
-          <a:noFill/>
-        </p:spPr>
-        <p:txBody>
-          <a:bodyPr wrap="none">
-            <a:spAutoFit/>
-          </a:bodyPr>
-          <a:lstStyle/>
-          <a:p>
-            <a:pPr>
-              <a:defRPr sz="1800" b="1">
-                <a:solidFill>
-                  <a:srgbClr val="FFFFFF"/>
-                </a:solidFill>
-              </a:defRPr>
-            </a:pPr>
-            <a:r>
-              <a:t>AInatomy — Phòng thực hành AI</a:t>
-            </a:r>
-          </a:p>
-        </p:txBody>
-      </p:sp>
-      <p:sp>
-        <p:nvSpPr>
-          <p:cNvPr id="6" name="TextBox 5"/>
-          <p:cNvSpPr txBox="1"/>
-          <p:nvPr/>
-        </p:nvSpPr>
-        <p:spPr>
-          <a:xfrm>
-            <a:off x="457200" y="1097280"/>
-            <a:ext cx="10972800" cy="731520"/>
-          </a:xfrm>
-          <a:prstGeom prst="rect">
-            <a:avLst/>
-          </a:prstGeom>
-          <a:noFill/>
-        </p:spPr>
-        <p:txBody>
-          <a:bodyPr wrap="none">
-            <a:spAutoFit/>
-          </a:bodyPr>
-          <a:lstStyle/>
-          <a:p>
-            <a:pPr>
-              <a:defRPr sz="3600" b="1">
-                <a:solidFill>
-                  <a:srgbClr val="333333"/>
-                </a:solidFill>
-              </a:defRPr>
-            </a:pPr>
-            <a:r>
-              <a:t>Hướng dẫn sử dụng</a:t>
-            </a:r>
-          </a:p>
-        </p:txBody>
-      </p:sp>
-      <p:sp>
-        <p:nvSpPr>
-          <p:cNvPr id="7" name="TextBox 6"/>
-          <p:cNvSpPr txBox="1"/>
-          <p:nvPr/>
-        </p:nvSpPr>
-        <p:spPr>
-          <a:xfrm>
-            <a:off x="457200" y="6217920"/>
-            <a:ext cx="10972800" cy="457200"/>
-          </a:xfrm>
-          <a:prstGeom prst="rect">
-            <a:avLst/>
-          </a:prstGeom>
-          <a:noFill/>
-        </p:spPr>
-        <p:txBody>
-          <a:bodyPr wrap="none">
-            <a:spAutoFit/>
-          </a:bodyPr>
-          <a:lstStyle/>
-          <a:p>
-            <a:pPr algn="ctr">
-              <a:defRPr sz="1100">
-                <a:solidFill>
-                  <a:srgbClr val="C8C8C8"/>
-                </a:solidFill>
-              </a:defRPr>
-            </a:pPr>
-            <a:r>
-              <a:t>Trường THPT Thuận Hoá — ĐHSP Huế | GV: Mai Xuân Văn</a:t>
-            </a:r>
-          </a:p>
-        </p:txBody>
-      </p:sp>
-      <p:sp>
-        <p:nvSpPr>
-          <p:cNvPr id="8" name="TextBox 7"/>
-          <p:cNvSpPr txBox="1"/>
-          <p:nvPr/>
-        </p:nvSpPr>
-        <p:spPr>
-          <a:xfrm>
-            <a:off x="457200" y="2011680"/>
-            <a:ext cx="5029200" cy="3840480"/>
-          </a:xfrm>
-          <a:prstGeom prst="rect">
-            <a:avLst/>
-          </a:prstGeom>
-          <a:noFill/>
-        </p:spPr>
-        <p:txBody>
-          <a:bodyPr wrap="square">
-            <a:spAutoFit/>
-          </a:bodyPr>
-          <a:lstStyle/>
-          <a:p>
-            <a:pPr>
-              <a:spcAft>
-                <a:spcPts val="1000"/>
-              </a:spcAft>
-              <a:defRPr sz="2400" b="1">
-                <a:solidFill>
-                  <a:srgbClr val="0078D7"/>
-                </a:solidFill>
-              </a:defRPr>
-            </a:pPr>
-            <a:r>
-              <a:t>3 cách chạy</a:t>
-            </a:r>
-          </a:p>
-          <a:p>
-            <a:pPr>
-              <a:spcBef>
-                <a:spcPts val="800"/>
-              </a:spcBef>
-              <a:defRPr sz="1600">
-                <a:solidFill>
-                  <a:srgbClr val="333333"/>
-                </a:solidFill>
-              </a:defRPr>
-            </a:pPr>
-            <a:r>
-              <a:t>• USB: Chép thư mục, mở index.html</a:t>
-            </a:r>
-          </a:p>
-          <a:p>
-            <a:pPr>
-              <a:spcBef>
-                <a:spcPts val="800"/>
-              </a:spcBef>
-              <a:defRPr sz="1600">
-                <a:solidFill>
-                  <a:srgbClr val="333333"/>
-                </a:solidFill>
-              </a:defRPr>
-            </a:pPr>
-            <a:r>
-              <a:t>• Máy chủ lớp: Chia sẻ qua mạng LAN</a:t>
-            </a:r>
-          </a:p>
-          <a:p>
-            <a:pPr>
-              <a:spcBef>
-                <a:spcPts val="800"/>
-              </a:spcBef>
-              <a:defRPr sz="1600">
-                <a:solidFill>
-                  <a:srgbClr val="333333"/>
-                </a:solidFill>
-              </a:defRPr>
-            </a:pPr>
-            <a:r>
-              <a:t>• Máy cá nhân: Mở trực tiếp từ thư mục</a:t>
-            </a:r>
-          </a:p>
-        </p:txBody>
-      </p:sp>
-      <p:sp>
-        <p:nvSpPr>
-          <p:cNvPr id="9" name="TextBox 8"/>
-          <p:cNvSpPr txBox="1"/>
-          <p:nvPr/>
-        </p:nvSpPr>
-        <p:spPr>
-          <a:xfrm>
-            <a:off x="5943600" y="2011680"/>
-            <a:ext cx="5029200" cy="3840480"/>
-          </a:xfrm>
-          <a:prstGeom prst="rect">
-            <a:avLst/>
-          </a:prstGeom>
-          <a:noFill/>
-        </p:spPr>
-        <p:txBody>
-          <a:bodyPr wrap="square">
-            <a:spAutoFit/>
-          </a:bodyPr>
-          <a:lstStyle/>
-          <a:p>
-            <a:pPr>
-              <a:spcAft>
-                <a:spcPts val="1000"/>
-              </a:spcAft>
-              <a:defRPr sz="2400" b="1">
-                <a:solidFill>
-                  <a:srgbClr val="0078D7"/>
-                </a:solidFill>
-              </a:defRPr>
-            </a:pPr>
-            <a:r>
-              <a:t>Yêu cầu</a:t>
-            </a:r>
-          </a:p>
-          <a:p>
-            <a:pPr>
-              <a:spcBef>
-                <a:spcPts val="800"/>
-              </a:spcBef>
-              <a:defRPr sz="1600">
-                <a:solidFill>
-                  <a:srgbClr val="333333"/>
-                </a:solidFill>
-              </a:defRPr>
-            </a:pPr>
-            <a:r>
-              <a:t>✓ Không cần Internet</a:t>
-            </a:r>
-          </a:p>
-          <a:p>
-            <a:pPr>
-              <a:spcBef>
-                <a:spcPts val="800"/>
-              </a:spcBef>
-              <a:defRPr sz="1600">
-                <a:solidFill>
-                  <a:srgbClr val="333333"/>
-                </a:solidFill>
-              </a:defRPr>
-            </a:pPr>
-            <a:r>
-              <a:t>✓ Không cần tài khoản</a:t>
-            </a:r>
-          </a:p>
-          <a:p>
-            <a:pPr>
-              <a:spcBef>
-                <a:spcPts val="800"/>
-              </a:spcBef>
-              <a:defRPr sz="1600">
-                <a:solidFill>
-                  <a:srgbClr val="333333"/>
-                </a:solidFill>
-              </a:defRPr>
-            </a:pPr>
-            <a:r>
-              <a:t>✓ Trình duyệt bất kỳ</a:t>
-            </a:r>
-          </a:p>
-          <a:p>
-            <a:pPr>
-              <a:spcBef>
-                <a:spcPts val="800"/>
-              </a:spcBef>
-              <a:defRPr sz="1600">
-                <a:solidFill>
-                  <a:srgbClr val="333333"/>
-                </a:solidFill>
-              </a:defRPr>
-            </a:pPr>
-            <a:r>
-              <a:t>✓ Máy cấu hình yếu vẫn chạy</a:t>
-            </a:r>
-          </a:p>
-          <a:p>
-            <a:pPr>
-              <a:spcBef>
-                <a:spcPts val="800"/>
-              </a:spcBef>
-              <a:defRPr sz="1600">
-                <a:solidFill>
-                  <a:srgbClr val="333333"/>
-                </a:solidFill>
-              </a:defRPr>
-            </a:pPr>
-            <a:r>
-              <a:t>✓ Dữ liệu lưu cục bộ</a:t>
+              <a:t>Trường THPT Thuận Hoá</a:t>
+            </a:r>
+            <a:br/>
+            <a:r>
+              <a:t>Đại học Sư Phạm, Đại học Huế</a:t>
+            </a:r>
+            <a:br/>
+            <a:r>
+              <a:t>GV: Mai Xuân Văn</a:t>
             </a:r>
           </a:p>
         </p:txBody>

</xml_diff>

<commit_message>
Hoàn thiện báo cáo sản phẩm ứng dụng với ảnh thao tác thật
</commit_message>
<xml_diff>
--- a/template_thuanhoa.pptx
+++ b/template_thuanhoa.pptx
@@ -3429,7 +3429,7 @@
             <a:avLst/>
           </a:prstGeom>
           <a:solidFill>
-            <a:srgbClr val="FFFFFF"/>
+            <a:srgbClr val="F2F7FC"/>
           </a:solidFill>
           <a:ln w="10160">
             <a:solidFill>
@@ -3475,8 +3475,8 @@
         </p:blipFill>
         <p:spPr>
           <a:xfrm>
-            <a:off x="640080" y="1234440"/>
-            <a:ext cx="10927080" cy="4206240"/>
+            <a:off x="3112516" y="1234440"/>
+            <a:ext cx="5982208" cy="4206240"/>
           </a:xfrm>
           <a:prstGeom prst="rect">
             <a:avLst/>
@@ -4451,7 +4451,7 @@
             <a:avLst/>
           </a:prstGeom>
           <a:solidFill>
-            <a:srgbClr val="FFFFFF"/>
+            <a:srgbClr val="F2F7FC"/>
           </a:solidFill>
           <a:ln w="10160">
             <a:solidFill>
@@ -4497,8 +4497,8 @@
         </p:blipFill>
         <p:spPr>
           <a:xfrm>
-            <a:off x="777240" y="3794760"/>
-            <a:ext cx="3749039" cy="1828800"/>
+            <a:off x="1351279" y="3794760"/>
+            <a:ext cx="2600960" cy="1828800"/>
           </a:xfrm>
           <a:prstGeom prst="rect">
             <a:avLst/>
@@ -4520,7 +4520,7 @@
             <a:avLst/>
           </a:prstGeom>
           <a:solidFill>
-            <a:srgbClr val="FFFFFF"/>
+            <a:srgbClr val="F2F7FC"/>
           </a:solidFill>
           <a:ln w="10160">
             <a:solidFill>
@@ -4566,8 +4566,8 @@
         </p:blipFill>
         <p:spPr>
           <a:xfrm>
-            <a:off x="4800600" y="3794760"/>
-            <a:ext cx="2743200" cy="1828800"/>
+            <a:off x="5749412" y="3794760"/>
+            <a:ext cx="845574" cy="1828800"/>
           </a:xfrm>
           <a:prstGeom prst="rect">
             <a:avLst/>
@@ -4589,7 +4589,7 @@
             <a:avLst/>
           </a:prstGeom>
           <a:solidFill>
-            <a:srgbClr val="FFFFFF"/>
+            <a:srgbClr val="F2F7FC"/>
           </a:solidFill>
           <a:ln w="10160">
             <a:solidFill>
@@ -4635,8 +4635,8 @@
         </p:blipFill>
         <p:spPr>
           <a:xfrm>
-            <a:off x="7818120" y="3794760"/>
-            <a:ext cx="3474720" cy="1828800"/>
+            <a:off x="9132692" y="3794760"/>
+            <a:ext cx="845574" cy="1828800"/>
           </a:xfrm>
           <a:prstGeom prst="rect">
             <a:avLst/>
@@ -6254,7 +6254,7 @@
             <a:avLst/>
           </a:prstGeom>
           <a:solidFill>
-            <a:srgbClr val="FFFFFF"/>
+            <a:srgbClr val="F2F7FC"/>
           </a:solidFill>
           <a:ln w="10160">
             <a:solidFill>
@@ -6300,8 +6300,8 @@
         </p:blipFill>
         <p:spPr>
           <a:xfrm>
-            <a:off x="1051560" y="4709160"/>
-            <a:ext cx="1828800" cy="1325880"/>
+            <a:off x="1659439" y="4709160"/>
+            <a:ext cx="613041" cy="1325880"/>
           </a:xfrm>
           <a:prstGeom prst="rect">
             <a:avLst/>
@@ -6323,7 +6323,7 @@
             <a:avLst/>
           </a:prstGeom>
           <a:solidFill>
-            <a:srgbClr val="FFFFFF"/>
+            <a:srgbClr val="F2F7FC"/>
           </a:solidFill>
           <a:ln w="10160">
             <a:solidFill>
@@ -6369,8 +6369,8 @@
         </p:blipFill>
         <p:spPr>
           <a:xfrm>
-            <a:off x="4526280" y="4709160"/>
-            <a:ext cx="1828800" cy="1325880"/>
+            <a:off x="4526280" y="4729162"/>
+            <a:ext cx="1828800" cy="1285875"/>
           </a:xfrm>
           <a:prstGeom prst="rect">
             <a:avLst/>
@@ -6392,7 +6392,7 @@
             <a:avLst/>
           </a:prstGeom>
           <a:solidFill>
-            <a:srgbClr val="FFFFFF"/>
+            <a:srgbClr val="F2F7FC"/>
           </a:solidFill>
           <a:ln w="10160">
             <a:solidFill>
@@ -6438,8 +6438,8 @@
         </p:blipFill>
         <p:spPr>
           <a:xfrm>
-            <a:off x="8001000" y="4709160"/>
-            <a:ext cx="1828800" cy="1325880"/>
+            <a:off x="8608879" y="4709160"/>
+            <a:ext cx="613041" cy="1325880"/>
           </a:xfrm>
           <a:prstGeom prst="rect">
             <a:avLst/>
@@ -6829,7 +6829,7 @@
             <a:avLst/>
           </a:prstGeom>
           <a:solidFill>
-            <a:srgbClr val="FFFFFF"/>
+            <a:srgbClr val="F2F7FC"/>
           </a:solidFill>
           <a:ln w="10160">
             <a:solidFill>
@@ -6875,8 +6875,8 @@
         </p:blipFill>
         <p:spPr>
           <a:xfrm>
-            <a:off x="640080" y="1828800"/>
-            <a:ext cx="5760720" cy="3566160"/>
+            <a:off x="984503" y="1828800"/>
+            <a:ext cx="5071872" cy="3566160"/>
           </a:xfrm>
           <a:prstGeom prst="rect">
             <a:avLst/>
@@ -8298,7 +8298,7 @@
             <a:avLst/>
           </a:prstGeom>
           <a:solidFill>
-            <a:srgbClr val="FFFFFF"/>
+            <a:srgbClr val="F2F7FC"/>
           </a:solidFill>
           <a:ln w="10160">
             <a:solidFill>
@@ -8344,8 +8344,8 @@
         </p:blipFill>
         <p:spPr>
           <a:xfrm>
-            <a:off x="822960" y="4343400"/>
-            <a:ext cx="1920240" cy="1691640"/>
+            <a:off x="1392001" y="4343400"/>
+            <a:ext cx="782156" cy="1691640"/>
           </a:xfrm>
           <a:prstGeom prst="rect">
             <a:avLst/>
@@ -8367,7 +8367,7 @@
             <a:avLst/>
           </a:prstGeom>
           <a:solidFill>
-            <a:srgbClr val="FFFFFF"/>
+            <a:srgbClr val="F2F7FC"/>
           </a:solidFill>
           <a:ln w="10160">
             <a:solidFill>
@@ -8413,8 +8413,8 @@
         </p:blipFill>
         <p:spPr>
           <a:xfrm>
-            <a:off x="3063240" y="4343400"/>
-            <a:ext cx="3749039" cy="1691640"/>
+            <a:off x="3734816" y="4343400"/>
+            <a:ext cx="2405888" cy="1691640"/>
           </a:xfrm>
           <a:prstGeom prst="rect">
             <a:avLst/>
@@ -8436,7 +8436,7 @@
             <a:avLst/>
           </a:prstGeom>
           <a:solidFill>
-            <a:srgbClr val="FFFFFF"/>
+            <a:srgbClr val="F2F7FC"/>
           </a:solidFill>
           <a:ln w="10160">
             <a:solidFill>
@@ -8482,8 +8482,8 @@
         </p:blipFill>
         <p:spPr>
           <a:xfrm>
-            <a:off x="7315200" y="4343400"/>
-            <a:ext cx="3566160" cy="1691640"/>
+            <a:off x="8707201" y="4343400"/>
+            <a:ext cx="782156" cy="1691640"/>
           </a:xfrm>
           <a:prstGeom prst="rect">
             <a:avLst/>
@@ -9449,7 +9449,7 @@
             <a:avLst/>
           </a:prstGeom>
           <a:solidFill>
-            <a:srgbClr val="FFFFFF"/>
+            <a:srgbClr val="F2F7FC"/>
           </a:solidFill>
           <a:ln w="10160">
             <a:solidFill>
@@ -9495,8 +9495,8 @@
         </p:blipFill>
         <p:spPr>
           <a:xfrm>
-            <a:off x="777240" y="3703320"/>
-            <a:ext cx="2240280" cy="1965960"/>
+            <a:off x="1442883" y="3703320"/>
+            <a:ext cx="908992" cy="1965960"/>
           </a:xfrm>
           <a:prstGeom prst="rect">
             <a:avLst/>
@@ -9518,7 +9518,7 @@
             <a:avLst/>
           </a:prstGeom>
           <a:solidFill>
-            <a:srgbClr val="FFFFFF"/>
+            <a:srgbClr val="F2F7FC"/>
           </a:solidFill>
           <a:ln w="10160">
             <a:solidFill>
@@ -9564,8 +9564,8 @@
         </p:blipFill>
         <p:spPr>
           <a:xfrm>
-            <a:off x="3566160" y="3703320"/>
-            <a:ext cx="2240280" cy="1965960"/>
+            <a:off x="4231803" y="3703320"/>
+            <a:ext cx="908992" cy="1965960"/>
           </a:xfrm>
           <a:prstGeom prst="rect">
             <a:avLst/>
@@ -9587,7 +9587,7 @@
             <a:avLst/>
           </a:prstGeom>
           <a:solidFill>
-            <a:srgbClr val="FFFFFF"/>
+            <a:srgbClr val="F2F7FC"/>
           </a:solidFill>
           <a:ln w="10160">
             <a:solidFill>
@@ -9633,8 +9633,8 @@
         </p:blipFill>
         <p:spPr>
           <a:xfrm>
-            <a:off x="6355079" y="3703320"/>
-            <a:ext cx="2240280" cy="1965960"/>
+            <a:off x="7020723" y="3703320"/>
+            <a:ext cx="908992" cy="1965960"/>
           </a:xfrm>
           <a:prstGeom prst="rect">
             <a:avLst/>
@@ -9656,7 +9656,7 @@
             <a:avLst/>
           </a:prstGeom>
           <a:solidFill>
-            <a:srgbClr val="FFFFFF"/>
+            <a:srgbClr val="F2F7FC"/>
           </a:solidFill>
           <a:ln w="10160">
             <a:solidFill>
@@ -9702,8 +9702,8 @@
         </p:blipFill>
         <p:spPr>
           <a:xfrm>
-            <a:off x="9143999" y="3703320"/>
-            <a:ext cx="2240280" cy="1965960"/>
+            <a:off x="9809643" y="3703320"/>
+            <a:ext cx="908992" cy="1965960"/>
           </a:xfrm>
           <a:prstGeom prst="rect">
             <a:avLst/>
@@ -10165,7 +10165,7 @@
             <a:avLst/>
           </a:prstGeom>
           <a:solidFill>
-            <a:srgbClr val="FFFFFF"/>
+            <a:srgbClr val="F2F7FC"/>
           </a:solidFill>
           <a:ln w="10160">
             <a:solidFill>
@@ -10211,8 +10211,8 @@
         </p:blipFill>
         <p:spPr>
           <a:xfrm>
-            <a:off x="685800" y="1828800"/>
-            <a:ext cx="2331720" cy="3611880"/>
+            <a:off x="1016655" y="1828800"/>
+            <a:ext cx="1670009" cy="3611880"/>
           </a:xfrm>
           <a:prstGeom prst="rect">
             <a:avLst/>
@@ -10270,7 +10270,7 @@
             <a:avLst/>
           </a:prstGeom>
           <a:solidFill>
-            <a:srgbClr val="FFFFFF"/>
+            <a:srgbClr val="F2F7FC"/>
           </a:solidFill>
           <a:ln w="10160">
             <a:solidFill>
@@ -10316,8 +10316,8 @@
         </p:blipFill>
         <p:spPr>
           <a:xfrm>
-            <a:off x="3474720" y="1828800"/>
-            <a:ext cx="2331720" cy="3611880"/>
+            <a:off x="3805575" y="1828800"/>
+            <a:ext cx="1670009" cy="3611880"/>
           </a:xfrm>
           <a:prstGeom prst="rect">
             <a:avLst/>
@@ -10375,7 +10375,7 @@
             <a:avLst/>
           </a:prstGeom>
           <a:solidFill>
-            <a:srgbClr val="FFFFFF"/>
+            <a:srgbClr val="F2F7FC"/>
           </a:solidFill>
           <a:ln w="10160">
             <a:solidFill>
@@ -10421,8 +10421,8 @@
         </p:blipFill>
         <p:spPr>
           <a:xfrm>
-            <a:off x="6263640" y="1828800"/>
-            <a:ext cx="2331720" cy="3611880"/>
+            <a:off x="6594495" y="1828800"/>
+            <a:ext cx="1670009" cy="3611880"/>
           </a:xfrm>
           <a:prstGeom prst="rect">
             <a:avLst/>
@@ -10480,7 +10480,7 @@
             <a:avLst/>
           </a:prstGeom>
           <a:solidFill>
-            <a:srgbClr val="FFFFFF"/>
+            <a:srgbClr val="F2F7FC"/>
           </a:solidFill>
           <a:ln w="10160">
             <a:solidFill>
@@ -10526,8 +10526,8 @@
         </p:blipFill>
         <p:spPr>
           <a:xfrm>
-            <a:off x="9052559" y="1828800"/>
-            <a:ext cx="2331720" cy="3611880"/>
+            <a:off x="9383415" y="1828800"/>
+            <a:ext cx="1670009" cy="3611880"/>
           </a:xfrm>
           <a:prstGeom prst="rect">
             <a:avLst/>
@@ -11025,7 +11025,7 @@
             <a:avLst/>
           </a:prstGeom>
           <a:solidFill>
-            <a:srgbClr val="FFFFFF"/>
+            <a:srgbClr val="F2F7FC"/>
           </a:solidFill>
           <a:ln w="10160">
             <a:solidFill>
@@ -11071,8 +11071,8 @@
         </p:blipFill>
         <p:spPr>
           <a:xfrm>
-            <a:off x="640080" y="1828800"/>
-            <a:ext cx="5760720" cy="3977639"/>
+            <a:off x="691895" y="1828800"/>
+            <a:ext cx="5657088" cy="3977639"/>
           </a:xfrm>
           <a:prstGeom prst="rect">
             <a:avLst/>
@@ -11942,7 +11942,7 @@
             <a:avLst/>
           </a:prstGeom>
           <a:solidFill>
-            <a:srgbClr val="FFFFFF"/>
+            <a:srgbClr val="F2F7FC"/>
           </a:solidFill>
           <a:ln w="10160">
             <a:solidFill>
@@ -11988,8 +11988,8 @@
         </p:blipFill>
         <p:spPr>
           <a:xfrm>
-            <a:off x="594360" y="1828800"/>
-            <a:ext cx="5394960" cy="3840480"/>
+            <a:off x="594360" y="1852374"/>
+            <a:ext cx="5394960" cy="3793331"/>
           </a:xfrm>
           <a:prstGeom prst="rect">
             <a:avLst/>
@@ -12011,7 +12011,7 @@
             <a:avLst/>
           </a:prstGeom>
           <a:solidFill>
-            <a:srgbClr val="FFFFFF"/>
+            <a:srgbClr val="F2F7FC"/>
           </a:solidFill>
           <a:ln w="10160">
             <a:solidFill>
@@ -12057,8 +12057,8 @@
         </p:blipFill>
         <p:spPr>
           <a:xfrm>
-            <a:off x="6217920" y="1828800"/>
-            <a:ext cx="5394960" cy="3840480"/>
+            <a:off x="6217920" y="1852374"/>
+            <a:ext cx="5394960" cy="3793331"/>
           </a:xfrm>
           <a:prstGeom prst="rect">
             <a:avLst/>
@@ -12529,7 +12529,7 @@
             <a:avLst/>
           </a:prstGeom>
           <a:solidFill>
-            <a:srgbClr val="FFFFFF"/>
+            <a:srgbClr val="F2F7FC"/>
           </a:solidFill>
           <a:ln w="10160">
             <a:solidFill>
@@ -12575,8 +12575,8 @@
         </p:blipFill>
         <p:spPr>
           <a:xfrm>
-            <a:off x="640080" y="1828800"/>
-            <a:ext cx="5486400" cy="3429000"/>
+            <a:off x="944879" y="1828800"/>
+            <a:ext cx="4876800" cy="3429000"/>
           </a:xfrm>
           <a:prstGeom prst="rect">
             <a:avLst/>
@@ -13950,7 +13950,7 @@
             <a:avLst/>
           </a:prstGeom>
           <a:solidFill>
-            <a:srgbClr val="FFFFFF"/>
+            <a:srgbClr val="F2F7FC"/>
           </a:solidFill>
           <a:ln w="10160">
             <a:solidFill>
@@ -13996,8 +13996,8 @@
         </p:blipFill>
         <p:spPr>
           <a:xfrm>
-            <a:off x="777240" y="3657600"/>
-            <a:ext cx="3291840" cy="2057400"/>
+            <a:off x="960119" y="3657600"/>
+            <a:ext cx="2926080" cy="2057400"/>
           </a:xfrm>
           <a:prstGeom prst="rect">
             <a:avLst/>
@@ -14019,7 +14019,7 @@
             <a:avLst/>
           </a:prstGeom>
           <a:solidFill>
-            <a:srgbClr val="FFFFFF"/>
+            <a:srgbClr val="F2F7FC"/>
           </a:solidFill>
           <a:ln w="10160">
             <a:solidFill>
@@ -14065,8 +14065,8 @@
         </p:blipFill>
         <p:spPr>
           <a:xfrm>
-            <a:off x="4434840" y="3657600"/>
-            <a:ext cx="3291840" cy="2057400"/>
+            <a:off x="4617720" y="3657600"/>
+            <a:ext cx="2926080" cy="2057400"/>
           </a:xfrm>
           <a:prstGeom prst="rect">
             <a:avLst/>
@@ -14088,7 +14088,7 @@
             <a:avLst/>
           </a:prstGeom>
           <a:solidFill>
-            <a:srgbClr val="FFFFFF"/>
+            <a:srgbClr val="F2F7FC"/>
           </a:solidFill>
           <a:ln w="10160">
             <a:solidFill>
@@ -14134,8 +14134,8 @@
         </p:blipFill>
         <p:spPr>
           <a:xfrm>
-            <a:off x="8092440" y="3657600"/>
-            <a:ext cx="3291840" cy="2057400"/>
+            <a:off x="9262724" y="3657600"/>
+            <a:ext cx="951270" cy="2057400"/>
           </a:xfrm>
           <a:prstGeom prst="rect">
             <a:avLst/>
@@ -14525,7 +14525,7 @@
             <a:avLst/>
           </a:prstGeom>
           <a:solidFill>
-            <a:srgbClr val="FFFFFF"/>
+            <a:srgbClr val="F2F7FC"/>
           </a:solidFill>
           <a:ln w="10160">
             <a:solidFill>
@@ -14571,8 +14571,8 @@
         </p:blipFill>
         <p:spPr>
           <a:xfrm>
-            <a:off x="685800" y="1828800"/>
-            <a:ext cx="4023360" cy="3931920"/>
+            <a:off x="1788487" y="1828800"/>
+            <a:ext cx="1817984" cy="3931920"/>
           </a:xfrm>
           <a:prstGeom prst="rect">
             <a:avLst/>

</xml_diff>